<commit_message>
Comply with project specifications: add LGPD and ethics, complete prompts chain, generate docx deliverables and enhance exercise quality
</commit_message>
<xml_diff>
--- a/02_apresentacao/Apresentacao_Aula_IA.pptx
+++ b/02_apresentacao/Apresentacao_Aula_IA.pptx
@@ -4,6 +4,9 @@
   <p:sldMasterIdLst>
     <p:sldMasterId id="2147483648" r:id="rId1"/>
   </p:sldMasterIdLst>
+  <p:notesMasterIdLst>
+    <p:notesMasterId r:id="rId16"/>
+  </p:notesMasterIdLst>
   <p:sldIdLst>
     <p:sldId id="256" r:id="rId2"/>
     <p:sldId id="257" r:id="rId3"/>
@@ -20,9 +23,6 @@
     <p:sldId id="268" r:id="rId14"/>
     <p:sldId id="269" r:id="rId15"/>
   </p:sldIdLst>
-  <p:notesMasterIdLst>
-    <p:notesMasterId r:id="rId16"/>
-  </p:notesMasterIdLst>
   <p:sldSz cx="12192000" cy="6858000"/>
   <p:notesSz cx="6858000" cy="12192000"/>
   <p:defaultTextStyle>
@@ -117,6 +117,11 @@
       </a:defRPr>
     </a:lvl9pPr>
   </p:defaultTextStyle>
+  <p:extLst>
+    <p:ext uri="{EFAFB233-063F-42B5-8137-9DF3F51BA10A}">
+      <p15:sldGuideLst xmlns:p15="http://schemas.microsoft.com/office/powerpoint/2012/main"/>
+    </p:ext>
+  </p:extLst>
 </p:presentation>
 </file>
 
@@ -142,234 +147,10 @@
           <a:chExt cx="0" cy="0"/>
         </a:xfrm>
       </p:grpSpPr>
-      <p:sp>
-        <p:nvSpPr>
-          <p:cNvPr id="2" name="Header Placeholder 1"/>
-          <p:cNvSpPr>
-            <a:spLocks noGrp="1"/>
-          </p:cNvSpPr>
-          <p:nvPr>
-            <p:ph type="hdr" sz="quarter"/>
-          </p:nvPr>
-        </p:nvSpPr>
-        <p:spPr>
-          <a:xfrm>
-            <a:off x="0" y="0"/>
-            <a:ext cx="2971800" cy="458788"/>
-          </a:xfrm>
-          <a:prstGeom prst="rect">
-            <a:avLst/>
-          </a:prstGeom>
-        </p:spPr>
-        <p:txBody>
-          <a:bodyPr vert="horz" lIns="91440" tIns="45720" rIns="91440" bIns="45720" rtlCol="0"/>
-          <a:lstStyle>
-            <a:lvl1pPr algn="l">
-              <a:defRPr sz="1200"/>
-            </a:lvl1pPr>
-          </a:lstStyle>
-          <a:p>
-            <a:endParaRPr lang="en-US"/>
-          </a:p>
-        </p:txBody>
-      </p:sp>
-      <p:sp>
-        <p:nvSpPr>
-          <p:cNvPr id="3" name="Date Placeholder 2"/>
-          <p:cNvSpPr>
-            <a:spLocks noGrp="1"/>
-          </p:cNvSpPr>
-          <p:nvPr>
-            <p:ph type="dt" idx="1"/>
-          </p:nvPr>
-        </p:nvSpPr>
-        <p:spPr>
-          <a:xfrm>
-            <a:off x="3884613" y="0"/>
-            <a:ext cx="2971800" cy="458788"/>
-          </a:xfrm>
-          <a:prstGeom prst="rect">
-            <a:avLst/>
-          </a:prstGeom>
-        </p:spPr>
-        <p:txBody>
-          <a:bodyPr vert="horz" lIns="91440" tIns="45720" rIns="91440" bIns="45720" rtlCol="0"/>
-          <a:lstStyle>
-            <a:lvl1pPr algn="r">
-              <a:defRPr sz="1200"/>
-            </a:lvl1pPr>
-          </a:lstStyle>
-          <a:p>
-            <a:fld id="{5282F153-3F37-0F45-9E97-73ACFA13230C}" type="datetimeFigureOut">
-              <a:rPr lang="en-US"/>
-              <a:t>7/23/19</a:t>
-            </a:fld>
-            <a:endParaRPr lang="en-US"/>
-          </a:p>
-        </p:txBody>
-      </p:sp>
-      <p:sp>
-        <p:nvSpPr>
-          <p:cNvPr id="4" name="Slide Image Placeholder 3"/>
-          <p:cNvSpPr>
-            <a:spLocks noGrp="1" noRot="1" noChangeAspect="1"/>
-          </p:cNvSpPr>
-          <p:nvPr>
-            <p:ph type="sldImg" idx="2"/>
-          </p:nvPr>
-        </p:nvSpPr>
-        <p:spPr>
-          <a:xfrm>
-            <a:off x="685800" y="1143000"/>
-            <a:ext cx="5486400" cy="3086100"/>
-          </a:xfrm>
-          <a:prstGeom prst="rect">
-            <a:avLst/>
-          </a:prstGeom>
-          <a:noFill/>
-          <a:ln w="12700">
-            <a:solidFill>
-              <a:prstClr val="black"/>
-            </a:solidFill>
-          </a:ln>
-        </p:spPr>
-        <p:txBody>
-          <a:bodyPr vert="horz" lIns="91440" tIns="45720" rIns="91440" bIns="45720" rtlCol="0" anchor="ctr"/>
-          <a:lstStyle/>
-          <a:p>
-            <a:endParaRPr lang="en-US"/>
-          </a:p>
-        </p:txBody>
-      </p:sp>
-      <p:sp>
-        <p:nvSpPr>
-          <p:cNvPr id="5" name="Notes Placeholder 4"/>
-          <p:cNvSpPr>
-            <a:spLocks noGrp="1"/>
-          </p:cNvSpPr>
-          <p:nvPr>
-            <p:ph type="body" sz="quarter" idx="3"/>
-          </p:nvPr>
-        </p:nvSpPr>
-        <p:spPr>
-          <a:xfrm>
-            <a:off x="685800" y="4400550"/>
-            <a:ext cx="5486400" cy="3600450"/>
-          </a:xfrm>
-          <a:prstGeom prst="rect">
-            <a:avLst/>
-          </a:prstGeom>
-        </p:spPr>
-        <p:txBody>
-          <a:bodyPr vert="horz" lIns="91440" tIns="45720" rIns="91440" bIns="45720" rtlCol="0"/>
-          <a:lstStyle/>
-          <a:p>
-            <a:pPr lvl="0"/>
-            <a:r>
-              <a:rPr lang="en-US"/>
-              <a:t>Click to edit Master text styles</a:t>
-            </a:r>
-          </a:p>
-          <a:p>
-            <a:pPr lvl="1"/>
-            <a:r>
-              <a:rPr lang="en-US"/>
-              <a:t>Second level</a:t>
-            </a:r>
-          </a:p>
-          <a:p>
-            <a:pPr lvl="2"/>
-            <a:r>
-              <a:rPr lang="en-US"/>
-              <a:t>Third level</a:t>
-            </a:r>
-          </a:p>
-          <a:p>
-            <a:pPr lvl="3"/>
-            <a:r>
-              <a:rPr lang="en-US"/>
-              <a:t>Fourth level</a:t>
-            </a:r>
-          </a:p>
-          <a:p>
-            <a:pPr lvl="4"/>
-            <a:r>
-              <a:rPr lang="en-US"/>
-              <a:t>Fifth level</a:t>
-            </a:r>
-          </a:p>
-        </p:txBody>
-      </p:sp>
-      <p:sp>
-        <p:nvSpPr>
-          <p:cNvPr id="6" name="Footer Placeholder 5"/>
-          <p:cNvSpPr>
-            <a:spLocks noGrp="1"/>
-          </p:cNvSpPr>
-          <p:nvPr>
-            <p:ph type="ftr" sz="quarter" idx="4"/>
-          </p:nvPr>
-        </p:nvSpPr>
-        <p:spPr>
-          <a:xfrm>
-            <a:off x="0" y="8685213"/>
-            <a:ext cx="2971800" cy="458787"/>
-          </a:xfrm>
-          <a:prstGeom prst="rect">
-            <a:avLst/>
-          </a:prstGeom>
-        </p:spPr>
-        <p:txBody>
-          <a:bodyPr vert="horz" lIns="91440" tIns="45720" rIns="91440" bIns="45720" rtlCol="0" anchor="b"/>
-          <a:lstStyle>
-            <a:lvl1pPr algn="l">
-              <a:defRPr sz="1200"/>
-            </a:lvl1pPr>
-          </a:lstStyle>
-          <a:p>
-            <a:endParaRPr lang="en-US"/>
-          </a:p>
-        </p:txBody>
-      </p:sp>
-      <p:sp>
-        <p:nvSpPr>
-          <p:cNvPr id="7" name="Slide Number Placeholder 6"/>
-          <p:cNvSpPr>
-            <a:spLocks noGrp="1"/>
-          </p:cNvSpPr>
-          <p:nvPr>
-            <p:ph type="sldNum" sz="quarter" idx="5"/>
-          </p:nvPr>
-        </p:nvSpPr>
-        <p:spPr>
-          <a:xfrm>
-            <a:off x="3884613" y="8685213"/>
-            <a:ext cx="2971800" cy="458787"/>
-          </a:xfrm>
-          <a:prstGeom prst="rect">
-            <a:avLst/>
-          </a:prstGeom>
-        </p:spPr>
-        <p:txBody>
-          <a:bodyPr vert="horz" lIns="91440" tIns="45720" rIns="91440" bIns="45720" rtlCol="0" anchor="b"/>
-          <a:lstStyle>
-            <a:lvl1pPr algn="r">
-              <a:defRPr sz="1200"/>
-            </a:lvl1pPr>
-          </a:lstStyle>
-          <a:p>
-            <a:fld id="{CE5E9CC1-C706-0F49-92D6-E571CC5EEA8F}" type="slidenum">
-              <a:rPr lang="en-US"/>
-              <a:t>‹#›</a:t>
-            </a:fld>
-            <a:endParaRPr lang="en-US"/>
-          </a:p>
-        </p:txBody>
-      </p:sp>
     </p:spTree>
     <p:extLst>
       <p:ext uri="{BB962C8B-B14F-4D97-AF65-F5344CB8AC3E}">
-        <p14:creationId xmlns:p14="http://schemas.microsoft.com/office/powerpoint/2010/main" val="1024086991"/>
+        <p14:creationId xmlns:p14="http://schemas.microsoft.com/office/powerpoint/2010/main" val="1673730796"/>
       </p:ext>
     </p:extLst>
   </p:cSld>
@@ -513,10 +294,6 @@
           <a:bodyPr/>
           <a:lstStyle/>
           <a:p>
-            <a:r>
-              <a:rPr lang="en-US" dirty="0"/>
-              <a:t/>
-            </a:r>
             <a:endParaRPr lang="en-US" dirty="0"/>
           </a:p>
         </p:txBody>
@@ -601,10 +378,6 @@
           <a:bodyPr/>
           <a:lstStyle/>
           <a:p>
-            <a:r>
-              <a:rPr lang="en-US" dirty="0"/>
-              <a:t/>
-            </a:r>
             <a:endParaRPr lang="en-US" dirty="0"/>
           </a:p>
         </p:txBody>
@@ -689,10 +462,6 @@
           <a:bodyPr/>
           <a:lstStyle/>
           <a:p>
-            <a:r>
-              <a:rPr lang="en-US" dirty="0"/>
-              <a:t/>
-            </a:r>
             <a:endParaRPr lang="en-US" dirty="0"/>
           </a:p>
         </p:txBody>
@@ -777,10 +546,6 @@
           <a:bodyPr/>
           <a:lstStyle/>
           <a:p>
-            <a:r>
-              <a:rPr lang="en-US" dirty="0"/>
-              <a:t/>
-            </a:r>
             <a:endParaRPr lang="en-US" dirty="0"/>
           </a:p>
         </p:txBody>
@@ -865,10 +630,6 @@
           <a:bodyPr/>
           <a:lstStyle/>
           <a:p>
-            <a:r>
-              <a:rPr lang="en-US" dirty="0"/>
-              <a:t/>
-            </a:r>
             <a:endParaRPr lang="en-US" dirty="0"/>
           </a:p>
         </p:txBody>
@@ -953,10 +714,6 @@
           <a:bodyPr/>
           <a:lstStyle/>
           <a:p>
-            <a:r>
-              <a:rPr lang="en-US" dirty="0"/>
-              <a:t/>
-            </a:r>
             <a:endParaRPr lang="en-US" dirty="0"/>
           </a:p>
         </p:txBody>
@@ -1041,10 +798,6 @@
           <a:bodyPr/>
           <a:lstStyle/>
           <a:p>
-            <a:r>
-              <a:rPr lang="en-US" dirty="0"/>
-              <a:t/>
-            </a:r>
             <a:endParaRPr lang="en-US" dirty="0"/>
           </a:p>
         </p:txBody>
@@ -1129,10 +882,6 @@
           <a:bodyPr/>
           <a:lstStyle/>
           <a:p>
-            <a:r>
-              <a:rPr lang="en-US" dirty="0"/>
-              <a:t/>
-            </a:r>
             <a:endParaRPr lang="en-US" dirty="0"/>
           </a:p>
         </p:txBody>
@@ -1217,10 +966,6 @@
           <a:bodyPr/>
           <a:lstStyle/>
           <a:p>
-            <a:r>
-              <a:rPr lang="en-US" dirty="0"/>
-              <a:t/>
-            </a:r>
             <a:endParaRPr lang="en-US" dirty="0"/>
           </a:p>
         </p:txBody>
@@ -1305,10 +1050,6 @@
           <a:bodyPr/>
           <a:lstStyle/>
           <a:p>
-            <a:r>
-              <a:rPr lang="en-US" dirty="0"/>
-              <a:t/>
-            </a:r>
             <a:endParaRPr lang="en-US" dirty="0"/>
           </a:p>
         </p:txBody>
@@ -1393,10 +1134,6 @@
           <a:bodyPr/>
           <a:lstStyle/>
           <a:p>
-            <a:r>
-              <a:rPr lang="en-US" dirty="0"/>
-              <a:t/>
-            </a:r>
             <a:endParaRPr lang="en-US" dirty="0"/>
           </a:p>
         </p:txBody>
@@ -1481,10 +1218,6 @@
           <a:bodyPr/>
           <a:lstStyle/>
           <a:p>
-            <a:r>
-              <a:rPr lang="en-US" dirty="0"/>
-              <a:t/>
-            </a:r>
             <a:endParaRPr lang="en-US" dirty="0"/>
           </a:p>
         </p:txBody>
@@ -1569,10 +1302,6 @@
           <a:bodyPr/>
           <a:lstStyle/>
           <a:p>
-            <a:r>
-              <a:rPr lang="en-US" dirty="0"/>
-              <a:t/>
-            </a:r>
             <a:endParaRPr lang="en-US" dirty="0"/>
           </a:p>
         </p:txBody>
@@ -1657,10 +1386,6 @@
           <a:bodyPr/>
           <a:lstStyle/>
           <a:p>
-            <a:r>
-              <a:rPr lang="en-US" dirty="0"/>
-              <a:t/>
-            </a:r>
             <a:endParaRPr lang="en-US" dirty="0"/>
           </a:p>
         </p:txBody>
@@ -1734,6 +1459,11 @@
 <file path=ppt/slideMasters/slideMaster1.xml><?xml version="1.0" encoding="utf-8"?>
 <p:sldMaster xmlns:a="http://schemas.openxmlformats.org/drawingml/2006/main" xmlns:r="http://schemas.openxmlformats.org/officeDocument/2006/relationships" xmlns:p="http://schemas.openxmlformats.org/presentationml/2006/main">
   <p:cSld>
+    <p:bg>
+      <p:bgRef idx="1001">
+        <a:schemeClr val="bg1"/>
+      </p:bgRef>
+    </p:bg>
     <p:spTree>
       <p:nvGrpSpPr>
         <p:cNvPr id="1" name=""/>
@@ -2016,6 +1746,7 @@
         <a:solidFill>
           <a:srgbClr val="0F2C59"/>
         </a:solidFill>
+        <a:effectLst/>
       </p:bgPr>
     </p:bg>
     <p:spTree>
@@ -2073,11 +1804,11 @@
           <a:bodyPr wrap="square" lIns="0" tIns="0" rIns="0" bIns="0" rtlCol="0" anchor="ctr"/>
           <a:lstStyle/>
           <a:p>
-            <a:pPr indent="0" marL="0">
-              <a:buNone/>
-            </a:pPr>
-            <a:r>
-              <a:rPr lang="en-US" sz="1400" spc="300" kern="0" dirty="0">
+            <a:pPr marL="0" indent="0">
+              <a:buNone/>
+            </a:pPr>
+            <a:r>
+              <a:rPr lang="en-US" sz="1400" kern="0" spc="300" dirty="0">
                 <a:solidFill>
                   <a:srgbClr val="E9C46A"/>
                 </a:solidFill>
@@ -2112,7 +1843,7 @@
           <a:bodyPr wrap="square" lIns="0" tIns="0" rIns="0" bIns="0" rtlCol="0" anchor="ctr"/>
           <a:lstStyle/>
           <a:p>
-            <a:pPr indent="0" marL="0">
+            <a:pPr marL="0" indent="0">
               <a:buNone/>
             </a:pPr>
             <a:r>
@@ -2151,7 +1882,7 @@
           <a:bodyPr wrap="square" lIns="0" tIns="0" rIns="0" bIns="0" rtlCol="0" anchor="ctr"/>
           <a:lstStyle/>
           <a:p>
-            <a:pPr indent="0" marL="0">
+            <a:pPr marL="0" indent="0">
               <a:buNone/>
             </a:pPr>
             <a:r>
@@ -2190,7 +1921,7 @@
           <a:bodyPr wrap="square" lIns="0" tIns="0" rIns="0" bIns="0" rtlCol="0" anchor="ctr"/>
           <a:lstStyle/>
           <a:p>
-            <a:pPr indent="0" marL="0">
+            <a:pPr marL="0" indent="0">
               <a:buNone/>
             </a:pPr>
             <a:r>
@@ -2229,7 +1960,7 @@
           <a:bodyPr wrap="square" lIns="0" tIns="0" rIns="0" bIns="0" rtlCol="0" anchor="ctr"/>
           <a:lstStyle/>
           <a:p>
-            <a:pPr indent="0" marL="0">
+            <a:pPr marL="0" indent="0">
               <a:buNone/>
             </a:pPr>
             <a:r>
@@ -2268,7 +1999,7 @@
           <a:bodyPr wrap="square" lIns="0" tIns="0" rIns="0" bIns="0" rtlCol="0" anchor="ctr"/>
           <a:lstStyle/>
           <a:p>
-            <a:pPr indent="0" marL="0">
+            <a:pPr marL="0" indent="0">
               <a:buNone/>
             </a:pPr>
             <a:r>
@@ -2302,6 +2033,7 @@
         <a:solidFill>
           <a:srgbClr val="F7F4EF"/>
         </a:solidFill>
+        <a:effectLst/>
       </p:bgPr>
     </p:bg>
     <p:spTree>
@@ -2339,11 +2071,11 @@
           <a:bodyPr wrap="square" lIns="0" tIns="0" rIns="0" bIns="0" rtlCol="0" anchor="ctr"/>
           <a:lstStyle/>
           <a:p>
-            <a:pPr indent="0" marL="0">
-              <a:buNone/>
-            </a:pPr>
-            <a:r>
-              <a:rPr lang="en-US" sz="1100" spc="200" kern="0" dirty="0">
+            <a:pPr marL="0" indent="0">
+              <a:buNone/>
+            </a:pPr>
+            <a:r>
+              <a:rPr lang="en-US" sz="1100" kern="0" spc="200" dirty="0">
                 <a:solidFill>
                   <a:srgbClr val="5C5C6E"/>
                 </a:solidFill>
@@ -2378,7 +2110,7 @@
           <a:bodyPr wrap="square" lIns="0" tIns="0" rIns="0" bIns="0" rtlCol="0" anchor="ctr"/>
           <a:lstStyle/>
           <a:p>
-            <a:pPr indent="0" marL="0">
+            <a:pPr marL="0" indent="0">
               <a:buNone/>
             </a:pPr>
             <a:r>
@@ -2417,7 +2149,7 @@
           <a:bodyPr wrap="square" lIns="0" tIns="0" rIns="0" bIns="0" rtlCol="0" anchor="ctr"/>
           <a:lstStyle/>
           <a:p>
-            <a:pPr algn="r" indent="0" marL="0">
+            <a:pPr marL="0" indent="0" algn="r">
               <a:buNone/>
             </a:pPr>
             <a:r>
@@ -2456,7 +2188,7 @@
           <a:bodyPr wrap="square" lIns="0" tIns="0" rIns="0" bIns="0" rtlCol="0" anchor="ctr"/>
           <a:lstStyle/>
           <a:p>
-            <a:pPr indent="0" marL="0">
+            <a:pPr marL="0" indent="0">
               <a:buNone/>
             </a:pPr>
             <a:r>
@@ -2468,7 +2200,7 @@
                 <a:ea typeface="Arial" pitchFamily="34" charset="-122"/>
                 <a:cs typeface="Arial" pitchFamily="34" charset="-120"/>
               </a:rPr>
-              <a:t>Hora da prática</a:t>
+              <a:t>Comparação guiada · 7 min</a:t>
             </a:r>
             <a:endParaRPr lang="en-US" sz="2800" dirty="0"/>
           </a:p>
@@ -2515,7 +2247,7 @@
           <a:bodyPr wrap="square" lIns="0" tIns="0" rIns="0" bIns="0" rtlCol="0" anchor="ctr"/>
           <a:lstStyle/>
           <a:p>
-            <a:pPr algn="ctr" indent="0" marL="0">
+            <a:pPr marL="0" indent="0" algn="ctr">
               <a:buNone/>
             </a:pPr>
             <a:r>
@@ -2554,7 +2286,7 @@
           <a:bodyPr wrap="square" lIns="0" tIns="0" rIns="0" bIns="0" rtlCol="0" anchor="ctr"/>
           <a:lstStyle/>
           <a:p>
-            <a:pPr indent="0" marL="0">
+            <a:pPr marL="0" indent="0">
               <a:buNone/>
             </a:pPr>
             <a:r>
@@ -2566,7 +2298,7 @@
                 <a:ea typeface="Arial" pitchFamily="34" charset="-122"/>
                 <a:cs typeface="Arial" pitchFamily="34" charset="-120"/>
               </a:rPr>
-              <a:t>Use os casos A, B e C da folha de atividade.</a:t>
+              <a:t>Calcule p nos casos A, B e C da atividade.</a:t>
             </a:r>
             <a:endParaRPr lang="en-US" sz="1800" dirty="0"/>
           </a:p>
@@ -2613,7 +2345,7 @@
           <a:bodyPr wrap="square" lIns="0" tIns="0" rIns="0" bIns="0" rtlCol="0" anchor="ctr"/>
           <a:lstStyle/>
           <a:p>
-            <a:pPr algn="ctr" indent="0" marL="0">
+            <a:pPr marL="0" indent="0" algn="ctr">
               <a:buNone/>
             </a:pPr>
             <a:r>
@@ -2652,7 +2384,7 @@
           <a:bodyPr wrap="square" lIns="0" tIns="0" rIns="0" bIns="0" rtlCol="0" anchor="ctr"/>
           <a:lstStyle/>
           <a:p>
-            <a:pPr indent="0" marL="0">
+            <a:pPr marL="0" indent="0">
               <a:buNone/>
             </a:pPr>
             <a:r>
@@ -2664,7 +2396,7 @@
                 <a:ea typeface="Arial" pitchFamily="34" charset="-122"/>
                 <a:cs typeface="Arial" pitchFamily="34" charset="-120"/>
               </a:rPr>
-              <a:t>Calcule p = m·v e compare os resultados.</a:t>
+              <a:t>Compare os casos: só uma grandeza muda por vez.</a:t>
             </a:r>
             <a:endParaRPr lang="en-US" sz="1800" dirty="0"/>
           </a:p>
@@ -2711,7 +2443,7 @@
           <a:bodyPr wrap="square" lIns="0" tIns="0" rIns="0" bIns="0" rtlCol="0" anchor="ctr"/>
           <a:lstStyle/>
           <a:p>
-            <a:pPr algn="ctr" indent="0" marL="0">
+            <a:pPr marL="0" indent="0" algn="ctr">
               <a:buNone/>
             </a:pPr>
             <a:r>
@@ -2750,7 +2482,7 @@
           <a:bodyPr wrap="square" lIns="0" tIns="0" rIns="0" bIns="0" rtlCol="0" anchor="ctr"/>
           <a:lstStyle/>
           <a:p>
-            <a:pPr indent="0" marL="0">
+            <a:pPr marL="0" indent="0">
               <a:buNone/>
             </a:pPr>
             <a:r>
@@ -2762,7 +2494,7 @@
                 <a:ea typeface="Arial" pitchFamily="34" charset="-122"/>
                 <a:cs typeface="Arial" pitchFamily="34" charset="-120"/>
               </a:rPr>
-              <a:t>p não é força nem determina, sozinho, a distância de frenagem.</a:t>
+              <a:t>p não é força e não determina sozinho a distância de frenagem.</a:t>
             </a:r>
             <a:endParaRPr lang="en-US" sz="1800" dirty="0"/>
           </a:p>
@@ -2809,7 +2541,7 @@
           <a:bodyPr wrap="square" lIns="0" tIns="0" rIns="0" bIns="0" rtlCol="0" anchor="ctr"/>
           <a:lstStyle/>
           <a:p>
-            <a:pPr algn="ctr" indent="0" marL="0">
+            <a:pPr marL="0" indent="0" algn="ctr">
               <a:buNone/>
             </a:pPr>
             <a:r>
@@ -2848,7 +2580,7 @@
           <a:bodyPr wrap="square" lIns="0" tIns="0" rIns="0" bIns="0" rtlCol="0" anchor="ctr"/>
           <a:lstStyle/>
           <a:p>
-            <a:pPr indent="0" marL="0">
+            <a:pPr marL="0" indent="0">
               <a:buNone/>
             </a:pPr>
             <a:r>
@@ -2860,7 +2592,7 @@
                 <a:ea typeface="Arial" pitchFamily="34" charset="-122"/>
                 <a:cs typeface="Arial" pitchFamily="34" charset="-120"/>
               </a:rPr>
-              <a:t>Converse com um colega.</a:t>
+              <a:t>Conversem sobre os resultados.</a:t>
             </a:r>
             <a:endParaRPr lang="en-US" sz="1800" dirty="0"/>
           </a:p>
@@ -2887,7 +2619,7 @@
           <a:bodyPr wrap="square" lIns="0" tIns="0" rIns="0" bIns="0" rtlCol="0" anchor="ctr"/>
           <a:lstStyle/>
           <a:p>
-            <a:pPr indent="0" marL="0">
+            <a:pPr marL="0" indent="0">
               <a:buNone/>
             </a:pPr>
             <a:r>
@@ -2921,6 +2653,7 @@
         <a:solidFill>
           <a:srgbClr val="F7F4EF"/>
         </a:solidFill>
+        <a:effectLst/>
       </p:bgPr>
     </p:bg>
     <p:spTree>
@@ -2958,11 +2691,11 @@
           <a:bodyPr wrap="square" lIns="0" tIns="0" rIns="0" bIns="0" rtlCol="0" anchor="ctr"/>
           <a:lstStyle/>
           <a:p>
-            <a:pPr indent="0" marL="0">
-              <a:buNone/>
-            </a:pPr>
-            <a:r>
-              <a:rPr lang="en-US" sz="1100" spc="200" kern="0" dirty="0">
+            <a:pPr marL="0" indent="0">
+              <a:buNone/>
+            </a:pPr>
+            <a:r>
+              <a:rPr lang="en-US" sz="1100" kern="0" spc="200" dirty="0">
                 <a:solidFill>
                   <a:srgbClr val="5C5C6E"/>
                 </a:solidFill>
@@ -2997,7 +2730,7 @@
           <a:bodyPr wrap="square" lIns="0" tIns="0" rIns="0" bIns="0" rtlCol="0" anchor="ctr"/>
           <a:lstStyle/>
           <a:p>
-            <a:pPr indent="0" marL="0">
+            <a:pPr marL="0" indent="0">
               <a:buNone/>
             </a:pPr>
             <a:r>
@@ -3036,7 +2769,7 @@
           <a:bodyPr wrap="square" lIns="0" tIns="0" rIns="0" bIns="0" rtlCol="0" anchor="ctr"/>
           <a:lstStyle/>
           <a:p>
-            <a:pPr algn="r" indent="0" marL="0">
+            <a:pPr marL="0" indent="0" algn="r">
               <a:buNone/>
             </a:pPr>
             <a:r>
@@ -3075,7 +2808,7 @@
           <a:bodyPr wrap="square" lIns="0" tIns="0" rIns="0" bIns="0" rtlCol="0" anchor="ctr"/>
           <a:lstStyle/>
           <a:p>
-            <a:pPr indent="0" marL="0">
+            <a:pPr marL="0" indent="0">
               <a:buNone/>
             </a:pPr>
             <a:r>
@@ -3114,7 +2847,7 @@
           <a:bodyPr wrap="square" lIns="0" tIns="0" rIns="0" bIns="0" rtlCol="0" anchor="ctr"/>
           <a:lstStyle/>
           <a:p>
-            <a:pPr indent="0" marL="0">
+            <a:pPr marL="0" indent="0">
               <a:buNone/>
             </a:pPr>
             <a:r>
@@ -3126,7 +2859,7 @@
                 <a:ea typeface="Arial" pitchFamily="34" charset="-122"/>
                 <a:cs typeface="Arial" pitchFamily="34" charset="-120"/>
               </a:rPr>
-              <a:t>Agora é sua vez (8 minutos).</a:t>
+              <a:t>8 min: questões selecionadas; demais itens depois.</a:t>
             </a:r>
             <a:endParaRPr lang="en-US" sz="1600" dirty="0"/>
           </a:p>
@@ -3175,11 +2908,11 @@
           <a:bodyPr wrap="square" lIns="0" tIns="0" rIns="0" bIns="0" rtlCol="0" anchor="ctr"/>
           <a:lstStyle/>
           <a:p>
-            <a:pPr indent="0" marL="0">
-              <a:buNone/>
-            </a:pPr>
-            <a:r>
-              <a:rPr lang="en-US" sz="1400" b="1" spc="200" kern="0" dirty="0">
+            <a:pPr marL="0" indent="0">
+              <a:buNone/>
+            </a:pPr>
+            <a:r>
+              <a:rPr lang="en-US" sz="1400" b="1" kern="0" spc="200" dirty="0">
                 <a:solidFill>
                   <a:srgbClr val="E9C46A"/>
                 </a:solidFill>
@@ -3214,7 +2947,7 @@
           <a:bodyPr wrap="square" lIns="0" tIns="0" rIns="0" bIns="0" rtlCol="0" anchor="ctr"/>
           <a:lstStyle/>
           <a:p>
-            <a:pPr indent="0" marL="0">
+            <a:pPr marL="0" indent="0">
               <a:buNone/>
             </a:pPr>
             <a:r>
@@ -3231,7 +2964,7 @@
             <a:endParaRPr lang="en-US" sz="2000" dirty="0"/>
           </a:p>
           <a:p>
-            <a:pPr indent="0" marL="0">
+            <a:pPr marL="0" indent="0">
               <a:buNone/>
             </a:pPr>
             <a:r>
@@ -3248,7 +2981,7 @@
             <a:endParaRPr lang="en-US" sz="2000" dirty="0"/>
           </a:p>
           <a:p>
-            <a:pPr indent="0" marL="0">
+            <a:pPr marL="0" indent="0">
               <a:buNone/>
             </a:pPr>
             <a:r>
@@ -3309,11 +3042,11 @@
           <a:bodyPr wrap="square" lIns="0" tIns="0" rIns="0" bIns="0" rtlCol="0" anchor="ctr"/>
           <a:lstStyle/>
           <a:p>
-            <a:pPr indent="0" marL="0">
-              <a:buNone/>
-            </a:pPr>
-            <a:r>
-              <a:rPr lang="en-US" sz="1400" b="1" spc="200" kern="0" dirty="0">
+            <a:pPr marL="0" indent="0">
+              <a:buNone/>
+            </a:pPr>
+            <a:r>
+              <a:rPr lang="en-US" sz="1400" b="1" kern="0" spc="200" dirty="0">
                 <a:solidFill>
                   <a:srgbClr val="E9C46A"/>
                 </a:solidFill>
@@ -3348,7 +3081,7 @@
           <a:bodyPr wrap="square" lIns="0" tIns="0" rIns="0" bIns="0" rtlCol="0" anchor="ctr"/>
           <a:lstStyle/>
           <a:p>
-            <a:pPr indent="0" marL="0">
+            <a:pPr marL="0" indent="0">
               <a:buNone/>
             </a:pPr>
             <a:r>
@@ -3365,7 +3098,7 @@
             <a:endParaRPr lang="en-US" sz="2000" dirty="0"/>
           </a:p>
           <a:p>
-            <a:pPr indent="0" marL="0">
+            <a:pPr marL="0" indent="0">
               <a:buNone/>
             </a:pPr>
             <a:r>
@@ -3382,7 +3115,7 @@
             <a:endParaRPr lang="en-US" sz="2000" dirty="0"/>
           </a:p>
           <a:p>
-            <a:pPr indent="0" marL="0">
+            <a:pPr marL="0" indent="0">
               <a:buNone/>
             </a:pPr>
             <a:r>
@@ -3416,6 +3149,7 @@
         <a:solidFill>
           <a:srgbClr val="F7F4EF"/>
         </a:solidFill>
+        <a:effectLst/>
       </p:bgPr>
     </p:bg>
     <p:spTree>
@@ -3453,11 +3187,11 @@
           <a:bodyPr wrap="square" lIns="0" tIns="0" rIns="0" bIns="0" rtlCol="0" anchor="ctr"/>
           <a:lstStyle/>
           <a:p>
-            <a:pPr indent="0" marL="0">
-              <a:buNone/>
-            </a:pPr>
-            <a:r>
-              <a:rPr lang="en-US" sz="1100" spc="200" kern="0" dirty="0">
+            <a:pPr marL="0" indent="0">
+              <a:buNone/>
+            </a:pPr>
+            <a:r>
+              <a:rPr lang="en-US" sz="1100" kern="0" spc="200" dirty="0">
                 <a:solidFill>
                   <a:srgbClr val="5C5C6E"/>
                 </a:solidFill>
@@ -3492,7 +3226,7 @@
           <a:bodyPr wrap="square" lIns="0" tIns="0" rIns="0" bIns="0" rtlCol="0" anchor="ctr"/>
           <a:lstStyle/>
           <a:p>
-            <a:pPr indent="0" marL="0">
+            <a:pPr marL="0" indent="0">
               <a:buNone/>
             </a:pPr>
             <a:r>
@@ -3531,7 +3265,7 @@
           <a:bodyPr wrap="square" lIns="0" tIns="0" rIns="0" bIns="0" rtlCol="0" anchor="ctr"/>
           <a:lstStyle/>
           <a:p>
-            <a:pPr algn="r" indent="0" marL="0">
+            <a:pPr marL="0" indent="0" algn="r">
               <a:buNone/>
             </a:pPr>
             <a:r>
@@ -3570,7 +3304,7 @@
           <a:bodyPr wrap="square" lIns="0" tIns="0" rIns="0" bIns="0" rtlCol="0" anchor="ctr"/>
           <a:lstStyle/>
           <a:p>
-            <a:pPr indent="0" marL="0">
+            <a:pPr marL="0" indent="0">
               <a:buNone/>
             </a:pPr>
             <a:r>
@@ -3629,7 +3363,7 @@
           <a:bodyPr wrap="square" lIns="0" tIns="0" rIns="0" bIns="0" rtlCol="0" anchor="ctr"/>
           <a:lstStyle/>
           <a:p>
-            <a:pPr algn="ctr" indent="0" marL="0">
+            <a:pPr marL="0" indent="0" algn="ctr">
               <a:buNone/>
             </a:pPr>
             <a:r>
@@ -3668,7 +3402,7 @@
           <a:bodyPr wrap="square" lIns="0" tIns="0" rIns="0" bIns="0" rtlCol="0" anchor="ctr"/>
           <a:lstStyle/>
           <a:p>
-            <a:pPr indent="0" marL="0">
+            <a:pPr marL="0" indent="0">
               <a:buNone/>
             </a:pPr>
             <a:r>
@@ -3727,7 +3461,7 @@
           <a:bodyPr wrap="square" lIns="0" tIns="0" rIns="0" bIns="0" rtlCol="0" anchor="ctr"/>
           <a:lstStyle/>
           <a:p>
-            <a:pPr algn="ctr" indent="0" marL="0">
+            <a:pPr marL="0" indent="0" algn="ctr">
               <a:buNone/>
             </a:pPr>
             <a:r>
@@ -3766,7 +3500,7 @@
           <a:bodyPr wrap="square" lIns="0" tIns="0" rIns="0" bIns="0" rtlCol="0" anchor="ctr"/>
           <a:lstStyle/>
           <a:p>
-            <a:pPr indent="0" marL="0">
+            <a:pPr marL="0" indent="0">
               <a:buNone/>
             </a:pPr>
             <a:r>
@@ -3825,7 +3559,7 @@
           <a:bodyPr wrap="square" lIns="0" tIns="0" rIns="0" bIns="0" rtlCol="0" anchor="ctr"/>
           <a:lstStyle/>
           <a:p>
-            <a:pPr algn="ctr" indent="0" marL="0">
+            <a:pPr marL="0" indent="0" algn="ctr">
               <a:buNone/>
             </a:pPr>
             <a:r>
@@ -3864,7 +3598,7 @@
           <a:bodyPr wrap="square" lIns="0" tIns="0" rIns="0" bIns="0" rtlCol="0" anchor="ctr"/>
           <a:lstStyle/>
           <a:p>
-            <a:pPr indent="0" marL="0">
+            <a:pPr marL="0" indent="0">
               <a:buNone/>
             </a:pPr>
             <a:r>
@@ -3923,7 +3657,7 @@
           <a:bodyPr wrap="square" lIns="0" tIns="0" rIns="0" bIns="0" rtlCol="0" anchor="ctr"/>
           <a:lstStyle/>
           <a:p>
-            <a:pPr algn="ctr" indent="0" marL="0">
+            <a:pPr marL="0" indent="0" algn="ctr">
               <a:buNone/>
             </a:pPr>
             <a:r>
@@ -3962,7 +3696,7 @@
           <a:bodyPr wrap="square" lIns="0" tIns="0" rIns="0" bIns="0" rtlCol="0" anchor="ctr"/>
           <a:lstStyle/>
           <a:p>
-            <a:pPr indent="0" marL="0">
+            <a:pPr marL="0" indent="0">
               <a:buNone/>
             </a:pPr>
             <a:r>
@@ -3974,7 +3708,7 @@
                 <a:ea typeface="Arial" pitchFamily="34" charset="-122"/>
                 <a:cs typeface="Arial" pitchFamily="34" charset="-120"/>
               </a:rPr>
-              <a:t>Aparece em muitas situações do nosso dia a dia.</a:t>
+              <a:t>Sistema isolado: p total pode se conservar (só a ideia).</a:t>
             </a:r>
             <a:endParaRPr lang="en-US" sz="1900" dirty="0"/>
           </a:p>
@@ -3996,6 +3730,7 @@
         <a:solidFill>
           <a:srgbClr val="F7F4EF"/>
         </a:solidFill>
+        <a:effectLst/>
       </p:bgPr>
     </p:bg>
     <p:spTree>
@@ -4033,11 +3768,11 @@
           <a:bodyPr wrap="square" lIns="0" tIns="0" rIns="0" bIns="0" rtlCol="0" anchor="ctr"/>
           <a:lstStyle/>
           <a:p>
-            <a:pPr indent="0" marL="0">
-              <a:buNone/>
-            </a:pPr>
-            <a:r>
-              <a:rPr lang="en-US" sz="1100" spc="200" kern="0" dirty="0">
+            <a:pPr marL="0" indent="0">
+              <a:buNone/>
+            </a:pPr>
+            <a:r>
+              <a:rPr lang="en-US" sz="1100" kern="0" spc="200" dirty="0">
                 <a:solidFill>
                   <a:srgbClr val="5C5C6E"/>
                 </a:solidFill>
@@ -4072,7 +3807,7 @@
           <a:bodyPr wrap="square" lIns="0" tIns="0" rIns="0" bIns="0" rtlCol="0" anchor="ctr"/>
           <a:lstStyle/>
           <a:p>
-            <a:pPr indent="0" marL="0">
+            <a:pPr marL="0" indent="0">
               <a:buNone/>
             </a:pPr>
             <a:r>
@@ -4111,7 +3846,7 @@
           <a:bodyPr wrap="square" lIns="0" tIns="0" rIns="0" bIns="0" rtlCol="0" anchor="ctr"/>
           <a:lstStyle/>
           <a:p>
-            <a:pPr algn="r" indent="0" marL="0">
+            <a:pPr marL="0" indent="0" algn="r">
               <a:buNone/>
             </a:pPr>
             <a:r>
@@ -4150,7 +3885,7 @@
           <a:bodyPr wrap="square" lIns="0" tIns="0" rIns="0" bIns="0" rtlCol="0" anchor="ctr"/>
           <a:lstStyle/>
           <a:p>
-            <a:pPr indent="0" marL="0">
+            <a:pPr marL="0" indent="0">
               <a:buNone/>
             </a:pPr>
             <a:r>
@@ -4189,7 +3924,7 @@
           <a:bodyPr wrap="square" lIns="0" tIns="0" rIns="0" bIns="0" rtlCol="0" anchor="ctr"/>
           <a:lstStyle/>
           <a:p>
-            <a:pPr indent="0" marL="0">
+            <a:pPr marL="0" indent="0">
               <a:buNone/>
             </a:pPr>
             <a:r>
@@ -4201,12 +3936,12 @@
                 <a:ea typeface="Arial" pitchFamily="34" charset="-122"/>
                 <a:cs typeface="Arial" pitchFamily="34" charset="-120"/>
               </a:rPr>
-              <a:t>Na próxima aula vamos conectar a quantidade de movimento</a:t>
+              <a:t>Hoje: só a ideia de conservação em sistema isolado.</a:t>
             </a:r>
             <a:endParaRPr lang="en-US" sz="1800" dirty="0"/>
           </a:p>
           <a:p>
-            <a:pPr indent="0" marL="0">
+            <a:pPr marL="0" indent="0">
               <a:buNone/>
             </a:pPr>
             <a:r>
@@ -4218,7 +3953,7 @@
                 <a:ea typeface="Arial" pitchFamily="34" charset="-122"/>
                 <a:cs typeface="Arial" pitchFamily="34" charset="-120"/>
               </a:rPr>
-              <a:t>com a ideia de conservação — um dos princípios mais importantes da Física.</a:t>
+              <a:t>Sem equações ou cálculos nesta aula; formalismo na próxima.</a:t>
             </a:r>
             <a:endParaRPr lang="en-US" sz="1800" dirty="0"/>
           </a:p>
@@ -4267,7 +4002,7 @@
           <a:bodyPr wrap="square" lIns="0" tIns="0" rIns="0" bIns="0" rtlCol="0" anchor="ctr"/>
           <a:lstStyle/>
           <a:p>
-            <a:pPr indent="0" marL="0">
+            <a:pPr marL="0" indent="0">
               <a:buNone/>
             </a:pPr>
             <a:r>
@@ -4306,7 +4041,7 @@
           <a:bodyPr wrap="square" lIns="0" tIns="0" rIns="0" bIns="0" rtlCol="0" anchor="ctr"/>
           <a:lstStyle/>
           <a:p>
-            <a:pPr indent="0" marL="0">
+            <a:pPr marL="0" indent="0">
               <a:buNone/>
             </a:pPr>
             <a:r>
@@ -4323,7 +4058,7 @@
             <a:endParaRPr lang="en-US" sz="1700" dirty="0"/>
           </a:p>
           <a:p>
-            <a:pPr indent="0" marL="0">
+            <a:pPr marL="0" indent="0">
               <a:buNone/>
             </a:pPr>
             <a:r>
@@ -4357,6 +4092,7 @@
         <a:solidFill>
           <a:srgbClr val="0F2C59"/>
         </a:solidFill>
+        <a:effectLst/>
       </p:bgPr>
     </p:bg>
     <p:spTree>
@@ -4414,7 +4150,7 @@
           <a:bodyPr wrap="square" lIns="0" tIns="0" rIns="0" bIns="0" rtlCol="0" anchor="ctr"/>
           <a:lstStyle/>
           <a:p>
-            <a:pPr indent="0" marL="0">
+            <a:pPr marL="0" indent="0">
               <a:buNone/>
             </a:pPr>
             <a:r>
@@ -4453,11 +4189,11 @@
           <a:bodyPr wrap="square" lIns="0" tIns="0" rIns="0" bIns="0" rtlCol="0" anchor="ctr"/>
           <a:lstStyle/>
           <a:p>
-            <a:pPr indent="0" marL="0">
-              <a:buNone/>
-            </a:pPr>
-            <a:r>
-              <a:rPr lang="en-US" sz="1400" b="1" spc="200" kern="0" dirty="0">
+            <a:pPr marL="0" indent="0">
+              <a:buNone/>
+            </a:pPr>
+            <a:r>
+              <a:rPr lang="en-US" sz="1400" b="1" kern="0" spc="200" dirty="0">
                 <a:solidFill>
                   <a:srgbClr val="E9C46A"/>
                 </a:solidFill>
@@ -4492,7 +4228,7 @@
           <a:bodyPr wrap="square" lIns="0" tIns="0" rIns="0" bIns="0" rtlCol="0" anchor="ctr"/>
           <a:lstStyle/>
           <a:p>
-            <a:pPr indent="0" marL="0">
+            <a:pPr marL="0" indent="0">
               <a:buNone/>
             </a:pPr>
             <a:r>
@@ -4531,11 +4267,11 @@
           <a:bodyPr wrap="square" lIns="0" tIns="0" rIns="0" bIns="0" rtlCol="0" anchor="ctr"/>
           <a:lstStyle/>
           <a:p>
-            <a:pPr indent="0" marL="0">
-              <a:buNone/>
-            </a:pPr>
-            <a:r>
-              <a:rPr lang="en-US" sz="1400" b="1" spc="200" kern="0" dirty="0">
+            <a:pPr marL="0" indent="0">
+              <a:buNone/>
+            </a:pPr>
+            <a:r>
+              <a:rPr lang="en-US" sz="1400" b="1" kern="0" spc="200" dirty="0">
                 <a:solidFill>
                   <a:srgbClr val="E9C46A"/>
                 </a:solidFill>
@@ -4570,7 +4306,7 @@
           <a:bodyPr wrap="square" lIns="0" tIns="0" rIns="0" bIns="0" rtlCol="0" anchor="ctr"/>
           <a:lstStyle/>
           <a:p>
-            <a:pPr indent="0" marL="0">
+            <a:pPr marL="0" indent="0">
               <a:buNone/>
             </a:pPr>
             <a:r>
@@ -4587,7 +4323,7 @@
             <a:endParaRPr lang="en-US" sz="1700" dirty="0"/>
           </a:p>
           <a:p>
-            <a:pPr indent="0" marL="0">
+            <a:pPr marL="0" indent="0">
               <a:buNone/>
             </a:pPr>
             <a:r>
@@ -4604,7 +4340,7 @@
             <a:endParaRPr lang="en-US" sz="1700" dirty="0"/>
           </a:p>
           <a:p>
-            <a:pPr indent="0" marL="0">
+            <a:pPr marL="0" indent="0">
               <a:buNone/>
             </a:pPr>
             <a:r>
@@ -4643,7 +4379,7 @@
           <a:bodyPr wrap="square" lIns="0" tIns="0" rIns="0" bIns="0" rtlCol="0" anchor="ctr"/>
           <a:lstStyle/>
           <a:p>
-            <a:pPr indent="0" marL="0">
+            <a:pPr marL="0" indent="0">
               <a:buNone/>
             </a:pPr>
             <a:r>
@@ -4655,7 +4391,7 @@
                 <a:ea typeface="Arial" pitchFamily="34" charset="-122"/>
                 <a:cs typeface="Arial" pitchFamily="34" charset="-120"/>
               </a:rPr>
-              <a:t>Referências: BNCC · Halliday/Resnick · Materiais didáticos de Física EM</a:t>
+              <a:t>Referências: BNCC, Ensino Médio — Ciências da Natureza e suas Tecnologias; Halliday, Resnick &amp; Walker, Fundamentos de Física, Mecânica (edição a confirmar).</a:t>
             </a:r>
             <a:endParaRPr lang="en-US" sz="1400" dirty="0"/>
           </a:p>
@@ -4677,6 +4413,7 @@
         <a:solidFill>
           <a:srgbClr val="F7F4EF"/>
         </a:solidFill>
+        <a:effectLst/>
       </p:bgPr>
     </p:bg>
     <p:spTree>
@@ -4714,11 +4451,11 @@
           <a:bodyPr wrap="square" lIns="0" tIns="0" rIns="0" bIns="0" rtlCol="0" anchor="ctr"/>
           <a:lstStyle/>
           <a:p>
-            <a:pPr indent="0" marL="0">
-              <a:buNone/>
-            </a:pPr>
-            <a:r>
-              <a:rPr lang="en-US" sz="1100" spc="200" kern="0" dirty="0">
+            <a:pPr marL="0" indent="0">
+              <a:buNone/>
+            </a:pPr>
+            <a:r>
+              <a:rPr lang="en-US" sz="1100" kern="0" spc="200" dirty="0">
                 <a:solidFill>
                   <a:srgbClr val="5C5C6E"/>
                 </a:solidFill>
@@ -4753,7 +4490,7 @@
           <a:bodyPr wrap="square" lIns="0" tIns="0" rIns="0" bIns="0" rtlCol="0" anchor="ctr"/>
           <a:lstStyle/>
           <a:p>
-            <a:pPr indent="0" marL="0">
+            <a:pPr marL="0" indent="0">
               <a:buNone/>
             </a:pPr>
             <a:r>
@@ -4792,7 +4529,7 @@
           <a:bodyPr wrap="square" lIns="0" tIns="0" rIns="0" bIns="0" rtlCol="0" anchor="ctr"/>
           <a:lstStyle/>
           <a:p>
-            <a:pPr algn="r" indent="0" marL="0">
+            <a:pPr marL="0" indent="0" algn="r">
               <a:buNone/>
             </a:pPr>
             <a:r>
@@ -4831,7 +4568,7 @@
           <a:bodyPr wrap="square" lIns="0" tIns="0" rIns="0" bIns="0" rtlCol="0" anchor="ctr"/>
           <a:lstStyle/>
           <a:p>
-            <a:pPr indent="0" marL="0">
+            <a:pPr marL="0" indent="0">
               <a:buNone/>
             </a:pPr>
             <a:r>
@@ -4914,7 +4651,7 @@
           <a:bodyPr wrap="square" lIns="0" tIns="0" rIns="0" bIns="0" rtlCol="0" anchor="ctr"/>
           <a:lstStyle/>
           <a:p>
-            <a:pPr indent="0" marL="0">
+            <a:pPr marL="0" indent="0">
               <a:buNone/>
             </a:pPr>
             <a:r>
@@ -4953,7 +4690,7 @@
           <a:bodyPr wrap="square" lIns="0" tIns="0" rIns="0" bIns="0" rtlCol="0" anchor="ctr"/>
           <a:lstStyle/>
           <a:p>
-            <a:pPr indent="0" marL="0">
+            <a:pPr marL="0" indent="0">
               <a:buNone/>
             </a:pPr>
             <a:r>
@@ -4965,7 +4702,7 @@
                 <a:ea typeface="Arial" pitchFamily="34" charset="-122"/>
                 <a:cs typeface="Arial" pitchFamily="34" charset="-120"/>
               </a:rPr>
-              <a:t>Definir quantidade de movimento e identificar suas grandezas</a:t>
+              <a:t>Definir quantidade de movimento: p = m·v</a:t>
             </a:r>
             <a:endParaRPr lang="en-US" sz="1800" dirty="0"/>
           </a:p>
@@ -5036,7 +4773,7 @@
           <a:bodyPr wrap="square" lIns="0" tIns="0" rIns="0" bIns="0" rtlCol="0" anchor="ctr"/>
           <a:lstStyle/>
           <a:p>
-            <a:pPr indent="0" marL="0">
+            <a:pPr marL="0" indent="0">
               <a:buNone/>
             </a:pPr>
             <a:r>
@@ -5075,7 +4812,7 @@
           <a:bodyPr wrap="square" lIns="0" tIns="0" rIns="0" bIns="0" rtlCol="0" anchor="ctr"/>
           <a:lstStyle/>
           <a:p>
-            <a:pPr indent="0" marL="0">
+            <a:pPr marL="0" indent="0">
               <a:buNone/>
             </a:pPr>
             <a:r>
@@ -5087,7 +4824,7 @@
                 <a:ea typeface="Arial" pitchFamily="34" charset="-122"/>
                 <a:cs typeface="Arial" pitchFamily="34" charset="-120"/>
               </a:rPr>
-              <a:t>Aplicar a fórmula  p = m · v  em situações simples</a:t>
+              <a:t>Calcular o módulo e indicar a unidade (kg·m/s)</a:t>
             </a:r>
             <a:endParaRPr lang="en-US" sz="1800" dirty="0"/>
           </a:p>
@@ -5158,7 +4895,7 @@
           <a:bodyPr wrap="square" lIns="0" tIns="0" rIns="0" bIns="0" rtlCol="0" anchor="ctr"/>
           <a:lstStyle/>
           <a:p>
-            <a:pPr indent="0" marL="0">
+            <a:pPr marL="0" indent="0">
               <a:buNone/>
             </a:pPr>
             <a:r>
@@ -5197,7 +4934,7 @@
           <a:bodyPr wrap="square" lIns="0" tIns="0" rIns="0" bIns="0" rtlCol="0" anchor="ctr"/>
           <a:lstStyle/>
           <a:p>
-            <a:pPr indent="0" marL="0">
+            <a:pPr marL="0" indent="0">
               <a:buNone/>
             </a:pPr>
             <a:r>
@@ -5209,7 +4946,7 @@
                 <a:ea typeface="Arial" pitchFamily="34" charset="-122"/>
                 <a:cs typeface="Arial" pitchFamily="34" charset="-120"/>
               </a:rPr>
-              <a:t>Compreender o caráter vetorial da quantidade de movimento</a:t>
+              <a:t>Relacionar direção e sentido de p ao vetor velocidade</a:t>
             </a:r>
             <a:endParaRPr lang="en-US" sz="1800" dirty="0"/>
           </a:p>
@@ -5280,7 +5017,7 @@
           <a:bodyPr wrap="square" lIns="0" tIns="0" rIns="0" bIns="0" rtlCol="0" anchor="ctr"/>
           <a:lstStyle/>
           <a:p>
-            <a:pPr indent="0" marL="0">
+            <a:pPr marL="0" indent="0">
               <a:buNone/>
             </a:pPr>
             <a:r>
@@ -5319,7 +5056,7 @@
           <a:bodyPr wrap="square" lIns="0" tIns="0" rIns="0" bIns="0" rtlCol="0" anchor="ctr"/>
           <a:lstStyle/>
           <a:p>
-            <a:pPr indent="0" marL="0">
+            <a:pPr marL="0" indent="0">
               <a:buNone/>
             </a:pPr>
             <a:r>
@@ -5331,7 +5068,7 @@
                 <a:ea typeface="Arial" pitchFamily="34" charset="-122"/>
                 <a:cs typeface="Arial" pitchFamily="34" charset="-120"/>
               </a:rPr>
-              <a:t>Relacionar o conceito a situações do cotidiano</a:t>
+              <a:t>Reconhecer só a ideia de conservação em sistema isolado.</a:t>
             </a:r>
             <a:endParaRPr lang="en-US" sz="1800" dirty="0"/>
           </a:p>
@@ -5353,6 +5090,7 @@
         <a:solidFill>
           <a:srgbClr val="F7F4EF"/>
         </a:solidFill>
+        <a:effectLst/>
       </p:bgPr>
     </p:bg>
     <p:spTree>
@@ -5390,11 +5128,11 @@
           <a:bodyPr wrap="square" lIns="0" tIns="0" rIns="0" bIns="0" rtlCol="0" anchor="ctr"/>
           <a:lstStyle/>
           <a:p>
-            <a:pPr indent="0" marL="0">
-              <a:buNone/>
-            </a:pPr>
-            <a:r>
-              <a:rPr lang="en-US" sz="1100" spc="200" kern="0" dirty="0">
+            <a:pPr marL="0" indent="0">
+              <a:buNone/>
+            </a:pPr>
+            <a:r>
+              <a:rPr lang="en-US" sz="1100" kern="0" spc="200" dirty="0">
                 <a:solidFill>
                   <a:srgbClr val="5C5C6E"/>
                 </a:solidFill>
@@ -5429,7 +5167,7 @@
           <a:bodyPr wrap="square" lIns="0" tIns="0" rIns="0" bIns="0" rtlCol="0" anchor="ctr"/>
           <a:lstStyle/>
           <a:p>
-            <a:pPr indent="0" marL="0">
+            <a:pPr marL="0" indent="0">
               <a:buNone/>
             </a:pPr>
             <a:r>
@@ -5468,7 +5206,7 @@
           <a:bodyPr wrap="square" lIns="0" tIns="0" rIns="0" bIns="0" rtlCol="0" anchor="ctr"/>
           <a:lstStyle/>
           <a:p>
-            <a:pPr algn="r" indent="0" marL="0">
+            <a:pPr marL="0" indent="0" algn="r">
               <a:buNone/>
             </a:pPr>
             <a:r>
@@ -5507,7 +5245,7 @@
           <a:bodyPr wrap="square" lIns="0" tIns="0" rIns="0" bIns="0" rtlCol="0" anchor="ctr"/>
           <a:lstStyle/>
           <a:p>
-            <a:pPr indent="0" marL="0">
+            <a:pPr marL="0" indent="0">
               <a:buNone/>
             </a:pPr>
             <a:r>
@@ -5546,7 +5284,7 @@
           <a:bodyPr wrap="square" lIns="0" tIns="0" rIns="0" bIns="0" rtlCol="0" anchor="ctr"/>
           <a:lstStyle/>
           <a:p>
-            <a:pPr indent="0" marL="0">
+            <a:pPr marL="0" indent="0">
               <a:buNone/>
             </a:pPr>
             <a:r>
@@ -5558,7 +5296,7 @@
                 <a:ea typeface="Arial" pitchFamily="34" charset="-122"/>
                 <a:cs typeface="Arial" pitchFamily="34" charset="-120"/>
               </a:rPr>
-              <a:t>Imagine duas situações:</a:t>
+              <a:t>Compare dois carrinhos:</a:t>
             </a:r>
             <a:endParaRPr lang="en-US" sz="1600" dirty="0"/>
           </a:p>
@@ -5627,7 +5365,7 @@
           <a:bodyPr wrap="square" lIns="0" tIns="0" rIns="0" bIns="0" rtlCol="0" anchor="ctr"/>
           <a:lstStyle/>
           <a:p>
-            <a:pPr algn="ctr" indent="0" marL="0">
+            <a:pPr marL="0" indent="0" algn="ctr">
               <a:buNone/>
             </a:pPr>
             <a:r>
@@ -5666,11 +5404,11 @@
           <a:bodyPr wrap="square" lIns="0" tIns="0" rIns="0" bIns="0" rtlCol="0" anchor="ctr"/>
           <a:lstStyle/>
           <a:p>
-            <a:pPr indent="0" marL="0">
-              <a:buNone/>
-            </a:pPr>
-            <a:r>
-              <a:rPr lang="en-US" sz="2000" dirty="0">
+            <a:pPr marL="0" indent="0">
+              <a:buNone/>
+            </a:pPr>
+            <a:r>
+              <a:rPr lang="pt-BR" sz="2000">
                 <a:solidFill>
                   <a:srgbClr val="1A1A2E"/>
                 </a:solidFill>
@@ -5678,41 +5416,8 @@
                 <a:ea typeface="Arial" pitchFamily="34" charset="-122"/>
                 <a:cs typeface="Arial" pitchFamily="34" charset="-120"/>
               </a:rPr>
-              <a:t>Pessoa no patinete</a:t>
-            </a:r>
-            <a:endParaRPr lang="en-US" sz="2000" dirty="0"/>
-          </a:p>
-          <a:p>
-            <a:pPr indent="0" marL="0">
-              <a:buNone/>
-            </a:pPr>
-            <a:r>
-              <a:rPr lang="en-US" sz="2000" dirty="0">
-                <a:solidFill>
-                  <a:srgbClr val="1A1A2E"/>
-                </a:solidFill>
-                <a:latin typeface="Arial" pitchFamily="34" charset="0"/>
-                <a:ea typeface="Arial" pitchFamily="34" charset="-122"/>
-                <a:cs typeface="Arial" pitchFamily="34" charset="-120"/>
-              </a:rPr>
-              <a:t>se movendo</a:t>
-            </a:r>
-            <a:endParaRPr lang="en-US" sz="2000" dirty="0"/>
-          </a:p>
-          <a:p>
-            <a:pPr indent="0" marL="0">
-              <a:buNone/>
-            </a:pPr>
-            <a:r>
-              <a:rPr lang="en-US" sz="2000" dirty="0">
-                <a:solidFill>
-                  <a:srgbClr val="1A1A2E"/>
-                </a:solidFill>
-                <a:latin typeface="Arial" pitchFamily="34" charset="0"/>
-                <a:ea typeface="Arial" pitchFamily="34" charset="-122"/>
-                <a:cs typeface="Arial" pitchFamily="34" charset="-120"/>
-              </a:rPr>
-              <a:t>devagar</a:t>
+              <a:t>Massa: 2 kg
+Velocidade: 3 m/s</a:t>
             </a:r>
             <a:endParaRPr lang="en-US" sz="2000" dirty="0"/>
           </a:p>
@@ -5781,7 +5486,7 @@
           <a:bodyPr wrap="square" lIns="0" tIns="0" rIns="0" bIns="0" rtlCol="0" anchor="ctr"/>
           <a:lstStyle/>
           <a:p>
-            <a:pPr algn="ctr" indent="0" marL="0">
+            <a:pPr marL="0" indent="0" algn="ctr">
               <a:buNone/>
             </a:pPr>
             <a:r>
@@ -5820,11 +5525,11 @@
           <a:bodyPr wrap="square" lIns="0" tIns="0" rIns="0" bIns="0" rtlCol="0" anchor="ctr"/>
           <a:lstStyle/>
           <a:p>
-            <a:pPr indent="0" marL="0">
-              <a:buNone/>
-            </a:pPr>
-            <a:r>
-              <a:rPr lang="en-US" sz="2000" dirty="0">
+            <a:pPr marL="0" indent="0">
+              <a:buNone/>
+            </a:pPr>
+            <a:r>
+              <a:rPr lang="pt-BR" sz="2000">
                 <a:solidFill>
                   <a:srgbClr val="1A1A2E"/>
                 </a:solidFill>
@@ -5832,41 +5537,8 @@
                 <a:ea typeface="Arial" pitchFamily="34" charset="-122"/>
                 <a:cs typeface="Arial" pitchFamily="34" charset="-120"/>
               </a:rPr>
-              <a:t>Mesma pessoa no</a:t>
-            </a:r>
-            <a:endParaRPr lang="en-US" sz="2000" dirty="0"/>
-          </a:p>
-          <a:p>
-            <a:pPr indent="0" marL="0">
-              <a:buNone/>
-            </a:pPr>
-            <a:r>
-              <a:rPr lang="en-US" sz="2000" dirty="0">
-                <a:solidFill>
-                  <a:srgbClr val="1A1A2E"/>
-                </a:solidFill>
-                <a:latin typeface="Arial" pitchFamily="34" charset="0"/>
-                <a:ea typeface="Arial" pitchFamily="34" charset="-122"/>
-                <a:cs typeface="Arial" pitchFamily="34" charset="-120"/>
-              </a:rPr>
-              <a:t>patinete se movendo</a:t>
-            </a:r>
-            <a:endParaRPr lang="en-US" sz="2000" dirty="0"/>
-          </a:p>
-          <a:p>
-            <a:pPr indent="0" marL="0">
-              <a:buNone/>
-            </a:pPr>
-            <a:r>
-              <a:rPr lang="en-US" sz="2000" dirty="0">
-                <a:solidFill>
-                  <a:srgbClr val="1A1A2E"/>
-                </a:solidFill>
-                <a:latin typeface="Arial" pitchFamily="34" charset="0"/>
-                <a:ea typeface="Arial" pitchFamily="34" charset="-122"/>
-                <a:cs typeface="Arial" pitchFamily="34" charset="-120"/>
-              </a:rPr>
-              <a:t>rápido</a:t>
+              <a:t>Massa: 4 kg
+Velocidade: 3 m/s</a:t>
             </a:r>
             <a:endParaRPr lang="en-US" sz="2000" dirty="0"/>
           </a:p>
@@ -5893,7 +5565,7 @@
           <a:bodyPr wrap="square" lIns="0" tIns="0" rIns="0" bIns="0" rtlCol="0" anchor="ctr"/>
           <a:lstStyle/>
           <a:p>
-            <a:pPr indent="0" marL="0">
+            <a:pPr marL="0" indent="0">
               <a:buNone/>
             </a:pPr>
             <a:r>
@@ -5905,7 +5577,7 @@
                 <a:ea typeface="Arial" pitchFamily="34" charset="-122"/>
                 <a:cs typeface="Arial" pitchFamily="34" charset="-120"/>
               </a:rPr>
-              <a:t>O que torna mais difícil parar o patinete?</a:t>
+              <a:t>Como a massa afeta |p| com a rapidez igual?</a:t>
             </a:r>
             <a:endParaRPr lang="en-US" sz="2000" dirty="0"/>
           </a:p>
@@ -5927,6 +5599,7 @@
         <a:solidFill>
           <a:srgbClr val="F7F4EF"/>
         </a:solidFill>
+        <a:effectLst/>
       </p:bgPr>
     </p:bg>
     <p:spTree>
@@ -5964,11 +5637,11 @@
           <a:bodyPr wrap="square" lIns="0" tIns="0" rIns="0" bIns="0" rtlCol="0" anchor="ctr"/>
           <a:lstStyle/>
           <a:p>
-            <a:pPr indent="0" marL="0">
-              <a:buNone/>
-            </a:pPr>
-            <a:r>
-              <a:rPr lang="en-US" sz="1100" spc="200" kern="0" dirty="0">
+            <a:pPr marL="0" indent="0">
+              <a:buNone/>
+            </a:pPr>
+            <a:r>
+              <a:rPr lang="en-US" sz="1100" kern="0" spc="200" dirty="0">
                 <a:solidFill>
                   <a:srgbClr val="5C5C6E"/>
                 </a:solidFill>
@@ -6003,7 +5676,7 @@
           <a:bodyPr wrap="square" lIns="0" tIns="0" rIns="0" bIns="0" rtlCol="0" anchor="ctr"/>
           <a:lstStyle/>
           <a:p>
-            <a:pPr indent="0" marL="0">
+            <a:pPr marL="0" indent="0">
               <a:buNone/>
             </a:pPr>
             <a:r>
@@ -6042,7 +5715,7 @@
           <a:bodyPr wrap="square" lIns="0" tIns="0" rIns="0" bIns="0" rtlCol="0" anchor="ctr"/>
           <a:lstStyle/>
           <a:p>
-            <a:pPr algn="r" indent="0" marL="0">
+            <a:pPr marL="0" indent="0" algn="r">
               <a:buNone/>
             </a:pPr>
             <a:r>
@@ -6081,7 +5754,7 @@
           <a:bodyPr wrap="square" lIns="0" tIns="0" rIns="0" bIns="0" rtlCol="0" anchor="ctr"/>
           <a:lstStyle/>
           <a:p>
-            <a:pPr indent="0" marL="0">
+            <a:pPr marL="0" indent="0">
               <a:buNone/>
             </a:pPr>
             <a:r>
@@ -6120,7 +5793,7 @@
           <a:bodyPr wrap="square" lIns="0" tIns="0" rIns="0" bIns="0" rtlCol="0" anchor="ctr"/>
           <a:lstStyle/>
           <a:p>
-            <a:pPr indent="0" marL="0">
+            <a:pPr marL="0" indent="0">
               <a:buNone/>
             </a:pPr>
             <a:r>
@@ -6181,7 +5854,7 @@
           <a:bodyPr wrap="square" lIns="0" tIns="0" rIns="0" bIns="0" rtlCol="0" anchor="ctr"/>
           <a:lstStyle/>
           <a:p>
-            <a:pPr indent="0" marL="0">
+            <a:pPr marL="0" indent="0">
               <a:buNone/>
             </a:pPr>
             <a:r>
@@ -6198,20 +5871,9 @@
             <a:endParaRPr lang="en-US" sz="2400" dirty="0"/>
           </a:p>
           <a:p>
-            <a:pPr indent="0" marL="0">
-              <a:buNone/>
-            </a:pPr>
-            <a:r>
-              <a:rPr lang="en-US" sz="2400" dirty="0">
-                <a:solidFill>
-                  <a:srgbClr val="FFFFFF"/>
-                </a:solidFill>
-                <a:latin typeface="Arial" pitchFamily="34" charset="0"/>
-                <a:ea typeface="Arial" pitchFamily="34" charset="-122"/>
-                <a:cs typeface="Arial" pitchFamily="34" charset="-120"/>
-              </a:rPr>
-              <a:t/>
-            </a:r>
+            <a:pPr marL="0" indent="0">
+              <a:buNone/>
+            </a:pPr>
             <a:endParaRPr lang="en-US" sz="2400" dirty="0"/>
           </a:p>
         </p:txBody>
@@ -6237,7 +5899,7 @@
           <a:bodyPr wrap="square" lIns="0" tIns="0" rIns="0" bIns="0" rtlCol="0" anchor="ctr"/>
           <a:lstStyle/>
           <a:p>
-            <a:pPr indent="0" marL="0">
+            <a:pPr marL="0" indent="0">
               <a:buNone/>
             </a:pPr>
             <a:r>
@@ -6276,7 +5938,7 @@
           <a:bodyPr wrap="square" lIns="0" tIns="0" rIns="0" bIns="0" rtlCol="0" anchor="ctr"/>
           <a:lstStyle/>
           <a:p>
-            <a:pPr indent="0" marL="0">
+            <a:pPr marL="0" indent="0">
               <a:buNone/>
             </a:pPr>
             <a:r>
@@ -6310,6 +5972,7 @@
         <a:solidFill>
           <a:srgbClr val="F7F4EF"/>
         </a:solidFill>
+        <a:effectLst/>
       </p:bgPr>
     </p:bg>
     <p:spTree>
@@ -6347,11 +6010,11 @@
           <a:bodyPr wrap="square" lIns="0" tIns="0" rIns="0" bIns="0" rtlCol="0" anchor="ctr"/>
           <a:lstStyle/>
           <a:p>
-            <a:pPr indent="0" marL="0">
-              <a:buNone/>
-            </a:pPr>
-            <a:r>
-              <a:rPr lang="en-US" sz="1100" spc="200" kern="0" dirty="0">
+            <a:pPr marL="0" indent="0">
+              <a:buNone/>
+            </a:pPr>
+            <a:r>
+              <a:rPr lang="en-US" sz="1100" kern="0" spc="200" dirty="0">
                 <a:solidFill>
                   <a:srgbClr val="5C5C6E"/>
                 </a:solidFill>
@@ -6386,7 +6049,7 @@
           <a:bodyPr wrap="square" lIns="0" tIns="0" rIns="0" bIns="0" rtlCol="0" anchor="ctr"/>
           <a:lstStyle/>
           <a:p>
-            <a:pPr indent="0" marL="0">
+            <a:pPr marL="0" indent="0">
               <a:buNone/>
             </a:pPr>
             <a:r>
@@ -6425,7 +6088,7 @@
           <a:bodyPr wrap="square" lIns="0" tIns="0" rIns="0" bIns="0" rtlCol="0" anchor="ctr"/>
           <a:lstStyle/>
           <a:p>
-            <a:pPr algn="r" indent="0" marL="0">
+            <a:pPr marL="0" indent="0" algn="r">
               <a:buNone/>
             </a:pPr>
             <a:r>
@@ -6464,7 +6127,7 @@
           <a:bodyPr wrap="square" lIns="0" tIns="0" rIns="0" bIns="0" rtlCol="0" anchor="ctr"/>
           <a:lstStyle/>
           <a:p>
-            <a:pPr indent="0" marL="0">
+            <a:pPr marL="0" indent="0">
               <a:buNone/>
             </a:pPr>
             <a:r>
@@ -6525,7 +6188,7 @@
           <a:bodyPr wrap="square" lIns="0" tIns="0" rIns="0" bIns="0" rtlCol="0" anchor="ctr"/>
           <a:lstStyle/>
           <a:p>
-            <a:pPr algn="ctr" indent="0" marL="0">
+            <a:pPr marL="0" indent="0" algn="ctr">
               <a:buNone/>
             </a:pPr>
             <a:r>
@@ -6586,7 +6249,7 @@
           <a:bodyPr wrap="square" lIns="0" tIns="0" rIns="0" bIns="0" rtlCol="0" anchor="ctr"/>
           <a:lstStyle/>
           <a:p>
-            <a:pPr algn="ctr" indent="0" marL="0">
+            <a:pPr marL="0" indent="0" algn="ctr">
               <a:buNone/>
             </a:pPr>
             <a:r>
@@ -6625,7 +6288,7 @@
           <a:bodyPr wrap="square" lIns="0" tIns="0" rIns="0" bIns="0" rtlCol="0" anchor="ctr"/>
           <a:lstStyle/>
           <a:p>
-            <a:pPr indent="0" marL="0">
+            <a:pPr marL="0" indent="0">
               <a:buNone/>
             </a:pPr>
             <a:r>
@@ -6686,7 +6349,7 @@
           <a:bodyPr wrap="square" lIns="0" tIns="0" rIns="0" bIns="0" rtlCol="0" anchor="ctr"/>
           <a:lstStyle/>
           <a:p>
-            <a:pPr algn="ctr" indent="0" marL="0">
+            <a:pPr marL="0" indent="0" algn="ctr">
               <a:buNone/>
             </a:pPr>
             <a:r>
@@ -6725,7 +6388,7 @@
           <a:bodyPr wrap="square" lIns="0" tIns="0" rIns="0" bIns="0" rtlCol="0" anchor="ctr"/>
           <a:lstStyle/>
           <a:p>
-            <a:pPr indent="0" marL="0">
+            <a:pPr marL="0" indent="0">
               <a:buNone/>
             </a:pPr>
             <a:r>
@@ -6786,7 +6449,7 @@
           <a:bodyPr wrap="square" lIns="0" tIns="0" rIns="0" bIns="0" rtlCol="0" anchor="ctr"/>
           <a:lstStyle/>
           <a:p>
-            <a:pPr algn="ctr" indent="0" marL="0">
+            <a:pPr marL="0" indent="0" algn="ctr">
               <a:buNone/>
             </a:pPr>
             <a:r>
@@ -6825,7 +6488,7 @@
           <a:bodyPr wrap="square" lIns="0" tIns="0" rIns="0" bIns="0" rtlCol="0" anchor="ctr"/>
           <a:lstStyle/>
           <a:p>
-            <a:pPr indent="0" marL="0">
+            <a:pPr marL="0" indent="0">
               <a:buNone/>
             </a:pPr>
             <a:r>
@@ -6859,6 +6522,7 @@
         <a:solidFill>
           <a:srgbClr val="F7F4EF"/>
         </a:solidFill>
+        <a:effectLst/>
       </p:bgPr>
     </p:bg>
     <p:spTree>
@@ -6896,11 +6560,11 @@
           <a:bodyPr wrap="square" lIns="0" tIns="0" rIns="0" bIns="0" rtlCol="0" anchor="ctr"/>
           <a:lstStyle/>
           <a:p>
-            <a:pPr indent="0" marL="0">
-              <a:buNone/>
-            </a:pPr>
-            <a:r>
-              <a:rPr lang="en-US" sz="1100" spc="200" kern="0" dirty="0">
+            <a:pPr marL="0" indent="0">
+              <a:buNone/>
+            </a:pPr>
+            <a:r>
+              <a:rPr lang="en-US" sz="1100" kern="0" spc="200" dirty="0">
                 <a:solidFill>
                   <a:srgbClr val="5C5C6E"/>
                 </a:solidFill>
@@ -6935,7 +6599,7 @@
           <a:bodyPr wrap="square" lIns="0" tIns="0" rIns="0" bIns="0" rtlCol="0" anchor="ctr"/>
           <a:lstStyle/>
           <a:p>
-            <a:pPr indent="0" marL="0">
+            <a:pPr marL="0" indent="0">
               <a:buNone/>
             </a:pPr>
             <a:r>
@@ -6974,7 +6638,7 @@
           <a:bodyPr wrap="square" lIns="0" tIns="0" rIns="0" bIns="0" rtlCol="0" anchor="ctr"/>
           <a:lstStyle/>
           <a:p>
-            <a:pPr algn="r" indent="0" marL="0">
+            <a:pPr marL="0" indent="0" algn="r">
               <a:buNone/>
             </a:pPr>
             <a:r>
@@ -7013,7 +6677,7 @@
           <a:bodyPr wrap="square" lIns="0" tIns="0" rIns="0" bIns="0" rtlCol="0" anchor="ctr"/>
           <a:lstStyle/>
           <a:p>
-            <a:pPr indent="0" marL="0">
+            <a:pPr marL="0" indent="0">
               <a:buNone/>
             </a:pPr>
             <a:r>
@@ -7074,11 +6738,11 @@
           <a:bodyPr wrap="square" lIns="0" tIns="0" rIns="0" bIns="0" rtlCol="0" anchor="ctr"/>
           <a:lstStyle/>
           <a:p>
-            <a:pPr indent="0" marL="0">
-              <a:buNone/>
-            </a:pPr>
-            <a:r>
-              <a:rPr lang="en-US" sz="1400" b="1" spc="200" kern="0" dirty="0">
+            <a:pPr marL="0" indent="0">
+              <a:buNone/>
+            </a:pPr>
+            <a:r>
+              <a:rPr lang="en-US" sz="1400" b="1" kern="0" spc="200" dirty="0">
                 <a:solidFill>
                   <a:srgbClr val="E9C46A"/>
                 </a:solidFill>
@@ -7113,7 +6777,7 @@
           <a:bodyPr wrap="square" lIns="0" tIns="0" rIns="0" bIns="0" rtlCol="0" anchor="ctr"/>
           <a:lstStyle/>
           <a:p>
-            <a:pPr indent="0" marL="0">
+            <a:pPr marL="0" indent="0">
               <a:buNone/>
             </a:pPr>
             <a:r>
@@ -7152,7 +6816,7 @@
           <a:bodyPr wrap="square" lIns="0" tIns="0" rIns="0" bIns="0" rtlCol="0" anchor="ctr"/>
           <a:lstStyle/>
           <a:p>
-            <a:pPr indent="0" marL="0">
+            <a:pPr marL="0" indent="0">
               <a:buNone/>
             </a:pPr>
             <a:r>
@@ -7169,7 +6833,7 @@
             <a:endParaRPr lang="en-US" sz="1700" dirty="0"/>
           </a:p>
           <a:p>
-            <a:pPr indent="0" marL="0">
+            <a:pPr marL="0" indent="0">
               <a:buNone/>
             </a:pPr>
             <a:r>
@@ -7186,13 +6850,13 @@
             <a:endParaRPr lang="en-US" sz="1700" dirty="0"/>
           </a:p>
           <a:p>
-            <a:pPr indent="0" marL="0">
+            <a:pPr marL="0" indent="0">
               <a:buNone/>
             </a:pPr>
             <a:endParaRPr lang="en-US" sz="1700" dirty="0"/>
           </a:p>
           <a:p>
-            <a:pPr indent="0" marL="0">
+            <a:pPr marL="0" indent="0">
               <a:buNone/>
             </a:pPr>
             <a:r>
@@ -7209,7 +6873,7 @@
             <a:endParaRPr lang="en-US" sz="1700" dirty="0"/>
           </a:p>
           <a:p>
-            <a:pPr indent="0" marL="0">
+            <a:pPr marL="0" indent="0">
               <a:buNone/>
             </a:pPr>
             <a:r>
@@ -7226,7 +6890,7 @@
             <a:endParaRPr lang="en-US" sz="1700" dirty="0"/>
           </a:p>
           <a:p>
-            <a:pPr indent="0" marL="0">
+            <a:pPr marL="0" indent="0">
               <a:buNone/>
             </a:pPr>
             <a:r>
@@ -7287,11 +6951,11 @@
           <a:bodyPr wrap="square" lIns="0" tIns="0" rIns="0" bIns="0" rtlCol="0" anchor="ctr"/>
           <a:lstStyle/>
           <a:p>
-            <a:pPr indent="0" marL="0">
-              <a:buNone/>
-            </a:pPr>
-            <a:r>
-              <a:rPr lang="en-US" sz="1400" b="1" spc="200" kern="0" dirty="0">
+            <a:pPr marL="0" indent="0">
+              <a:buNone/>
+            </a:pPr>
+            <a:r>
+              <a:rPr lang="en-US" sz="1400" b="1" kern="0" spc="200" dirty="0">
                 <a:solidFill>
                   <a:srgbClr val="E9C46A"/>
                 </a:solidFill>
@@ -7326,7 +6990,7 @@
           <a:bodyPr wrap="square" lIns="0" tIns="0" rIns="0" bIns="0" rtlCol="0" anchor="ctr"/>
           <a:lstStyle/>
           <a:p>
-            <a:pPr indent="0" marL="0">
+            <a:pPr marL="0" indent="0">
               <a:buNone/>
             </a:pPr>
             <a:r>
@@ -7343,7 +7007,7 @@
             <a:endParaRPr lang="en-US" sz="2600" dirty="0"/>
           </a:p>
           <a:p>
-            <a:pPr indent="0" marL="0">
+            <a:pPr marL="0" indent="0">
               <a:buNone/>
             </a:pPr>
             <a:r>
@@ -7382,7 +7046,7 @@
           <a:bodyPr wrap="square" lIns="0" tIns="0" rIns="0" bIns="0" rtlCol="0" anchor="ctr"/>
           <a:lstStyle/>
           <a:p>
-            <a:pPr indent="0" marL="0">
+            <a:pPr marL="0" indent="0">
               <a:buNone/>
             </a:pPr>
             <a:r>
@@ -7399,7 +7063,7 @@
             <a:endParaRPr lang="en-US" sz="1600" dirty="0"/>
           </a:p>
           <a:p>
-            <a:pPr indent="0" marL="0">
+            <a:pPr marL="0" indent="0">
               <a:buNone/>
             </a:pPr>
             <a:r>
@@ -7416,7 +7080,7 @@
             <a:endParaRPr lang="en-US" sz="1600" dirty="0"/>
           </a:p>
           <a:p>
-            <a:pPr indent="0" marL="0">
+            <a:pPr marL="0" indent="0">
               <a:buNone/>
             </a:pPr>
             <a:r>
@@ -7433,13 +7097,13 @@
             <a:endParaRPr lang="en-US" sz="1600" dirty="0"/>
           </a:p>
           <a:p>
-            <a:pPr indent="0" marL="0">
+            <a:pPr marL="0" indent="0">
               <a:buNone/>
             </a:pPr>
             <a:endParaRPr lang="en-US" sz="1600" dirty="0"/>
           </a:p>
           <a:p>
-            <a:pPr indent="0" marL="0">
+            <a:pPr marL="0" indent="0">
               <a:buNone/>
             </a:pPr>
             <a:r>
@@ -7456,7 +7120,7 @@
             <a:endParaRPr lang="en-US" sz="1600" dirty="0"/>
           </a:p>
           <a:p>
-            <a:pPr indent="0" marL="0">
+            <a:pPr marL="0" indent="0">
               <a:buNone/>
             </a:pPr>
             <a:r>
@@ -7490,6 +7154,7 @@
         <a:solidFill>
           <a:srgbClr val="F7F4EF"/>
         </a:solidFill>
+        <a:effectLst/>
       </p:bgPr>
     </p:bg>
     <p:spTree>
@@ -7527,11 +7192,11 @@
           <a:bodyPr wrap="square" lIns="0" tIns="0" rIns="0" bIns="0" rtlCol="0" anchor="ctr"/>
           <a:lstStyle/>
           <a:p>
-            <a:pPr indent="0" marL="0">
-              <a:buNone/>
-            </a:pPr>
-            <a:r>
-              <a:rPr lang="en-US" sz="1100" spc="200" kern="0" dirty="0">
+            <a:pPr marL="0" indent="0">
+              <a:buNone/>
+            </a:pPr>
+            <a:r>
+              <a:rPr lang="en-US" sz="1100" kern="0" spc="200" dirty="0">
                 <a:solidFill>
                   <a:srgbClr val="5C5C6E"/>
                 </a:solidFill>
@@ -7566,7 +7231,7 @@
           <a:bodyPr wrap="square" lIns="0" tIns="0" rIns="0" bIns="0" rtlCol="0" anchor="ctr"/>
           <a:lstStyle/>
           <a:p>
-            <a:pPr indent="0" marL="0">
+            <a:pPr marL="0" indent="0">
               <a:buNone/>
             </a:pPr>
             <a:r>
@@ -7605,7 +7270,7 @@
           <a:bodyPr wrap="square" lIns="0" tIns="0" rIns="0" bIns="0" rtlCol="0" anchor="ctr"/>
           <a:lstStyle/>
           <a:p>
-            <a:pPr algn="r" indent="0" marL="0">
+            <a:pPr marL="0" indent="0" algn="r">
               <a:buNone/>
             </a:pPr>
             <a:r>
@@ -7644,7 +7309,7 @@
           <a:bodyPr wrap="square" lIns="0" tIns="0" rIns="0" bIns="0" rtlCol="0" anchor="ctr"/>
           <a:lstStyle/>
           <a:p>
-            <a:pPr indent="0" marL="0">
+            <a:pPr marL="0" indent="0">
               <a:buNone/>
             </a:pPr>
             <a:r>
@@ -7727,7 +7392,7 @@
           <a:bodyPr wrap="square" lIns="0" tIns="0" rIns="0" bIns="0" rtlCol="0" anchor="ctr"/>
           <a:lstStyle/>
           <a:p>
-            <a:pPr indent="0" marL="0">
+            <a:pPr marL="0" indent="0">
               <a:buNone/>
             </a:pPr>
             <a:r>
@@ -7766,7 +7431,7 @@
           <a:bodyPr wrap="square" lIns="0" tIns="0" rIns="0" bIns="0" rtlCol="0" anchor="ctr"/>
           <a:lstStyle/>
           <a:p>
-            <a:pPr indent="0" marL="0">
+            <a:pPr marL="0" indent="0">
               <a:buNone/>
             </a:pPr>
             <a:r>
@@ -7778,7 +7443,7 @@
                 <a:ea typeface="Arial" pitchFamily="34" charset="-122"/>
                 <a:cs typeface="Arial" pitchFamily="34" charset="-120"/>
               </a:rPr>
-              <a:t>Leve, mas chutada com alta velocidade — pode ter quantidade de movimento surpreendente.</a:t>
+              <a:t>No mesmo sentido, a mesma bola a 16 m/s tem o dobro de |p| que a 8 m/s.</a:t>
             </a:r>
             <a:endParaRPr lang="en-US" sz="1600" dirty="0"/>
           </a:p>
@@ -7849,7 +7514,7 @@
           <a:bodyPr wrap="square" lIns="0" tIns="0" rIns="0" bIns="0" rtlCol="0" anchor="ctr"/>
           <a:lstStyle/>
           <a:p>
-            <a:pPr indent="0" marL="0">
+            <a:pPr marL="0" indent="0">
               <a:buNone/>
             </a:pPr>
             <a:r>
@@ -7861,7 +7526,7 @@
                 <a:ea typeface="Arial" pitchFamily="34" charset="-122"/>
                 <a:cs typeface="Arial" pitchFamily="34" charset="-120"/>
               </a:rPr>
-              <a:t>Caminhão vs. moto</a:t>
+              <a:t>Carrinhos A/B</a:t>
             </a:r>
             <a:endParaRPr lang="en-US" sz="1800" dirty="0"/>
           </a:p>
@@ -7888,7 +7553,7 @@
           <a:bodyPr wrap="square" lIns="0" tIns="0" rIns="0" bIns="0" rtlCol="0" anchor="ctr"/>
           <a:lstStyle/>
           <a:p>
-            <a:pPr indent="0" marL="0">
+            <a:pPr marL="0" indent="0">
               <a:buNone/>
             </a:pPr>
             <a:r>
@@ -7900,7 +7565,7 @@
                 <a:ea typeface="Arial" pitchFamily="34" charset="-122"/>
                 <a:cs typeface="Arial" pitchFamily="34" charset="-120"/>
               </a:rPr>
-              <a:t>A massa maior, sozinha, não garante maior |p|: considere também a velocidade.</a:t>
+              <a:t>A 3 m/s, 2 kg têm |p| = 6; 4 kg têm |p| = 12 kg·m/s.</a:t>
             </a:r>
             <a:endParaRPr lang="en-US" sz="1600" dirty="0"/>
           </a:p>
@@ -7971,7 +7636,7 @@
           <a:bodyPr wrap="square" lIns="0" tIns="0" rIns="0" bIns="0" rtlCol="0" anchor="ctr"/>
           <a:lstStyle/>
           <a:p>
-            <a:pPr indent="0" marL="0">
+            <a:pPr marL="0" indent="0">
               <a:buNone/>
             </a:pPr>
             <a:r>
@@ -8010,7 +7675,7 @@
           <a:bodyPr wrap="square" lIns="0" tIns="0" rIns="0" bIns="0" rtlCol="0" anchor="ctr"/>
           <a:lstStyle/>
           <a:p>
-            <a:pPr indent="0" marL="0">
+            <a:pPr marL="0" indent="0">
               <a:buNone/>
             </a:pPr>
             <a:r>
@@ -8022,7 +7687,7 @@
                 <a:ea typeface="Arial" pitchFamily="34" charset="-122"/>
                 <a:cs typeface="Arial" pitchFamily="34" charset="-120"/>
               </a:rPr>
-              <a:t>Ao aumentar a velocidade, a quantidade de movimento aumenta (massa constante).</a:t>
+              <a:t>Ao inverter a velocidade, o vetor quantidade de movimento inverte o sentido.</a:t>
             </a:r>
             <a:endParaRPr lang="en-US" sz="1600" dirty="0"/>
           </a:p>
@@ -8044,6 +7709,7 @@
         <a:solidFill>
           <a:srgbClr val="F7F4EF"/>
         </a:solidFill>
+        <a:effectLst/>
       </p:bgPr>
     </p:bg>
     <p:spTree>
@@ -8081,11 +7747,11 @@
           <a:bodyPr wrap="square" lIns="0" tIns="0" rIns="0" bIns="0" rtlCol="0" anchor="ctr"/>
           <a:lstStyle/>
           <a:p>
-            <a:pPr indent="0" marL="0">
-              <a:buNone/>
-            </a:pPr>
-            <a:r>
-              <a:rPr lang="en-US" sz="1100" spc="200" kern="0" dirty="0">
+            <a:pPr marL="0" indent="0">
+              <a:buNone/>
+            </a:pPr>
+            <a:r>
+              <a:rPr lang="en-US" sz="1100" kern="0" spc="200" dirty="0">
                 <a:solidFill>
                   <a:srgbClr val="5C5C6E"/>
                 </a:solidFill>
@@ -8120,7 +7786,7 @@
           <a:bodyPr wrap="square" lIns="0" tIns="0" rIns="0" bIns="0" rtlCol="0" anchor="ctr"/>
           <a:lstStyle/>
           <a:p>
-            <a:pPr indent="0" marL="0">
+            <a:pPr marL="0" indent="0">
               <a:buNone/>
             </a:pPr>
             <a:r>
@@ -8159,7 +7825,7 @@
           <a:bodyPr wrap="square" lIns="0" tIns="0" rIns="0" bIns="0" rtlCol="0" anchor="ctr"/>
           <a:lstStyle/>
           <a:p>
-            <a:pPr algn="r" indent="0" marL="0">
+            <a:pPr marL="0" indent="0" algn="r">
               <a:buNone/>
             </a:pPr>
             <a:r>
@@ -8198,7 +7864,7 @@
           <a:bodyPr wrap="square" lIns="0" tIns="0" rIns="0" bIns="0" rtlCol="0" anchor="ctr"/>
           <a:lstStyle/>
           <a:p>
-            <a:pPr indent="0" marL="0">
+            <a:pPr marL="0" indent="0">
               <a:buNone/>
             </a:pPr>
             <a:r>
@@ -8237,7 +7903,7 @@
           <a:bodyPr wrap="square" lIns="0" tIns="0" rIns="0" bIns="0" rtlCol="0" anchor="ctr"/>
           <a:lstStyle/>
           <a:p>
-            <a:pPr indent="0" marL="0">
+            <a:pPr marL="0" indent="0">
               <a:buNone/>
             </a:pPr>
             <a:r>
@@ -8254,7 +7920,7 @@
             <a:endParaRPr lang="en-US" sz="1800" dirty="0"/>
           </a:p>
           <a:p>
-            <a:pPr indent="0" marL="0">
+            <a:pPr marL="0" indent="0">
               <a:buNone/>
             </a:pPr>
             <a:r>
@@ -8315,11 +7981,11 @@
           <a:bodyPr wrap="square" lIns="0" tIns="0" rIns="0" bIns="0" rtlCol="0" anchor="ctr"/>
           <a:lstStyle/>
           <a:p>
-            <a:pPr indent="0" marL="0">
-              <a:buNone/>
-            </a:pPr>
-            <a:r>
-              <a:rPr lang="en-US" sz="1400" b="1" spc="200" kern="0" dirty="0">
+            <a:pPr marL="0" indent="0">
+              <a:buNone/>
+            </a:pPr>
+            <a:r>
+              <a:rPr lang="en-US" sz="1400" b="1" kern="0" spc="200" dirty="0">
                 <a:solidFill>
                   <a:srgbClr val="E85A4F"/>
                 </a:solidFill>
@@ -8354,7 +8020,7 @@
           <a:bodyPr wrap="square" lIns="0" tIns="0" rIns="0" bIns="0" rtlCol="0" anchor="ctr"/>
           <a:lstStyle/>
           <a:p>
-            <a:pPr indent="0" marL="0">
+            <a:pPr marL="0" indent="0">
               <a:buNone/>
             </a:pPr>
             <a:r>
@@ -8371,7 +8037,7 @@
             <a:endParaRPr lang="en-US" sz="2200" dirty="0"/>
           </a:p>
           <a:p>
-            <a:pPr indent="0" marL="0">
+            <a:pPr marL="0" indent="0">
               <a:buNone/>
             </a:pPr>
             <a:r>
@@ -8432,11 +8098,11 @@
           <a:bodyPr wrap="square" lIns="0" tIns="0" rIns="0" bIns="0" rtlCol="0" anchor="ctr"/>
           <a:lstStyle/>
           <a:p>
-            <a:pPr indent="0" marL="0">
-              <a:buNone/>
-            </a:pPr>
-            <a:r>
-              <a:rPr lang="en-US" sz="1400" b="1" spc="200" kern="0" dirty="0">
+            <a:pPr marL="0" indent="0">
+              <a:buNone/>
+            </a:pPr>
+            <a:r>
+              <a:rPr lang="en-US" sz="1400" b="1" kern="0" spc="200" dirty="0">
                 <a:solidFill>
                   <a:srgbClr val="E9C46A"/>
                 </a:solidFill>
@@ -8471,7 +8137,7 @@
           <a:bodyPr wrap="square" lIns="0" tIns="0" rIns="0" bIns="0" rtlCol="0" anchor="ctr"/>
           <a:lstStyle/>
           <a:p>
-            <a:pPr indent="0" marL="0">
+            <a:pPr marL="0" indent="0">
               <a:buNone/>
             </a:pPr>
             <a:r>
@@ -8488,7 +8154,7 @@
             <a:endParaRPr lang="en-US" sz="2200" dirty="0"/>
           </a:p>
           <a:p>
-            <a:pPr indent="0" marL="0">
+            <a:pPr marL="0" indent="0">
               <a:buNone/>
             </a:pPr>
             <a:r>
@@ -8505,7 +8171,7 @@
             <a:endParaRPr lang="en-US" sz="2200" dirty="0"/>
           </a:p>
           <a:p>
-            <a:pPr indent="0" marL="0">
+            <a:pPr marL="0" indent="0">
               <a:buNone/>
             </a:pPr>
             <a:r>
@@ -8539,6 +8205,7 @@
         <a:solidFill>
           <a:srgbClr val="F7F4EF"/>
         </a:solidFill>
+        <a:effectLst/>
       </p:bgPr>
     </p:bg>
     <p:spTree>
@@ -8576,11 +8243,11 @@
           <a:bodyPr wrap="square" lIns="0" tIns="0" rIns="0" bIns="0" rtlCol="0" anchor="ctr"/>
           <a:lstStyle/>
           <a:p>
-            <a:pPr indent="0" marL="0">
-              <a:buNone/>
-            </a:pPr>
-            <a:r>
-              <a:rPr lang="en-US" sz="1100" spc="200" kern="0" dirty="0">
+            <a:pPr marL="0" indent="0">
+              <a:buNone/>
+            </a:pPr>
+            <a:r>
+              <a:rPr lang="en-US" sz="1100" kern="0" spc="200" dirty="0">
                 <a:solidFill>
                   <a:srgbClr val="5C5C6E"/>
                 </a:solidFill>
@@ -8615,7 +8282,7 @@
           <a:bodyPr wrap="square" lIns="0" tIns="0" rIns="0" bIns="0" rtlCol="0" anchor="ctr"/>
           <a:lstStyle/>
           <a:p>
-            <a:pPr indent="0" marL="0">
+            <a:pPr marL="0" indent="0">
               <a:buNone/>
             </a:pPr>
             <a:r>
@@ -8654,7 +8321,7 @@
           <a:bodyPr wrap="square" lIns="0" tIns="0" rIns="0" bIns="0" rtlCol="0" anchor="ctr"/>
           <a:lstStyle/>
           <a:p>
-            <a:pPr algn="r" indent="0" marL="0">
+            <a:pPr marL="0" indent="0" algn="r">
               <a:buNone/>
             </a:pPr>
             <a:r>
@@ -8693,7 +8360,7 @@
           <a:bodyPr wrap="square" lIns="0" tIns="0" rIns="0" bIns="0" rtlCol="0" anchor="ctr"/>
           <a:lstStyle/>
           <a:p>
-            <a:pPr indent="0" marL="0">
+            <a:pPr marL="0" indent="0">
               <a:buNone/>
             </a:pPr>
             <a:r>
@@ -8732,7 +8399,7 @@
           <a:bodyPr wrap="square" lIns="0" tIns="0" rIns="0" bIns="0" rtlCol="0" anchor="ctr"/>
           <a:lstStyle/>
           <a:p>
-            <a:pPr indent="0" marL="0">
+            <a:pPr marL="0" indent="0">
               <a:buNone/>
             </a:pPr>
             <a:r>
@@ -8749,7 +8416,7 @@
             <a:endParaRPr lang="en-US" sz="1700" dirty="0"/>
           </a:p>
           <a:p>
-            <a:pPr indent="0" marL="0">
+            <a:pPr marL="0" indent="0">
               <a:buNone/>
             </a:pPr>
             <a:r>
@@ -8810,7 +8477,7 @@
           <a:bodyPr wrap="square" lIns="0" tIns="0" rIns="0" bIns="0" rtlCol="0" anchor="ctr"/>
           <a:lstStyle/>
           <a:p>
-            <a:pPr indent="0" marL="0">
+            <a:pPr marL="0" indent="0">
               <a:buNone/>
             </a:pPr>
             <a:r>
@@ -8871,7 +8538,7 @@
           <a:bodyPr wrap="square" lIns="0" tIns="0" rIns="0" bIns="0" rtlCol="0" anchor="ctr"/>
           <a:lstStyle/>
           <a:p>
-            <a:pPr indent="0" marL="0">
+            <a:pPr marL="0" indent="0">
               <a:buNone/>
             </a:pPr>
             <a:r>
@@ -8910,7 +8577,7 @@
           <a:bodyPr wrap="square" lIns="0" tIns="0" rIns="0" bIns="0" rtlCol="0" anchor="ctr"/>
           <a:lstStyle/>
           <a:p>
-            <a:pPr indent="0" marL="0">
+            <a:pPr marL="0" indent="0">
               <a:buNone/>
             </a:pPr>
             <a:r>
@@ -8927,7 +8594,7 @@
             <a:endParaRPr lang="en-US" sz="1600" dirty="0"/>
           </a:p>
           <a:p>
-            <a:pPr indent="0" marL="0">
+            <a:pPr marL="0" indent="0">
               <a:buNone/>
             </a:pPr>
             <a:r>
@@ -9246,4 +8913,319 @@
     </a:ext>
   </a:extLst>
 </a:theme>
+</file>
+
+<file path=ppt/theme/theme2.xml><?xml version="1.0" encoding="utf-8"?>
+<a:theme xmlns:a="http://schemas.openxmlformats.org/drawingml/2006/main" name="Office Theme">
+  <a:themeElements>
+    <a:clrScheme name="Office">
+      <a:dk1>
+        <a:sysClr val="windowText" lastClr="000000"/>
+      </a:dk1>
+      <a:lt1>
+        <a:sysClr val="window" lastClr="FFFFFF"/>
+      </a:lt1>
+      <a:dk2>
+        <a:srgbClr val="0E2841"/>
+      </a:dk2>
+      <a:lt2>
+        <a:srgbClr val="E8E8E8"/>
+      </a:lt2>
+      <a:accent1>
+        <a:srgbClr val="156082"/>
+      </a:accent1>
+      <a:accent2>
+        <a:srgbClr val="E97132"/>
+      </a:accent2>
+      <a:accent3>
+        <a:srgbClr val="196B24"/>
+      </a:accent3>
+      <a:accent4>
+        <a:srgbClr val="0F9ED5"/>
+      </a:accent4>
+      <a:accent5>
+        <a:srgbClr val="A02B93"/>
+      </a:accent5>
+      <a:accent6>
+        <a:srgbClr val="4EA72E"/>
+      </a:accent6>
+      <a:hlink>
+        <a:srgbClr val="467886"/>
+      </a:hlink>
+      <a:folHlink>
+        <a:srgbClr val="96607D"/>
+      </a:folHlink>
+    </a:clrScheme>
+    <a:fontScheme name="Office">
+      <a:majorFont>
+        <a:latin typeface="Aptos Display" panose="02110004020202020204"/>
+        <a:ea typeface=""/>
+        <a:cs typeface=""/>
+        <a:font script="Jpan" typeface="游ゴシック Light"/>
+        <a:font script="Hang" typeface="맑은 고딕"/>
+        <a:font script="Hans" typeface="等线 Light"/>
+        <a:font script="Hant" typeface="新細明體"/>
+        <a:font script="Arab" typeface="Times New Roman"/>
+        <a:font script="Hebr" typeface="Times New Roman"/>
+        <a:font script="Thai" typeface="Angsana New"/>
+        <a:font script="Ethi" typeface="Nyala"/>
+        <a:font script="Beng" typeface="Vrinda"/>
+        <a:font script="Gujr" typeface="Shruti"/>
+        <a:font script="Khmr" typeface="MoolBoran"/>
+        <a:font script="Knda" typeface="Tunga"/>
+        <a:font script="Guru" typeface="Raavi"/>
+        <a:font script="Cans" typeface="Euphemia"/>
+        <a:font script="Cher" typeface="Plantagenet Cherokee"/>
+        <a:font script="Yiii" typeface="Microsoft Yi Baiti"/>
+        <a:font script="Tibt" typeface="Microsoft Himalaya"/>
+        <a:font script="Thaa" typeface="MV Boli"/>
+        <a:font script="Deva" typeface="Mangal"/>
+        <a:font script="Telu" typeface="Gautami"/>
+        <a:font script="Taml" typeface="Latha"/>
+        <a:font script="Syrc" typeface="Estrangelo Edessa"/>
+        <a:font script="Orya" typeface="Kalinga"/>
+        <a:font script="Mlym" typeface="Kartika"/>
+        <a:font script="Laoo" typeface="DokChampa"/>
+        <a:font script="Sinh" typeface="Iskoola Pota"/>
+        <a:font script="Mong" typeface="Mongolian Baiti"/>
+        <a:font script="Viet" typeface="Times New Roman"/>
+        <a:font script="Uigh" typeface="Microsoft Uighur"/>
+        <a:font script="Geor" typeface="Sylfaen"/>
+        <a:font script="Armn" typeface="Arial"/>
+        <a:font script="Bugi" typeface="Leelawadee UI"/>
+        <a:font script="Bopo" typeface="Microsoft JhengHei"/>
+        <a:font script="Java" typeface="Javanese Text"/>
+        <a:font script="Lisu" typeface="Segoe UI"/>
+        <a:font script="Mymr" typeface="Myanmar Text"/>
+        <a:font script="Nkoo" typeface="Ebrima"/>
+        <a:font script="Olck" typeface="Nirmala UI"/>
+        <a:font script="Osma" typeface="Ebrima"/>
+        <a:font script="Phag" typeface="Phagspa"/>
+        <a:font script="Syrn" typeface="Estrangelo Edessa"/>
+        <a:font script="Syrj" typeface="Estrangelo Edessa"/>
+        <a:font script="Syre" typeface="Estrangelo Edessa"/>
+        <a:font script="Sora" typeface="Nirmala UI"/>
+        <a:font script="Tale" typeface="Microsoft Tai Le"/>
+        <a:font script="Talu" typeface="Microsoft New Tai Lue"/>
+        <a:font script="Tfng" typeface="Ebrima"/>
+      </a:majorFont>
+      <a:minorFont>
+        <a:latin typeface="Aptos" panose="02110004020202020204"/>
+        <a:ea typeface=""/>
+        <a:cs typeface=""/>
+        <a:font script="Jpan" typeface="游ゴシック"/>
+        <a:font script="Hang" typeface="맑은 고딕"/>
+        <a:font script="Hans" typeface="等线"/>
+        <a:font script="Hant" typeface="新細明體"/>
+        <a:font script="Arab" typeface="Arial"/>
+        <a:font script="Hebr" typeface="Arial"/>
+        <a:font script="Thai" typeface="Cordia New"/>
+        <a:font script="Ethi" typeface="Nyala"/>
+        <a:font script="Beng" typeface="Vrinda"/>
+        <a:font script="Gujr" typeface="Shruti"/>
+        <a:font script="Khmr" typeface="DaunPenh"/>
+        <a:font script="Knda" typeface="Tunga"/>
+        <a:font script="Guru" typeface="Raavi"/>
+        <a:font script="Cans" typeface="Euphemia"/>
+        <a:font script="Cher" typeface="Plantagenet Cherokee"/>
+        <a:font script="Yiii" typeface="Microsoft Yi Baiti"/>
+        <a:font script="Tibt" typeface="Microsoft Himalaya"/>
+        <a:font script="Thaa" typeface="MV Boli"/>
+        <a:font script="Deva" typeface="Mangal"/>
+        <a:font script="Telu" typeface="Gautami"/>
+        <a:font script="Taml" typeface="Latha"/>
+        <a:font script="Syrc" typeface="Estrangelo Edessa"/>
+        <a:font script="Orya" typeface="Kalinga"/>
+        <a:font script="Mlym" typeface="Kartika"/>
+        <a:font script="Laoo" typeface="DokChampa"/>
+        <a:font script="Sinh" typeface="Iskoola Pota"/>
+        <a:font script="Mong" typeface="Mongolian Baiti"/>
+        <a:font script="Viet" typeface="Arial"/>
+        <a:font script="Uigh" typeface="Microsoft Uighur"/>
+        <a:font script="Geor" typeface="Sylfaen"/>
+        <a:font script="Armn" typeface="Arial"/>
+        <a:font script="Bugi" typeface="Leelawadee UI"/>
+        <a:font script="Bopo" typeface="Microsoft JhengHei"/>
+        <a:font script="Java" typeface="Javanese Text"/>
+        <a:font script="Lisu" typeface="Segoe UI"/>
+        <a:font script="Mymr" typeface="Myanmar Text"/>
+        <a:font script="Nkoo" typeface="Ebrima"/>
+        <a:font script="Olck" typeface="Nirmala UI"/>
+        <a:font script="Osma" typeface="Ebrima"/>
+        <a:font script="Phag" typeface="Phagspa"/>
+        <a:font script="Syrn" typeface="Estrangelo Edessa"/>
+        <a:font script="Syrj" typeface="Estrangelo Edessa"/>
+        <a:font script="Syre" typeface="Estrangelo Edessa"/>
+        <a:font script="Sora" typeface="Nirmala UI"/>
+        <a:font script="Tale" typeface="Microsoft Tai Le"/>
+        <a:font script="Talu" typeface="Microsoft New Tai Lue"/>
+        <a:font script="Tfng" typeface="Ebrima"/>
+      </a:minorFont>
+    </a:fontScheme>
+    <a:fmtScheme name="Office">
+      <a:fillStyleLst>
+        <a:solidFill>
+          <a:schemeClr val="phClr"/>
+        </a:solidFill>
+        <a:gradFill rotWithShape="1">
+          <a:gsLst>
+            <a:gs pos="0">
+              <a:schemeClr val="phClr">
+                <a:lumMod val="110000"/>
+                <a:satMod val="105000"/>
+                <a:tint val="67000"/>
+              </a:schemeClr>
+            </a:gs>
+            <a:gs pos="50000">
+              <a:schemeClr val="phClr">
+                <a:lumMod val="105000"/>
+                <a:satMod val="103000"/>
+                <a:tint val="73000"/>
+              </a:schemeClr>
+            </a:gs>
+            <a:gs pos="100000">
+              <a:schemeClr val="phClr">
+                <a:lumMod val="105000"/>
+                <a:satMod val="109000"/>
+                <a:tint val="81000"/>
+              </a:schemeClr>
+            </a:gs>
+          </a:gsLst>
+          <a:lin ang="5400000" scaled="0"/>
+        </a:gradFill>
+        <a:gradFill rotWithShape="1">
+          <a:gsLst>
+            <a:gs pos="0">
+              <a:schemeClr val="phClr">
+                <a:satMod val="103000"/>
+                <a:lumMod val="102000"/>
+                <a:tint val="94000"/>
+              </a:schemeClr>
+            </a:gs>
+            <a:gs pos="50000">
+              <a:schemeClr val="phClr">
+                <a:satMod val="110000"/>
+                <a:lumMod val="100000"/>
+                <a:shade val="100000"/>
+              </a:schemeClr>
+            </a:gs>
+            <a:gs pos="100000">
+              <a:schemeClr val="phClr">
+                <a:lumMod val="99000"/>
+                <a:satMod val="120000"/>
+                <a:shade val="78000"/>
+              </a:schemeClr>
+            </a:gs>
+          </a:gsLst>
+          <a:lin ang="5400000" scaled="0"/>
+        </a:gradFill>
+      </a:fillStyleLst>
+      <a:lnStyleLst>
+        <a:ln w="12700" cap="flat" cmpd="sng" algn="ctr">
+          <a:solidFill>
+            <a:schemeClr val="phClr"/>
+          </a:solidFill>
+          <a:prstDash val="solid"/>
+          <a:miter lim="800000"/>
+        </a:ln>
+        <a:ln w="19050" cap="flat" cmpd="sng" algn="ctr">
+          <a:solidFill>
+            <a:schemeClr val="phClr"/>
+          </a:solidFill>
+          <a:prstDash val="solid"/>
+          <a:miter lim="800000"/>
+        </a:ln>
+        <a:ln w="25400" cap="flat" cmpd="sng" algn="ctr">
+          <a:solidFill>
+            <a:schemeClr val="phClr"/>
+          </a:solidFill>
+          <a:prstDash val="solid"/>
+          <a:miter lim="800000"/>
+        </a:ln>
+      </a:lnStyleLst>
+      <a:effectStyleLst>
+        <a:effectStyle>
+          <a:effectLst/>
+        </a:effectStyle>
+        <a:effectStyle>
+          <a:effectLst/>
+        </a:effectStyle>
+        <a:effectStyle>
+          <a:effectLst>
+            <a:outerShdw blurRad="57150" dist="19050" dir="5400000" algn="ctr" rotWithShape="0">
+              <a:srgbClr val="000000">
+                <a:alpha val="63000"/>
+              </a:srgbClr>
+            </a:outerShdw>
+          </a:effectLst>
+        </a:effectStyle>
+      </a:effectStyleLst>
+      <a:bgFillStyleLst>
+        <a:solidFill>
+          <a:schemeClr val="phClr"/>
+        </a:solidFill>
+        <a:solidFill>
+          <a:schemeClr val="phClr">
+            <a:tint val="95000"/>
+            <a:satMod val="170000"/>
+          </a:schemeClr>
+        </a:solidFill>
+        <a:gradFill rotWithShape="1">
+          <a:gsLst>
+            <a:gs pos="0">
+              <a:schemeClr val="phClr">
+                <a:tint val="93000"/>
+                <a:satMod val="150000"/>
+                <a:shade val="98000"/>
+                <a:lumMod val="102000"/>
+              </a:schemeClr>
+            </a:gs>
+            <a:gs pos="50000">
+              <a:schemeClr val="phClr">
+                <a:tint val="98000"/>
+                <a:satMod val="130000"/>
+                <a:shade val="90000"/>
+                <a:lumMod val="103000"/>
+              </a:schemeClr>
+            </a:gs>
+            <a:gs pos="100000">
+              <a:schemeClr val="phClr">
+                <a:shade val="63000"/>
+                <a:satMod val="120000"/>
+              </a:schemeClr>
+            </a:gs>
+          </a:gsLst>
+          <a:lin ang="5400000" scaled="0"/>
+        </a:gradFill>
+      </a:bgFillStyleLst>
+    </a:fmtScheme>
+  </a:themeElements>
+  <a:objectDefaults>
+    <a:lnDef>
+      <a:spPr/>
+      <a:bodyPr/>
+      <a:lstStyle/>
+      <a:style>
+        <a:lnRef idx="2">
+          <a:schemeClr val="accent1"/>
+        </a:lnRef>
+        <a:fillRef idx="0">
+          <a:schemeClr val="accent1"/>
+        </a:fillRef>
+        <a:effectRef idx="1">
+          <a:schemeClr val="accent1"/>
+        </a:effectRef>
+        <a:fontRef idx="minor">
+          <a:schemeClr val="tx1"/>
+        </a:fontRef>
+      </a:style>
+    </a:lnDef>
+  </a:objectDefaults>
+  <a:extraClrSchemeLst/>
+  <a:extLst>
+    <a:ext uri="{05A4C25C-085E-4340-85A3-A5531E510DB2}">
+      <thm15:themeFamily xmlns:thm15="http://schemas.microsoft.com/office/thememl/2012/main" name="Office Theme" id="{2E142A2C-CD16-42D6-873A-C26D2A0506FA}" vid="{1BDDFF52-6CD6-40A5-AB3C-68EB2F1E4D0A}"/>
+    </a:ext>
+  </a:extLst>
+</a:theme>
 </file>
</xml_diff>

<commit_message>
Corrige inconsistências da revisão: renumera tabela de entregáveis no README, adiciona .odt ao objetivos.md, remove referência a arquivo inexistente no Instrucoes_PowerPoint.md, corrige erro físico no PPTX (slides 7 e 8: 8 m/s -> 20 m/s), adiciona RELATORIO_REVISAO.md
</commit_message>
<xml_diff>
--- a/02_apresentacao/Apresentacao_Aula_IA.pptx
+++ b/02_apresentacao/Apresentacao_Aula_IA.pptx
@@ -1,5 +1,1396 @@
 
-<file path=ppt/presentation.xml><?xml version="1.0" encoding="utf-8"?>
+<file path=docProps\app.xml><?xml version="1.0" encoding="utf-8"?>
+<Properties xmlns="http://schemas.openxmlformats.org/officeDocument/2006/extended-properties" xmlns:vt="http://schemas.openxmlformats.org/officeDocument/2006/docPropsVTypes">
+  <TotalTime>0</TotalTime>
+  <Words>855</Words>
+  <Application>Microsoft Office PowerPoint</Application>
+  <PresentationFormat>Widescreen</PresentationFormat>
+  <Paragraphs>170</Paragraphs>
+  <Slides>14</Slides>
+  <Notes>14</Notes>
+  <HiddenSlides>0</HiddenSlides>
+  <MMClips>0</MMClips>
+  <ScaleCrop>false</ScaleCrop>
+  <HeadingPairs>
+    <vt:vector size="6" baseType="variant">
+      <vt:variant>
+        <vt:lpstr>Fonts Used</vt:lpstr>
+      </vt:variant>
+      <vt:variant>
+        <vt:i4>1</vt:i4>
+      </vt:variant>
+      <vt:variant>
+        <vt:lpstr>Theme</vt:lpstr>
+      </vt:variant>
+      <vt:variant>
+        <vt:i4>1</vt:i4>
+      </vt:variant>
+      <vt:variant>
+        <vt:lpstr>Slide Titles</vt:lpstr>
+      </vt:variant>
+      <vt:variant>
+        <vt:i4>14</vt:i4>
+      </vt:variant>
+    </vt:vector>
+  </HeadingPairs>
+  <TitlesOfParts>
+    <vt:vector size="16" baseType="lpstr">
+      <vt:lpstr>Arial</vt:lpstr>
+      <vt:lpstr>Office Theme</vt:lpstr>
+      <vt:lpstr>PowerPoint Presentation</vt:lpstr>
+      <vt:lpstr>PowerPoint Presentation</vt:lpstr>
+      <vt:lpstr>PowerPoint Presentation</vt:lpstr>
+      <vt:lpstr>PowerPoint Presentation</vt:lpstr>
+      <vt:lpstr>PowerPoint Presentation</vt:lpstr>
+      <vt:lpstr>PowerPoint Presentation</vt:lpstr>
+      <vt:lpstr>PowerPoint Presentation</vt:lpstr>
+      <vt:lpstr>PowerPoint Presentation</vt:lpstr>
+      <vt:lpstr>PowerPoint Presentation</vt:lpstr>
+      <vt:lpstr>PowerPoint Presentation</vt:lpstr>
+      <vt:lpstr>PowerPoint Presentation</vt:lpstr>
+      <vt:lpstr>PowerPoint Presentation</vt:lpstr>
+      <vt:lpstr>PowerPoint Presentation</vt:lpstr>
+      <vt:lpstr>PowerPoint Presentation</vt:lpstr>
+    </vt:vector>
+  </TitlesOfParts>
+  <Company>PptxGenJS</Company>
+  <LinksUpToDate>false</LinksUpToDate>
+  <SharedDoc>false</SharedDoc>
+  <HyperlinksChanged>false</HyperlinksChanged>
+  <AppVersion>16.0000</AppVersion>
+</Properties>
+</file>
+
+<file path=docProps\core.xml><?xml version="1.0" encoding="utf-8"?>
+<cp:coreProperties xmlns:cp="http://schemas.openxmlformats.org/package/2006/metadata/core-properties" xmlns:dc="http://purl.org/dc/elements/1.1/" xmlns:dcterms="http://purl.org/dc/terms/" xmlns:dcmitype="http://purl.org/dc/dcmitype/" xmlns:xsi="http://www.w3.org/2001/XMLSchema-instance">
+  <dc:title>Quantidade de Movimento</dc:title>
+  <dc:subject>PptxGenJS Presentation</dc:subject>
+  <dc:creator>Victor Palmeira</dc:creator>
+  <cp:lastModifiedBy>victordiaspalmeira@gmail.com</cp:lastModifiedBy>
+  <cp:revision>3</cp:revision>
+  <dcterms:created xsi:type="dcterms:W3CDTF">2026-10-23T15:15:20Z</dcterms:created>
+  <dcterms:modified xsi:type="dcterms:W3CDTF">2026-10-23T23:03:18Z</dcterms:modified>
+</cp:coreProperties>
+</file>
+
+<file path=ppt\notesMasters\notesMaster1.xml><?xml version="1.0" encoding="utf-8"?>
+<p:notesMaster xmlns:a="http://schemas.openxmlformats.org/drawingml/2006/main" xmlns:r="http://schemas.openxmlformats.org/officeDocument/2006/relationships" xmlns:p="http://schemas.openxmlformats.org/presentationml/2006/main">
+  <p:cSld>
+    <p:bg>
+      <p:bgRef idx="1001">
+        <a:schemeClr val="bg1"/>
+      </p:bgRef>
+    </p:bg>
+    <p:spTree>
+      <p:nvGrpSpPr>
+        <p:cNvPr id="1" name=""/>
+        <p:cNvGrpSpPr/>
+        <p:nvPr/>
+      </p:nvGrpSpPr>
+      <p:grpSpPr>
+        <a:xfrm>
+          <a:off x="0" y="0"/>
+          <a:ext cx="0" cy="0"/>
+          <a:chOff x="0" y="0"/>
+          <a:chExt cx="0" cy="0"/>
+        </a:xfrm>
+      </p:grpSpPr>
+    </p:spTree>
+    <p:extLst>
+      <p:ext uri="{BB962C8B-B14F-4D97-AF65-F5344CB8AC3E}">
+        <p14:creationId xmlns:p14="http://schemas.microsoft.com/office/powerpoint/2010/main" val="1673730796"/>
+      </p:ext>
+    </p:extLst>
+  </p:cSld>
+  <p:clrMap bg1="lt1" tx1="dk1" bg2="lt2" tx2="dk2" accent1="accent1" accent2="accent2" accent3="accent3" accent4="accent4" accent5="accent5" accent6="accent6" hlink="hlink" folHlink="folHlink"/>
+  <p:notesStyle>
+    <a:lvl1pPr marL="0" algn="l" defTabSz="914400" rtl="0" eaLnBrk="1" latinLnBrk="0" hangingPunct="1">
+      <a:defRPr sz="1200" kern="1200">
+        <a:solidFill>
+          <a:schemeClr val="tx1"/>
+        </a:solidFill>
+        <a:latin typeface="+mn-lt"/>
+        <a:ea typeface="+mn-ea"/>
+        <a:cs typeface="+mn-cs"/>
+      </a:defRPr>
+    </a:lvl1pPr>
+    <a:lvl2pPr marL="457200" algn="l" defTabSz="914400" rtl="0" eaLnBrk="1" latinLnBrk="0" hangingPunct="1">
+      <a:defRPr sz="1200" kern="1200">
+        <a:solidFill>
+          <a:schemeClr val="tx1"/>
+        </a:solidFill>
+        <a:latin typeface="+mn-lt"/>
+        <a:ea typeface="+mn-ea"/>
+        <a:cs typeface="+mn-cs"/>
+      </a:defRPr>
+    </a:lvl2pPr>
+    <a:lvl3pPr marL="914400" algn="l" defTabSz="914400" rtl="0" eaLnBrk="1" latinLnBrk="0" hangingPunct="1">
+      <a:defRPr sz="1200" kern="1200">
+        <a:solidFill>
+          <a:schemeClr val="tx1"/>
+        </a:solidFill>
+        <a:latin typeface="+mn-lt"/>
+        <a:ea typeface="+mn-ea"/>
+        <a:cs typeface="+mn-cs"/>
+      </a:defRPr>
+    </a:lvl3pPr>
+    <a:lvl4pPr marL="1371600" algn="l" defTabSz="914400" rtl="0" eaLnBrk="1" latinLnBrk="0" hangingPunct="1">
+      <a:defRPr sz="1200" kern="1200">
+        <a:solidFill>
+          <a:schemeClr val="tx1"/>
+        </a:solidFill>
+        <a:latin typeface="+mn-lt"/>
+        <a:ea typeface="+mn-ea"/>
+        <a:cs typeface="+mn-cs"/>
+      </a:defRPr>
+    </a:lvl4pPr>
+    <a:lvl5pPr marL="1828800" algn="l" defTabSz="914400" rtl="0" eaLnBrk="1" latinLnBrk="0" hangingPunct="1">
+      <a:defRPr sz="1200" kern="1200">
+        <a:solidFill>
+          <a:schemeClr val="tx1"/>
+        </a:solidFill>
+        <a:latin typeface="+mn-lt"/>
+        <a:ea typeface="+mn-ea"/>
+        <a:cs typeface="+mn-cs"/>
+      </a:defRPr>
+    </a:lvl5pPr>
+    <a:lvl6pPr marL="2286000" algn="l" defTabSz="914400" rtl="0" eaLnBrk="1" latinLnBrk="0" hangingPunct="1">
+      <a:defRPr sz="1200" kern="1200">
+        <a:solidFill>
+          <a:schemeClr val="tx1"/>
+        </a:solidFill>
+        <a:latin typeface="+mn-lt"/>
+        <a:ea typeface="+mn-ea"/>
+        <a:cs typeface="+mn-cs"/>
+      </a:defRPr>
+    </a:lvl6pPr>
+    <a:lvl7pPr marL="2743200" algn="l" defTabSz="914400" rtl="0" eaLnBrk="1" latinLnBrk="0" hangingPunct="1">
+      <a:defRPr sz="1200" kern="1200">
+        <a:solidFill>
+          <a:schemeClr val="tx1"/>
+        </a:solidFill>
+        <a:latin typeface="+mn-lt"/>
+        <a:ea typeface="+mn-ea"/>
+        <a:cs typeface="+mn-cs"/>
+      </a:defRPr>
+    </a:lvl7pPr>
+    <a:lvl8pPr marL="3200400" algn="l" defTabSz="914400" rtl="0" eaLnBrk="1" latinLnBrk="0" hangingPunct="1">
+      <a:defRPr sz="1200" kern="1200">
+        <a:solidFill>
+          <a:schemeClr val="tx1"/>
+        </a:solidFill>
+        <a:latin typeface="+mn-lt"/>
+        <a:ea typeface="+mn-ea"/>
+        <a:cs typeface="+mn-cs"/>
+      </a:defRPr>
+    </a:lvl8pPr>
+    <a:lvl9pPr marL="3657600" algn="l" defTabSz="914400" rtl="0" eaLnBrk="1" latinLnBrk="0" hangingPunct="1">
+      <a:defRPr sz="1200" kern="1200">
+        <a:solidFill>
+          <a:schemeClr val="tx1"/>
+        </a:solidFill>
+        <a:latin typeface="+mn-lt"/>
+        <a:ea typeface="+mn-ea"/>
+        <a:cs typeface="+mn-cs"/>
+      </a:defRPr>
+    </a:lvl9pPr>
+  </p:notesStyle>
+</p:notesMaster>
+</file>
+
+<file path=ppt\notesSlides\notesSlide1.xml><?xml version="1.0" encoding="utf-8"?>
+<p:notes xmlns:a="http://schemas.openxmlformats.org/drawingml/2006/main" xmlns:r="http://schemas.openxmlformats.org/officeDocument/2006/relationships" xmlns:p="http://schemas.openxmlformats.org/presentationml/2006/main">
+  <p:cSld>
+    <p:spTree>
+      <p:nvGrpSpPr>
+        <p:cNvPr id="1" name=""/>
+        <p:cNvGrpSpPr/>
+        <p:nvPr/>
+      </p:nvGrpSpPr>
+      <p:grpSpPr>
+        <a:xfrm>
+          <a:off x="0" y="0"/>
+          <a:ext cx="0" cy="0"/>
+          <a:chOff x="0" y="0"/>
+          <a:chExt cx="0" cy="0"/>
+        </a:xfrm>
+      </p:grpSpPr>
+      <p:sp>
+        <p:nvSpPr>
+          <p:cNvPr id="2" name="Slide Image Placeholder 1"/>
+          <p:cNvSpPr>
+            <a:spLocks noGrp="1" noRot="1" noChangeAspect="1"/>
+          </p:cNvSpPr>
+          <p:nvPr>
+            <p:ph type="sldImg"/>
+          </p:nvPr>
+        </p:nvSpPr>
+        <p:spPr/>
+      </p:sp>
+      <p:sp>
+        <p:nvSpPr>
+          <p:cNvPr id="3" name="Notes Placeholder 2"/>
+          <p:cNvSpPr>
+            <a:spLocks noGrp="1"/>
+          </p:cNvSpPr>
+          <p:nvPr>
+            <p:ph type="body" idx="1"/>
+          </p:nvPr>
+        </p:nvSpPr>
+        <p:spPr/>
+        <p:txBody>
+          <a:bodyPr/>
+          <a:lstStyle/>
+          <a:p>
+            <a:endParaRPr lang="en-US" dirty="0"/>
+          </a:p>
+        </p:txBody>
+      </p:sp>
+      <p:sp>
+        <p:nvSpPr>
+          <p:cNvPr id="4" name="Slide Number Placeholder 3"/>
+          <p:cNvSpPr>
+            <a:spLocks noGrp="1"/>
+          </p:cNvSpPr>
+          <p:nvPr>
+            <p:ph type="sldNum" sz="quarter" idx="10"/>
+          </p:nvPr>
+        </p:nvSpPr>
+        <p:spPr/>
+        <p:txBody>
+          <a:bodyPr/>
+          <a:lstStyle/>
+          <a:p>
+            <a:fld id="{F7021451-1387-4CA6-816F-3879F97B5CBC}" type="slidenum">
+              <a:rPr lang="en-US"/>
+              <a:t>1</a:t>
+            </a:fld>
+            <a:endParaRPr lang="en-US"/>
+          </a:p>
+        </p:txBody>
+      </p:sp>
+    </p:spTree>
+    <p:extLst>
+      <p:ext uri="{BB962C8B-B14F-4D97-AF65-F5344CB8AC3E}">
+        <p14:creationId xmlns:p14="http://schemas.microsoft.com/office/powerpoint/2010/main" val="1024086991"/>
+      </p:ext>
+    </p:extLst>
+  </p:cSld>
+  <p:clrMapOvr>
+    <a:masterClrMapping/>
+  </p:clrMapOvr>
+</p:notes>
+</file>
+
+<file path=ppt\notesSlides\notesSlide10.xml><?xml version="1.0" encoding="utf-8"?>
+<p:notes xmlns:a="http://schemas.openxmlformats.org/drawingml/2006/main" xmlns:r="http://schemas.openxmlformats.org/officeDocument/2006/relationships" xmlns:p="http://schemas.openxmlformats.org/presentationml/2006/main">
+  <p:cSld>
+    <p:spTree>
+      <p:nvGrpSpPr>
+        <p:cNvPr id="1" name=""/>
+        <p:cNvGrpSpPr/>
+        <p:nvPr/>
+      </p:nvGrpSpPr>
+      <p:grpSpPr>
+        <a:xfrm>
+          <a:off x="0" y="0"/>
+          <a:ext cx="0" cy="0"/>
+          <a:chOff x="0" y="0"/>
+          <a:chExt cx="0" cy="0"/>
+        </a:xfrm>
+      </p:grpSpPr>
+      <p:sp>
+        <p:nvSpPr>
+          <p:cNvPr id="2" name="Slide Image Placeholder 1"/>
+          <p:cNvSpPr>
+            <a:spLocks noGrp="1" noRot="1" noChangeAspect="1"/>
+          </p:cNvSpPr>
+          <p:nvPr>
+            <p:ph type="sldImg"/>
+          </p:nvPr>
+        </p:nvSpPr>
+        <p:spPr/>
+      </p:sp>
+      <p:sp>
+        <p:nvSpPr>
+          <p:cNvPr id="3" name="Notes Placeholder 2"/>
+          <p:cNvSpPr>
+            <a:spLocks noGrp="1"/>
+          </p:cNvSpPr>
+          <p:nvPr>
+            <p:ph type="body" idx="1"/>
+          </p:nvPr>
+        </p:nvSpPr>
+        <p:spPr/>
+        <p:txBody>
+          <a:bodyPr/>
+          <a:lstStyle/>
+          <a:p>
+            <a:endParaRPr lang="en-US" dirty="0"/>
+          </a:p>
+        </p:txBody>
+      </p:sp>
+      <p:sp>
+        <p:nvSpPr>
+          <p:cNvPr id="4" name="Slide Number Placeholder 3"/>
+          <p:cNvSpPr>
+            <a:spLocks noGrp="1"/>
+          </p:cNvSpPr>
+          <p:nvPr>
+            <p:ph type="sldNum" sz="quarter" idx="10"/>
+          </p:nvPr>
+        </p:nvSpPr>
+        <p:spPr/>
+        <p:txBody>
+          <a:bodyPr/>
+          <a:lstStyle/>
+          <a:p>
+            <a:fld id="{F7021451-1387-4CA6-816F-3879F97B5CBC}" type="slidenum">
+              <a:rPr lang="en-US"/>
+              <a:t>10</a:t>
+            </a:fld>
+            <a:endParaRPr lang="en-US"/>
+          </a:p>
+        </p:txBody>
+      </p:sp>
+    </p:spTree>
+    <p:extLst>
+      <p:ext uri="{BB962C8B-B14F-4D97-AF65-F5344CB8AC3E}">
+        <p14:creationId xmlns:p14="http://schemas.microsoft.com/office/powerpoint/2010/main" val="1024086991"/>
+      </p:ext>
+    </p:extLst>
+  </p:cSld>
+  <p:clrMapOvr>
+    <a:masterClrMapping/>
+  </p:clrMapOvr>
+</p:notes>
+</file>
+
+<file path=ppt\notesSlides\notesSlide11.xml><?xml version="1.0" encoding="utf-8"?>
+<p:notes xmlns:a="http://schemas.openxmlformats.org/drawingml/2006/main" xmlns:r="http://schemas.openxmlformats.org/officeDocument/2006/relationships" xmlns:p="http://schemas.openxmlformats.org/presentationml/2006/main">
+  <p:cSld>
+    <p:spTree>
+      <p:nvGrpSpPr>
+        <p:cNvPr id="1" name=""/>
+        <p:cNvGrpSpPr/>
+        <p:nvPr/>
+      </p:nvGrpSpPr>
+      <p:grpSpPr>
+        <a:xfrm>
+          <a:off x="0" y="0"/>
+          <a:ext cx="0" cy="0"/>
+          <a:chOff x="0" y="0"/>
+          <a:chExt cx="0" cy="0"/>
+        </a:xfrm>
+      </p:grpSpPr>
+      <p:sp>
+        <p:nvSpPr>
+          <p:cNvPr id="2" name="Slide Image Placeholder 1"/>
+          <p:cNvSpPr>
+            <a:spLocks noGrp="1" noRot="1" noChangeAspect="1"/>
+          </p:cNvSpPr>
+          <p:nvPr>
+            <p:ph type="sldImg"/>
+          </p:nvPr>
+        </p:nvSpPr>
+        <p:spPr/>
+      </p:sp>
+      <p:sp>
+        <p:nvSpPr>
+          <p:cNvPr id="3" name="Notes Placeholder 2"/>
+          <p:cNvSpPr>
+            <a:spLocks noGrp="1"/>
+          </p:cNvSpPr>
+          <p:nvPr>
+            <p:ph type="body" idx="1"/>
+          </p:nvPr>
+        </p:nvSpPr>
+        <p:spPr/>
+        <p:txBody>
+          <a:bodyPr/>
+          <a:lstStyle/>
+          <a:p>
+            <a:endParaRPr lang="en-US" dirty="0"/>
+          </a:p>
+        </p:txBody>
+      </p:sp>
+      <p:sp>
+        <p:nvSpPr>
+          <p:cNvPr id="4" name="Slide Number Placeholder 3"/>
+          <p:cNvSpPr>
+            <a:spLocks noGrp="1"/>
+          </p:cNvSpPr>
+          <p:nvPr>
+            <p:ph type="sldNum" sz="quarter" idx="10"/>
+          </p:nvPr>
+        </p:nvSpPr>
+        <p:spPr/>
+        <p:txBody>
+          <a:bodyPr/>
+          <a:lstStyle/>
+          <a:p>
+            <a:fld id="{F7021451-1387-4CA6-816F-3879F97B5CBC}" type="slidenum">
+              <a:rPr lang="en-US"/>
+              <a:t>11</a:t>
+            </a:fld>
+            <a:endParaRPr lang="en-US"/>
+          </a:p>
+        </p:txBody>
+      </p:sp>
+    </p:spTree>
+    <p:extLst>
+      <p:ext uri="{BB962C8B-B14F-4D97-AF65-F5344CB8AC3E}">
+        <p14:creationId xmlns:p14="http://schemas.microsoft.com/office/powerpoint/2010/main" val="1024086991"/>
+      </p:ext>
+    </p:extLst>
+  </p:cSld>
+  <p:clrMapOvr>
+    <a:masterClrMapping/>
+  </p:clrMapOvr>
+</p:notes>
+</file>
+
+<file path=ppt\notesSlides\notesSlide12.xml><?xml version="1.0" encoding="utf-8"?>
+<p:notes xmlns:a="http://schemas.openxmlformats.org/drawingml/2006/main" xmlns:r="http://schemas.openxmlformats.org/officeDocument/2006/relationships" xmlns:p="http://schemas.openxmlformats.org/presentationml/2006/main">
+  <p:cSld>
+    <p:spTree>
+      <p:nvGrpSpPr>
+        <p:cNvPr id="1" name=""/>
+        <p:cNvGrpSpPr/>
+        <p:nvPr/>
+      </p:nvGrpSpPr>
+      <p:grpSpPr>
+        <a:xfrm>
+          <a:off x="0" y="0"/>
+          <a:ext cx="0" cy="0"/>
+          <a:chOff x="0" y="0"/>
+          <a:chExt cx="0" cy="0"/>
+        </a:xfrm>
+      </p:grpSpPr>
+      <p:sp>
+        <p:nvSpPr>
+          <p:cNvPr id="2" name="Slide Image Placeholder 1"/>
+          <p:cNvSpPr>
+            <a:spLocks noGrp="1" noRot="1" noChangeAspect="1"/>
+          </p:cNvSpPr>
+          <p:nvPr>
+            <p:ph type="sldImg"/>
+          </p:nvPr>
+        </p:nvSpPr>
+        <p:spPr/>
+      </p:sp>
+      <p:sp>
+        <p:nvSpPr>
+          <p:cNvPr id="3" name="Notes Placeholder 2"/>
+          <p:cNvSpPr>
+            <a:spLocks noGrp="1"/>
+          </p:cNvSpPr>
+          <p:nvPr>
+            <p:ph type="body" idx="1"/>
+          </p:nvPr>
+        </p:nvSpPr>
+        <p:spPr/>
+        <p:txBody>
+          <a:bodyPr/>
+          <a:lstStyle/>
+          <a:p>
+            <a:endParaRPr lang="en-US" dirty="0"/>
+          </a:p>
+        </p:txBody>
+      </p:sp>
+      <p:sp>
+        <p:nvSpPr>
+          <p:cNvPr id="4" name="Slide Number Placeholder 3"/>
+          <p:cNvSpPr>
+            <a:spLocks noGrp="1"/>
+          </p:cNvSpPr>
+          <p:nvPr>
+            <p:ph type="sldNum" sz="quarter" idx="10"/>
+          </p:nvPr>
+        </p:nvSpPr>
+        <p:spPr/>
+        <p:txBody>
+          <a:bodyPr/>
+          <a:lstStyle/>
+          <a:p>
+            <a:fld id="{F7021451-1387-4CA6-816F-3879F97B5CBC}" type="slidenum">
+              <a:rPr lang="en-US"/>
+              <a:t>12</a:t>
+            </a:fld>
+            <a:endParaRPr lang="en-US"/>
+          </a:p>
+        </p:txBody>
+      </p:sp>
+    </p:spTree>
+    <p:extLst>
+      <p:ext uri="{BB962C8B-B14F-4D97-AF65-F5344CB8AC3E}">
+        <p14:creationId xmlns:p14="http://schemas.microsoft.com/office/powerpoint/2010/main" val="1024086991"/>
+      </p:ext>
+    </p:extLst>
+  </p:cSld>
+  <p:clrMapOvr>
+    <a:masterClrMapping/>
+  </p:clrMapOvr>
+</p:notes>
+</file>
+
+<file path=ppt\notesSlides\notesSlide13.xml><?xml version="1.0" encoding="utf-8"?>
+<p:notes xmlns:a="http://schemas.openxmlformats.org/drawingml/2006/main" xmlns:r="http://schemas.openxmlformats.org/officeDocument/2006/relationships" xmlns:p="http://schemas.openxmlformats.org/presentationml/2006/main">
+  <p:cSld>
+    <p:spTree>
+      <p:nvGrpSpPr>
+        <p:cNvPr id="1" name=""/>
+        <p:cNvGrpSpPr/>
+        <p:nvPr/>
+      </p:nvGrpSpPr>
+      <p:grpSpPr>
+        <a:xfrm>
+          <a:off x="0" y="0"/>
+          <a:ext cx="0" cy="0"/>
+          <a:chOff x="0" y="0"/>
+          <a:chExt cx="0" cy="0"/>
+        </a:xfrm>
+      </p:grpSpPr>
+      <p:sp>
+        <p:nvSpPr>
+          <p:cNvPr id="2" name="Slide Image Placeholder 1"/>
+          <p:cNvSpPr>
+            <a:spLocks noGrp="1" noRot="1" noChangeAspect="1"/>
+          </p:cNvSpPr>
+          <p:nvPr>
+            <p:ph type="sldImg"/>
+          </p:nvPr>
+        </p:nvSpPr>
+        <p:spPr/>
+      </p:sp>
+      <p:sp>
+        <p:nvSpPr>
+          <p:cNvPr id="3" name="Notes Placeholder 2"/>
+          <p:cNvSpPr>
+            <a:spLocks noGrp="1"/>
+          </p:cNvSpPr>
+          <p:nvPr>
+            <p:ph type="body" idx="1"/>
+          </p:nvPr>
+        </p:nvSpPr>
+        <p:spPr/>
+        <p:txBody>
+          <a:bodyPr/>
+          <a:lstStyle/>
+          <a:p>
+            <a:endParaRPr lang="en-US" dirty="0"/>
+          </a:p>
+        </p:txBody>
+      </p:sp>
+      <p:sp>
+        <p:nvSpPr>
+          <p:cNvPr id="4" name="Slide Number Placeholder 3"/>
+          <p:cNvSpPr>
+            <a:spLocks noGrp="1"/>
+          </p:cNvSpPr>
+          <p:nvPr>
+            <p:ph type="sldNum" sz="quarter" idx="10"/>
+          </p:nvPr>
+        </p:nvSpPr>
+        <p:spPr/>
+        <p:txBody>
+          <a:bodyPr/>
+          <a:lstStyle/>
+          <a:p>
+            <a:fld id="{F7021451-1387-4CA6-816F-3879F97B5CBC}" type="slidenum">
+              <a:rPr lang="en-US"/>
+              <a:t>13</a:t>
+            </a:fld>
+            <a:endParaRPr lang="en-US"/>
+          </a:p>
+        </p:txBody>
+      </p:sp>
+    </p:spTree>
+    <p:extLst>
+      <p:ext uri="{BB962C8B-B14F-4D97-AF65-F5344CB8AC3E}">
+        <p14:creationId xmlns:p14="http://schemas.microsoft.com/office/powerpoint/2010/main" val="1024086991"/>
+      </p:ext>
+    </p:extLst>
+  </p:cSld>
+  <p:clrMapOvr>
+    <a:masterClrMapping/>
+  </p:clrMapOvr>
+</p:notes>
+</file>
+
+<file path=ppt\notesSlides\notesSlide14.xml><?xml version="1.0" encoding="utf-8"?>
+<p:notes xmlns:a="http://schemas.openxmlformats.org/drawingml/2006/main" xmlns:r="http://schemas.openxmlformats.org/officeDocument/2006/relationships" xmlns:p="http://schemas.openxmlformats.org/presentationml/2006/main">
+  <p:cSld>
+    <p:spTree>
+      <p:nvGrpSpPr>
+        <p:cNvPr id="1" name=""/>
+        <p:cNvGrpSpPr/>
+        <p:nvPr/>
+      </p:nvGrpSpPr>
+      <p:grpSpPr>
+        <a:xfrm>
+          <a:off x="0" y="0"/>
+          <a:ext cx="0" cy="0"/>
+          <a:chOff x="0" y="0"/>
+          <a:chExt cx="0" cy="0"/>
+        </a:xfrm>
+      </p:grpSpPr>
+      <p:sp>
+        <p:nvSpPr>
+          <p:cNvPr id="2" name="Slide Image Placeholder 1"/>
+          <p:cNvSpPr>
+            <a:spLocks noGrp="1" noRot="1" noChangeAspect="1"/>
+          </p:cNvSpPr>
+          <p:nvPr>
+            <p:ph type="sldImg"/>
+          </p:nvPr>
+        </p:nvSpPr>
+        <p:spPr/>
+      </p:sp>
+      <p:sp>
+        <p:nvSpPr>
+          <p:cNvPr id="3" name="Notes Placeholder 2"/>
+          <p:cNvSpPr>
+            <a:spLocks noGrp="1"/>
+          </p:cNvSpPr>
+          <p:nvPr>
+            <p:ph type="body" idx="1"/>
+          </p:nvPr>
+        </p:nvSpPr>
+        <p:spPr/>
+        <p:txBody>
+          <a:bodyPr/>
+          <a:lstStyle/>
+          <a:p>
+            <a:endParaRPr lang="en-US" dirty="0"/>
+          </a:p>
+        </p:txBody>
+      </p:sp>
+      <p:sp>
+        <p:nvSpPr>
+          <p:cNvPr id="4" name="Slide Number Placeholder 3"/>
+          <p:cNvSpPr>
+            <a:spLocks noGrp="1"/>
+          </p:cNvSpPr>
+          <p:nvPr>
+            <p:ph type="sldNum" sz="quarter" idx="10"/>
+          </p:nvPr>
+        </p:nvSpPr>
+        <p:spPr/>
+        <p:txBody>
+          <a:bodyPr/>
+          <a:lstStyle/>
+          <a:p>
+            <a:fld id="{F7021451-1387-4CA6-816F-3879F97B5CBC}" type="slidenum">
+              <a:rPr lang="en-US"/>
+              <a:t>14</a:t>
+            </a:fld>
+            <a:endParaRPr lang="en-US"/>
+          </a:p>
+        </p:txBody>
+      </p:sp>
+    </p:spTree>
+    <p:extLst>
+      <p:ext uri="{BB962C8B-B14F-4D97-AF65-F5344CB8AC3E}">
+        <p14:creationId xmlns:p14="http://schemas.microsoft.com/office/powerpoint/2010/main" val="1024086991"/>
+      </p:ext>
+    </p:extLst>
+  </p:cSld>
+  <p:clrMapOvr>
+    <a:masterClrMapping/>
+  </p:clrMapOvr>
+</p:notes>
+</file>
+
+<file path=ppt\notesSlides\notesSlide2.xml><?xml version="1.0" encoding="utf-8"?>
+<p:notes xmlns:a="http://schemas.openxmlformats.org/drawingml/2006/main" xmlns:r="http://schemas.openxmlformats.org/officeDocument/2006/relationships" xmlns:p="http://schemas.openxmlformats.org/presentationml/2006/main">
+  <p:cSld>
+    <p:spTree>
+      <p:nvGrpSpPr>
+        <p:cNvPr id="1" name=""/>
+        <p:cNvGrpSpPr/>
+        <p:nvPr/>
+      </p:nvGrpSpPr>
+      <p:grpSpPr>
+        <a:xfrm>
+          <a:off x="0" y="0"/>
+          <a:ext cx="0" cy="0"/>
+          <a:chOff x="0" y="0"/>
+          <a:chExt cx="0" cy="0"/>
+        </a:xfrm>
+      </p:grpSpPr>
+      <p:sp>
+        <p:nvSpPr>
+          <p:cNvPr id="2" name="Slide Image Placeholder 1"/>
+          <p:cNvSpPr>
+            <a:spLocks noGrp="1" noRot="1" noChangeAspect="1"/>
+          </p:cNvSpPr>
+          <p:nvPr>
+            <p:ph type="sldImg"/>
+          </p:nvPr>
+        </p:nvSpPr>
+        <p:spPr/>
+      </p:sp>
+      <p:sp>
+        <p:nvSpPr>
+          <p:cNvPr id="3" name="Notes Placeholder 2"/>
+          <p:cNvSpPr>
+            <a:spLocks noGrp="1"/>
+          </p:cNvSpPr>
+          <p:nvPr>
+            <p:ph type="body" idx="1"/>
+          </p:nvPr>
+        </p:nvSpPr>
+        <p:spPr/>
+        <p:txBody>
+          <a:bodyPr/>
+          <a:lstStyle/>
+          <a:p>
+            <a:endParaRPr lang="en-US" dirty="0"/>
+          </a:p>
+        </p:txBody>
+      </p:sp>
+      <p:sp>
+        <p:nvSpPr>
+          <p:cNvPr id="4" name="Slide Number Placeholder 3"/>
+          <p:cNvSpPr>
+            <a:spLocks noGrp="1"/>
+          </p:cNvSpPr>
+          <p:nvPr>
+            <p:ph type="sldNum" sz="quarter" idx="10"/>
+          </p:nvPr>
+        </p:nvSpPr>
+        <p:spPr/>
+        <p:txBody>
+          <a:bodyPr/>
+          <a:lstStyle/>
+          <a:p>
+            <a:fld id="{F7021451-1387-4CA6-816F-3879F97B5CBC}" type="slidenum">
+              <a:rPr lang="en-US"/>
+              <a:t>2</a:t>
+            </a:fld>
+            <a:endParaRPr lang="en-US"/>
+          </a:p>
+        </p:txBody>
+      </p:sp>
+    </p:spTree>
+    <p:extLst>
+      <p:ext uri="{BB962C8B-B14F-4D97-AF65-F5344CB8AC3E}">
+        <p14:creationId xmlns:p14="http://schemas.microsoft.com/office/powerpoint/2010/main" val="1024086991"/>
+      </p:ext>
+    </p:extLst>
+  </p:cSld>
+  <p:clrMapOvr>
+    <a:masterClrMapping/>
+  </p:clrMapOvr>
+</p:notes>
+</file>
+
+<file path=ppt\notesSlides\notesSlide3.xml><?xml version="1.0" encoding="utf-8"?>
+<p:notes xmlns:a="http://schemas.openxmlformats.org/drawingml/2006/main" xmlns:r="http://schemas.openxmlformats.org/officeDocument/2006/relationships" xmlns:p="http://schemas.openxmlformats.org/presentationml/2006/main">
+  <p:cSld>
+    <p:spTree>
+      <p:nvGrpSpPr>
+        <p:cNvPr id="1" name=""/>
+        <p:cNvGrpSpPr/>
+        <p:nvPr/>
+      </p:nvGrpSpPr>
+      <p:grpSpPr>
+        <a:xfrm>
+          <a:off x="0" y="0"/>
+          <a:ext cx="0" cy="0"/>
+          <a:chOff x="0" y="0"/>
+          <a:chExt cx="0" cy="0"/>
+        </a:xfrm>
+      </p:grpSpPr>
+      <p:sp>
+        <p:nvSpPr>
+          <p:cNvPr id="2" name="Slide Image Placeholder 1"/>
+          <p:cNvSpPr>
+            <a:spLocks noGrp="1" noRot="1" noChangeAspect="1"/>
+          </p:cNvSpPr>
+          <p:nvPr>
+            <p:ph type="sldImg"/>
+          </p:nvPr>
+        </p:nvSpPr>
+        <p:spPr/>
+      </p:sp>
+      <p:sp>
+        <p:nvSpPr>
+          <p:cNvPr id="3" name="Notes Placeholder 2"/>
+          <p:cNvSpPr>
+            <a:spLocks noGrp="1"/>
+          </p:cNvSpPr>
+          <p:nvPr>
+            <p:ph type="body" idx="1"/>
+          </p:nvPr>
+        </p:nvSpPr>
+        <p:spPr/>
+        <p:txBody>
+          <a:bodyPr/>
+          <a:lstStyle/>
+          <a:p>
+            <a:endParaRPr lang="en-US" dirty="0"/>
+          </a:p>
+        </p:txBody>
+      </p:sp>
+      <p:sp>
+        <p:nvSpPr>
+          <p:cNvPr id="4" name="Slide Number Placeholder 3"/>
+          <p:cNvSpPr>
+            <a:spLocks noGrp="1"/>
+          </p:cNvSpPr>
+          <p:nvPr>
+            <p:ph type="sldNum" sz="quarter" idx="10"/>
+          </p:nvPr>
+        </p:nvSpPr>
+        <p:spPr/>
+        <p:txBody>
+          <a:bodyPr/>
+          <a:lstStyle/>
+          <a:p>
+            <a:fld id="{F7021451-1387-4CA6-816F-3879F97B5CBC}" type="slidenum">
+              <a:rPr lang="en-US"/>
+              <a:t>3</a:t>
+            </a:fld>
+            <a:endParaRPr lang="en-US"/>
+          </a:p>
+        </p:txBody>
+      </p:sp>
+    </p:spTree>
+    <p:extLst>
+      <p:ext uri="{BB962C8B-B14F-4D97-AF65-F5344CB8AC3E}">
+        <p14:creationId xmlns:p14="http://schemas.microsoft.com/office/powerpoint/2010/main" val="1024086991"/>
+      </p:ext>
+    </p:extLst>
+  </p:cSld>
+  <p:clrMapOvr>
+    <a:masterClrMapping/>
+  </p:clrMapOvr>
+</p:notes>
+</file>
+
+<file path=ppt\notesSlides\notesSlide4.xml><?xml version="1.0" encoding="utf-8"?>
+<p:notes xmlns:a="http://schemas.openxmlformats.org/drawingml/2006/main" xmlns:r="http://schemas.openxmlformats.org/officeDocument/2006/relationships" xmlns:p="http://schemas.openxmlformats.org/presentationml/2006/main">
+  <p:cSld>
+    <p:spTree>
+      <p:nvGrpSpPr>
+        <p:cNvPr id="1" name=""/>
+        <p:cNvGrpSpPr/>
+        <p:nvPr/>
+      </p:nvGrpSpPr>
+      <p:grpSpPr>
+        <a:xfrm>
+          <a:off x="0" y="0"/>
+          <a:ext cx="0" cy="0"/>
+          <a:chOff x="0" y="0"/>
+          <a:chExt cx="0" cy="0"/>
+        </a:xfrm>
+      </p:grpSpPr>
+      <p:sp>
+        <p:nvSpPr>
+          <p:cNvPr id="2" name="Slide Image Placeholder 1"/>
+          <p:cNvSpPr>
+            <a:spLocks noGrp="1" noRot="1" noChangeAspect="1"/>
+          </p:cNvSpPr>
+          <p:nvPr>
+            <p:ph type="sldImg"/>
+          </p:nvPr>
+        </p:nvSpPr>
+        <p:spPr/>
+      </p:sp>
+      <p:sp>
+        <p:nvSpPr>
+          <p:cNvPr id="3" name="Notes Placeholder 2"/>
+          <p:cNvSpPr>
+            <a:spLocks noGrp="1"/>
+          </p:cNvSpPr>
+          <p:nvPr>
+            <p:ph type="body" idx="1"/>
+          </p:nvPr>
+        </p:nvSpPr>
+        <p:spPr/>
+        <p:txBody>
+          <a:bodyPr/>
+          <a:lstStyle/>
+          <a:p>
+            <a:endParaRPr lang="en-US" dirty="0"/>
+          </a:p>
+        </p:txBody>
+      </p:sp>
+      <p:sp>
+        <p:nvSpPr>
+          <p:cNvPr id="4" name="Slide Number Placeholder 3"/>
+          <p:cNvSpPr>
+            <a:spLocks noGrp="1"/>
+          </p:cNvSpPr>
+          <p:nvPr>
+            <p:ph type="sldNum" sz="quarter" idx="10"/>
+          </p:nvPr>
+        </p:nvSpPr>
+        <p:spPr/>
+        <p:txBody>
+          <a:bodyPr/>
+          <a:lstStyle/>
+          <a:p>
+            <a:fld id="{F7021451-1387-4CA6-816F-3879F97B5CBC}" type="slidenum">
+              <a:rPr lang="en-US"/>
+              <a:t>4</a:t>
+            </a:fld>
+            <a:endParaRPr lang="en-US"/>
+          </a:p>
+        </p:txBody>
+      </p:sp>
+    </p:spTree>
+    <p:extLst>
+      <p:ext uri="{BB962C8B-B14F-4D97-AF65-F5344CB8AC3E}">
+        <p14:creationId xmlns:p14="http://schemas.microsoft.com/office/powerpoint/2010/main" val="1024086991"/>
+      </p:ext>
+    </p:extLst>
+  </p:cSld>
+  <p:clrMapOvr>
+    <a:masterClrMapping/>
+  </p:clrMapOvr>
+</p:notes>
+</file>
+
+<file path=ppt\notesSlides\notesSlide5.xml><?xml version="1.0" encoding="utf-8"?>
+<p:notes xmlns:a="http://schemas.openxmlformats.org/drawingml/2006/main" xmlns:r="http://schemas.openxmlformats.org/officeDocument/2006/relationships" xmlns:p="http://schemas.openxmlformats.org/presentationml/2006/main">
+  <p:cSld>
+    <p:spTree>
+      <p:nvGrpSpPr>
+        <p:cNvPr id="1" name=""/>
+        <p:cNvGrpSpPr/>
+        <p:nvPr/>
+      </p:nvGrpSpPr>
+      <p:grpSpPr>
+        <a:xfrm>
+          <a:off x="0" y="0"/>
+          <a:ext cx="0" cy="0"/>
+          <a:chOff x="0" y="0"/>
+          <a:chExt cx="0" cy="0"/>
+        </a:xfrm>
+      </p:grpSpPr>
+      <p:sp>
+        <p:nvSpPr>
+          <p:cNvPr id="2" name="Slide Image Placeholder 1"/>
+          <p:cNvSpPr>
+            <a:spLocks noGrp="1" noRot="1" noChangeAspect="1"/>
+          </p:cNvSpPr>
+          <p:nvPr>
+            <p:ph type="sldImg"/>
+          </p:nvPr>
+        </p:nvSpPr>
+        <p:spPr/>
+      </p:sp>
+      <p:sp>
+        <p:nvSpPr>
+          <p:cNvPr id="3" name="Notes Placeholder 2"/>
+          <p:cNvSpPr>
+            <a:spLocks noGrp="1"/>
+          </p:cNvSpPr>
+          <p:nvPr>
+            <p:ph type="body" idx="1"/>
+          </p:nvPr>
+        </p:nvSpPr>
+        <p:spPr/>
+        <p:txBody>
+          <a:bodyPr/>
+          <a:lstStyle/>
+          <a:p>
+            <a:endParaRPr lang="en-US" dirty="0"/>
+          </a:p>
+        </p:txBody>
+      </p:sp>
+      <p:sp>
+        <p:nvSpPr>
+          <p:cNvPr id="4" name="Slide Number Placeholder 3"/>
+          <p:cNvSpPr>
+            <a:spLocks noGrp="1"/>
+          </p:cNvSpPr>
+          <p:nvPr>
+            <p:ph type="sldNum" sz="quarter" idx="10"/>
+          </p:nvPr>
+        </p:nvSpPr>
+        <p:spPr/>
+        <p:txBody>
+          <a:bodyPr/>
+          <a:lstStyle/>
+          <a:p>
+            <a:fld id="{F7021451-1387-4CA6-816F-3879F97B5CBC}" type="slidenum">
+              <a:rPr lang="en-US"/>
+              <a:t>5</a:t>
+            </a:fld>
+            <a:endParaRPr lang="en-US"/>
+          </a:p>
+        </p:txBody>
+      </p:sp>
+    </p:spTree>
+    <p:extLst>
+      <p:ext uri="{BB962C8B-B14F-4D97-AF65-F5344CB8AC3E}">
+        <p14:creationId xmlns:p14="http://schemas.microsoft.com/office/powerpoint/2010/main" val="1024086991"/>
+      </p:ext>
+    </p:extLst>
+  </p:cSld>
+  <p:clrMapOvr>
+    <a:masterClrMapping/>
+  </p:clrMapOvr>
+</p:notes>
+</file>
+
+<file path=ppt\notesSlides\notesSlide6.xml><?xml version="1.0" encoding="utf-8"?>
+<p:notes xmlns:a="http://schemas.openxmlformats.org/drawingml/2006/main" xmlns:r="http://schemas.openxmlformats.org/officeDocument/2006/relationships" xmlns:p="http://schemas.openxmlformats.org/presentationml/2006/main">
+  <p:cSld>
+    <p:spTree>
+      <p:nvGrpSpPr>
+        <p:cNvPr id="1" name=""/>
+        <p:cNvGrpSpPr/>
+        <p:nvPr/>
+      </p:nvGrpSpPr>
+      <p:grpSpPr>
+        <a:xfrm>
+          <a:off x="0" y="0"/>
+          <a:ext cx="0" cy="0"/>
+          <a:chOff x="0" y="0"/>
+          <a:chExt cx="0" cy="0"/>
+        </a:xfrm>
+      </p:grpSpPr>
+      <p:sp>
+        <p:nvSpPr>
+          <p:cNvPr id="2" name="Slide Image Placeholder 1"/>
+          <p:cNvSpPr>
+            <a:spLocks noGrp="1" noRot="1" noChangeAspect="1"/>
+          </p:cNvSpPr>
+          <p:nvPr>
+            <p:ph type="sldImg"/>
+          </p:nvPr>
+        </p:nvSpPr>
+        <p:spPr/>
+      </p:sp>
+      <p:sp>
+        <p:nvSpPr>
+          <p:cNvPr id="3" name="Notes Placeholder 2"/>
+          <p:cNvSpPr>
+            <a:spLocks noGrp="1"/>
+          </p:cNvSpPr>
+          <p:nvPr>
+            <p:ph type="body" idx="1"/>
+          </p:nvPr>
+        </p:nvSpPr>
+        <p:spPr/>
+        <p:txBody>
+          <a:bodyPr/>
+          <a:lstStyle/>
+          <a:p>
+            <a:endParaRPr lang="en-US" dirty="0"/>
+          </a:p>
+        </p:txBody>
+      </p:sp>
+      <p:sp>
+        <p:nvSpPr>
+          <p:cNvPr id="4" name="Slide Number Placeholder 3"/>
+          <p:cNvSpPr>
+            <a:spLocks noGrp="1"/>
+          </p:cNvSpPr>
+          <p:nvPr>
+            <p:ph type="sldNum" sz="quarter" idx="10"/>
+          </p:nvPr>
+        </p:nvSpPr>
+        <p:spPr/>
+        <p:txBody>
+          <a:bodyPr/>
+          <a:lstStyle/>
+          <a:p>
+            <a:fld id="{F7021451-1387-4CA6-816F-3879F97B5CBC}" type="slidenum">
+              <a:rPr lang="en-US"/>
+              <a:t>6</a:t>
+            </a:fld>
+            <a:endParaRPr lang="en-US"/>
+          </a:p>
+        </p:txBody>
+      </p:sp>
+    </p:spTree>
+    <p:extLst>
+      <p:ext uri="{BB962C8B-B14F-4D97-AF65-F5344CB8AC3E}">
+        <p14:creationId xmlns:p14="http://schemas.microsoft.com/office/powerpoint/2010/main" val="1024086991"/>
+      </p:ext>
+    </p:extLst>
+  </p:cSld>
+  <p:clrMapOvr>
+    <a:masterClrMapping/>
+  </p:clrMapOvr>
+</p:notes>
+</file>
+
+<file path=ppt\notesSlides\notesSlide7.xml><?xml version="1.0" encoding="utf-8"?>
+<p:notes xmlns:a="http://schemas.openxmlformats.org/drawingml/2006/main" xmlns:r="http://schemas.openxmlformats.org/officeDocument/2006/relationships" xmlns:p="http://schemas.openxmlformats.org/presentationml/2006/main">
+  <p:cSld>
+    <p:spTree>
+      <p:nvGrpSpPr>
+        <p:cNvPr id="1" name=""/>
+        <p:cNvGrpSpPr/>
+        <p:nvPr/>
+      </p:nvGrpSpPr>
+      <p:grpSpPr>
+        <a:xfrm>
+          <a:off x="0" y="0"/>
+          <a:ext cx="0" cy="0"/>
+          <a:chOff x="0" y="0"/>
+          <a:chExt cx="0" cy="0"/>
+        </a:xfrm>
+      </p:grpSpPr>
+      <p:sp>
+        <p:nvSpPr>
+          <p:cNvPr id="2" name="Slide Image Placeholder 1"/>
+          <p:cNvSpPr>
+            <a:spLocks noGrp="1" noRot="1" noChangeAspect="1"/>
+          </p:cNvSpPr>
+          <p:nvPr>
+            <p:ph type="sldImg"/>
+          </p:nvPr>
+        </p:nvSpPr>
+        <p:spPr/>
+      </p:sp>
+      <p:sp>
+        <p:nvSpPr>
+          <p:cNvPr id="3" name="Notes Placeholder 2"/>
+          <p:cNvSpPr>
+            <a:spLocks noGrp="1"/>
+          </p:cNvSpPr>
+          <p:nvPr>
+            <p:ph type="body" idx="1"/>
+          </p:nvPr>
+        </p:nvSpPr>
+        <p:spPr/>
+        <p:txBody>
+          <a:bodyPr/>
+          <a:lstStyle/>
+          <a:p>
+            <a:endParaRPr lang="en-US" dirty="0"/>
+          </a:p>
+        </p:txBody>
+      </p:sp>
+      <p:sp>
+        <p:nvSpPr>
+          <p:cNvPr id="4" name="Slide Number Placeholder 3"/>
+          <p:cNvSpPr>
+            <a:spLocks noGrp="1"/>
+          </p:cNvSpPr>
+          <p:nvPr>
+            <p:ph type="sldNum" sz="quarter" idx="10"/>
+          </p:nvPr>
+        </p:nvSpPr>
+        <p:spPr/>
+        <p:txBody>
+          <a:bodyPr/>
+          <a:lstStyle/>
+          <a:p>
+            <a:fld id="{F7021451-1387-4CA6-816F-3879F97B5CBC}" type="slidenum">
+              <a:rPr lang="en-US"/>
+              <a:t>7</a:t>
+            </a:fld>
+            <a:endParaRPr lang="en-US"/>
+          </a:p>
+        </p:txBody>
+      </p:sp>
+    </p:spTree>
+    <p:extLst>
+      <p:ext uri="{BB962C8B-B14F-4D97-AF65-F5344CB8AC3E}">
+        <p14:creationId xmlns:p14="http://schemas.microsoft.com/office/powerpoint/2010/main" val="1024086991"/>
+      </p:ext>
+    </p:extLst>
+  </p:cSld>
+  <p:clrMapOvr>
+    <a:masterClrMapping/>
+  </p:clrMapOvr>
+</p:notes>
+</file>
+
+<file path=ppt\notesSlides\notesSlide8.xml><?xml version="1.0" encoding="utf-8"?>
+<p:notes xmlns:a="http://schemas.openxmlformats.org/drawingml/2006/main" xmlns:r="http://schemas.openxmlformats.org/officeDocument/2006/relationships" xmlns:p="http://schemas.openxmlformats.org/presentationml/2006/main">
+  <p:cSld>
+    <p:spTree>
+      <p:nvGrpSpPr>
+        <p:cNvPr id="1" name=""/>
+        <p:cNvGrpSpPr/>
+        <p:nvPr/>
+      </p:nvGrpSpPr>
+      <p:grpSpPr>
+        <a:xfrm>
+          <a:off x="0" y="0"/>
+          <a:ext cx="0" cy="0"/>
+          <a:chOff x="0" y="0"/>
+          <a:chExt cx="0" cy="0"/>
+        </a:xfrm>
+      </p:grpSpPr>
+      <p:sp>
+        <p:nvSpPr>
+          <p:cNvPr id="2" name="Slide Image Placeholder 1"/>
+          <p:cNvSpPr>
+            <a:spLocks noGrp="1" noRot="1" noChangeAspect="1"/>
+          </p:cNvSpPr>
+          <p:nvPr>
+            <p:ph type="sldImg"/>
+          </p:nvPr>
+        </p:nvSpPr>
+        <p:spPr/>
+      </p:sp>
+      <p:sp>
+        <p:nvSpPr>
+          <p:cNvPr id="3" name="Notes Placeholder 2"/>
+          <p:cNvSpPr>
+            <a:spLocks noGrp="1"/>
+          </p:cNvSpPr>
+          <p:nvPr>
+            <p:ph type="body" idx="1"/>
+          </p:nvPr>
+        </p:nvSpPr>
+        <p:spPr/>
+        <p:txBody>
+          <a:bodyPr/>
+          <a:lstStyle/>
+          <a:p>
+            <a:endParaRPr lang="en-US" dirty="0"/>
+          </a:p>
+        </p:txBody>
+      </p:sp>
+      <p:sp>
+        <p:nvSpPr>
+          <p:cNvPr id="4" name="Slide Number Placeholder 3"/>
+          <p:cNvSpPr>
+            <a:spLocks noGrp="1"/>
+          </p:cNvSpPr>
+          <p:nvPr>
+            <p:ph type="sldNum" sz="quarter" idx="10"/>
+          </p:nvPr>
+        </p:nvSpPr>
+        <p:spPr/>
+        <p:txBody>
+          <a:bodyPr/>
+          <a:lstStyle/>
+          <a:p>
+            <a:fld id="{F7021451-1387-4CA6-816F-3879F97B5CBC}" type="slidenum">
+              <a:rPr lang="en-US"/>
+              <a:t>8</a:t>
+            </a:fld>
+            <a:endParaRPr lang="en-US"/>
+          </a:p>
+        </p:txBody>
+      </p:sp>
+    </p:spTree>
+    <p:extLst>
+      <p:ext uri="{BB962C8B-B14F-4D97-AF65-F5344CB8AC3E}">
+        <p14:creationId xmlns:p14="http://schemas.microsoft.com/office/powerpoint/2010/main" val="1024086991"/>
+      </p:ext>
+    </p:extLst>
+  </p:cSld>
+  <p:clrMapOvr>
+    <a:masterClrMapping/>
+  </p:clrMapOvr>
+</p:notes>
+</file>
+
+<file path=ppt\notesSlides\notesSlide9.xml><?xml version="1.0" encoding="utf-8"?>
+<p:notes xmlns:a="http://schemas.openxmlformats.org/drawingml/2006/main" xmlns:r="http://schemas.openxmlformats.org/officeDocument/2006/relationships" xmlns:p="http://schemas.openxmlformats.org/presentationml/2006/main">
+  <p:cSld>
+    <p:spTree>
+      <p:nvGrpSpPr>
+        <p:cNvPr id="1" name=""/>
+        <p:cNvGrpSpPr/>
+        <p:nvPr/>
+      </p:nvGrpSpPr>
+      <p:grpSpPr>
+        <a:xfrm>
+          <a:off x="0" y="0"/>
+          <a:ext cx="0" cy="0"/>
+          <a:chOff x="0" y="0"/>
+          <a:chExt cx="0" cy="0"/>
+        </a:xfrm>
+      </p:grpSpPr>
+      <p:sp>
+        <p:nvSpPr>
+          <p:cNvPr id="2" name="Slide Image Placeholder 1"/>
+          <p:cNvSpPr>
+            <a:spLocks noGrp="1" noRot="1" noChangeAspect="1"/>
+          </p:cNvSpPr>
+          <p:nvPr>
+            <p:ph type="sldImg"/>
+          </p:nvPr>
+        </p:nvSpPr>
+        <p:spPr/>
+      </p:sp>
+      <p:sp>
+        <p:nvSpPr>
+          <p:cNvPr id="3" name="Notes Placeholder 2"/>
+          <p:cNvSpPr>
+            <a:spLocks noGrp="1"/>
+          </p:cNvSpPr>
+          <p:nvPr>
+            <p:ph type="body" idx="1"/>
+          </p:nvPr>
+        </p:nvSpPr>
+        <p:spPr/>
+        <p:txBody>
+          <a:bodyPr/>
+          <a:lstStyle/>
+          <a:p>
+            <a:endParaRPr lang="en-US" dirty="0"/>
+          </a:p>
+        </p:txBody>
+      </p:sp>
+      <p:sp>
+        <p:nvSpPr>
+          <p:cNvPr id="4" name="Slide Number Placeholder 3"/>
+          <p:cNvSpPr>
+            <a:spLocks noGrp="1"/>
+          </p:cNvSpPr>
+          <p:nvPr>
+            <p:ph type="sldNum" sz="quarter" idx="10"/>
+          </p:nvPr>
+        </p:nvSpPr>
+        <p:spPr/>
+        <p:txBody>
+          <a:bodyPr/>
+          <a:lstStyle/>
+          <a:p>
+            <a:fld id="{F7021451-1387-4CA6-816F-3879F97B5CBC}" type="slidenum">
+              <a:rPr lang="en-US"/>
+              <a:t>9</a:t>
+            </a:fld>
+            <a:endParaRPr lang="en-US"/>
+          </a:p>
+        </p:txBody>
+      </p:sp>
+    </p:spTree>
+    <p:extLst>
+      <p:ext uri="{BB962C8B-B14F-4D97-AF65-F5344CB8AC3E}">
+        <p14:creationId xmlns:p14="http://schemas.microsoft.com/office/powerpoint/2010/main" val="1024086991"/>
+      </p:ext>
+    </p:extLst>
+  </p:cSld>
+  <p:clrMapOvr>
+    <a:masterClrMapping/>
+  </p:clrMapOvr>
+</p:notes>
+</file>
+
+<file path=ppt\presProps.xml><?xml version="1.0" encoding="utf-8"?>
+<p:presentationPr xmlns:a="http://schemas.openxmlformats.org/drawingml/2006/main" xmlns:r="http://schemas.openxmlformats.org/officeDocument/2006/relationships" xmlns:p="http://schemas.openxmlformats.org/presentationml/2006/main">
+  <p:extLst>
+    <p:ext uri="{E76CE94A-603C-4142-B9EB-6D1370010A27}">
+      <p14:discardImageEditData xmlns:p14="http://schemas.microsoft.com/office/powerpoint/2010/main" val="0"/>
+    </p:ext>
+    <p:ext uri="{D31A062A-798A-4329-ABDD-BBA856620510}">
+      <p14:defaultImageDpi xmlns:p14="http://schemas.microsoft.com/office/powerpoint/2010/main" val="220"/>
+    </p:ext>
+    <p:ext uri="{FD5EFAAD-0ECE-453E-9831-46B23BE46B34}">
+      <p15:chartTrackingRefBased xmlns:p15="http://schemas.microsoft.com/office/powerpoint/2012/main" val="0"/>
+    </p:ext>
+  </p:extLst>
+</p:presentationPr>
+</file>
+
+<file path=ppt\presentation.xml><?xml version="1.0" encoding="utf-8"?>
 <p:presentation xmlns:a="http://schemas.openxmlformats.org/drawingml/2006/main" xmlns:r="http://schemas.openxmlformats.org/officeDocument/2006/relationships" xmlns:p="http://schemas.openxmlformats.org/presentationml/2006/main" saveSubsetFonts="1" autoCompressPictures="0">
   <p:sldMasterIdLst>
     <p:sldMasterId id="2147483648" r:id="rId1"/>
@@ -125,1308 +1516,7 @@
 </p:presentation>
 </file>
 
-<file path=ppt/notesMasters/notesMaster1.xml><?xml version="1.0" encoding="utf-8"?>
-<p:notesMaster xmlns:a="http://schemas.openxmlformats.org/drawingml/2006/main" xmlns:r="http://schemas.openxmlformats.org/officeDocument/2006/relationships" xmlns:p="http://schemas.openxmlformats.org/presentationml/2006/main">
-  <p:cSld>
-    <p:bg>
-      <p:bgRef idx="1001">
-        <a:schemeClr val="bg1"/>
-      </p:bgRef>
-    </p:bg>
-    <p:spTree>
-      <p:nvGrpSpPr>
-        <p:cNvPr id="1" name=""/>
-        <p:cNvGrpSpPr/>
-        <p:nvPr/>
-      </p:nvGrpSpPr>
-      <p:grpSpPr>
-        <a:xfrm>
-          <a:off x="0" y="0"/>
-          <a:ext cx="0" cy="0"/>
-          <a:chOff x="0" y="0"/>
-          <a:chExt cx="0" cy="0"/>
-        </a:xfrm>
-      </p:grpSpPr>
-    </p:spTree>
-    <p:extLst>
-      <p:ext uri="{BB962C8B-B14F-4D97-AF65-F5344CB8AC3E}">
-        <p14:creationId xmlns:p14="http://schemas.microsoft.com/office/powerpoint/2010/main" val="1673730796"/>
-      </p:ext>
-    </p:extLst>
-  </p:cSld>
-  <p:clrMap bg1="lt1" tx1="dk1" bg2="lt2" tx2="dk2" accent1="accent1" accent2="accent2" accent3="accent3" accent4="accent4" accent5="accent5" accent6="accent6" hlink="hlink" folHlink="folHlink"/>
-  <p:notesStyle>
-    <a:lvl1pPr marL="0" algn="l" defTabSz="914400" rtl="0" eaLnBrk="1" latinLnBrk="0" hangingPunct="1">
-      <a:defRPr sz="1200" kern="1200">
-        <a:solidFill>
-          <a:schemeClr val="tx1"/>
-        </a:solidFill>
-        <a:latin typeface="+mn-lt"/>
-        <a:ea typeface="+mn-ea"/>
-        <a:cs typeface="+mn-cs"/>
-      </a:defRPr>
-    </a:lvl1pPr>
-    <a:lvl2pPr marL="457200" algn="l" defTabSz="914400" rtl="0" eaLnBrk="1" latinLnBrk="0" hangingPunct="1">
-      <a:defRPr sz="1200" kern="1200">
-        <a:solidFill>
-          <a:schemeClr val="tx1"/>
-        </a:solidFill>
-        <a:latin typeface="+mn-lt"/>
-        <a:ea typeface="+mn-ea"/>
-        <a:cs typeface="+mn-cs"/>
-      </a:defRPr>
-    </a:lvl2pPr>
-    <a:lvl3pPr marL="914400" algn="l" defTabSz="914400" rtl="0" eaLnBrk="1" latinLnBrk="0" hangingPunct="1">
-      <a:defRPr sz="1200" kern="1200">
-        <a:solidFill>
-          <a:schemeClr val="tx1"/>
-        </a:solidFill>
-        <a:latin typeface="+mn-lt"/>
-        <a:ea typeface="+mn-ea"/>
-        <a:cs typeface="+mn-cs"/>
-      </a:defRPr>
-    </a:lvl3pPr>
-    <a:lvl4pPr marL="1371600" algn="l" defTabSz="914400" rtl="0" eaLnBrk="1" latinLnBrk="0" hangingPunct="1">
-      <a:defRPr sz="1200" kern="1200">
-        <a:solidFill>
-          <a:schemeClr val="tx1"/>
-        </a:solidFill>
-        <a:latin typeface="+mn-lt"/>
-        <a:ea typeface="+mn-ea"/>
-        <a:cs typeface="+mn-cs"/>
-      </a:defRPr>
-    </a:lvl4pPr>
-    <a:lvl5pPr marL="1828800" algn="l" defTabSz="914400" rtl="0" eaLnBrk="1" latinLnBrk="0" hangingPunct="1">
-      <a:defRPr sz="1200" kern="1200">
-        <a:solidFill>
-          <a:schemeClr val="tx1"/>
-        </a:solidFill>
-        <a:latin typeface="+mn-lt"/>
-        <a:ea typeface="+mn-ea"/>
-        <a:cs typeface="+mn-cs"/>
-      </a:defRPr>
-    </a:lvl5pPr>
-    <a:lvl6pPr marL="2286000" algn="l" defTabSz="914400" rtl="0" eaLnBrk="1" latinLnBrk="0" hangingPunct="1">
-      <a:defRPr sz="1200" kern="1200">
-        <a:solidFill>
-          <a:schemeClr val="tx1"/>
-        </a:solidFill>
-        <a:latin typeface="+mn-lt"/>
-        <a:ea typeface="+mn-ea"/>
-        <a:cs typeface="+mn-cs"/>
-      </a:defRPr>
-    </a:lvl6pPr>
-    <a:lvl7pPr marL="2743200" algn="l" defTabSz="914400" rtl="0" eaLnBrk="1" latinLnBrk="0" hangingPunct="1">
-      <a:defRPr sz="1200" kern="1200">
-        <a:solidFill>
-          <a:schemeClr val="tx1"/>
-        </a:solidFill>
-        <a:latin typeface="+mn-lt"/>
-        <a:ea typeface="+mn-ea"/>
-        <a:cs typeface="+mn-cs"/>
-      </a:defRPr>
-    </a:lvl7pPr>
-    <a:lvl8pPr marL="3200400" algn="l" defTabSz="914400" rtl="0" eaLnBrk="1" latinLnBrk="0" hangingPunct="1">
-      <a:defRPr sz="1200" kern="1200">
-        <a:solidFill>
-          <a:schemeClr val="tx1"/>
-        </a:solidFill>
-        <a:latin typeface="+mn-lt"/>
-        <a:ea typeface="+mn-ea"/>
-        <a:cs typeface="+mn-cs"/>
-      </a:defRPr>
-    </a:lvl8pPr>
-    <a:lvl9pPr marL="3657600" algn="l" defTabSz="914400" rtl="0" eaLnBrk="1" latinLnBrk="0" hangingPunct="1">
-      <a:defRPr sz="1200" kern="1200">
-        <a:solidFill>
-          <a:schemeClr val="tx1"/>
-        </a:solidFill>
-        <a:latin typeface="+mn-lt"/>
-        <a:ea typeface="+mn-ea"/>
-        <a:cs typeface="+mn-cs"/>
-      </a:defRPr>
-    </a:lvl9pPr>
-  </p:notesStyle>
-</p:notesMaster>
-</file>
-
-<file path=ppt/notesSlides/notesSlide1.xml><?xml version="1.0" encoding="utf-8"?>
-<p:notes xmlns:a="http://schemas.openxmlformats.org/drawingml/2006/main" xmlns:r="http://schemas.openxmlformats.org/officeDocument/2006/relationships" xmlns:p="http://schemas.openxmlformats.org/presentationml/2006/main">
-  <p:cSld>
-    <p:spTree>
-      <p:nvGrpSpPr>
-        <p:cNvPr id="1" name=""/>
-        <p:cNvGrpSpPr/>
-        <p:nvPr/>
-      </p:nvGrpSpPr>
-      <p:grpSpPr>
-        <a:xfrm>
-          <a:off x="0" y="0"/>
-          <a:ext cx="0" cy="0"/>
-          <a:chOff x="0" y="0"/>
-          <a:chExt cx="0" cy="0"/>
-        </a:xfrm>
-      </p:grpSpPr>
-      <p:sp>
-        <p:nvSpPr>
-          <p:cNvPr id="2" name="Slide Image Placeholder 1"/>
-          <p:cNvSpPr>
-            <a:spLocks noGrp="1" noRot="1" noChangeAspect="1"/>
-          </p:cNvSpPr>
-          <p:nvPr>
-            <p:ph type="sldImg"/>
-          </p:nvPr>
-        </p:nvSpPr>
-        <p:spPr/>
-      </p:sp>
-      <p:sp>
-        <p:nvSpPr>
-          <p:cNvPr id="3" name="Notes Placeholder 2"/>
-          <p:cNvSpPr>
-            <a:spLocks noGrp="1"/>
-          </p:cNvSpPr>
-          <p:nvPr>
-            <p:ph type="body" idx="1"/>
-          </p:nvPr>
-        </p:nvSpPr>
-        <p:spPr/>
-        <p:txBody>
-          <a:bodyPr/>
-          <a:lstStyle/>
-          <a:p>
-            <a:endParaRPr lang="en-US" dirty="0"/>
-          </a:p>
-        </p:txBody>
-      </p:sp>
-      <p:sp>
-        <p:nvSpPr>
-          <p:cNvPr id="4" name="Slide Number Placeholder 3"/>
-          <p:cNvSpPr>
-            <a:spLocks noGrp="1"/>
-          </p:cNvSpPr>
-          <p:nvPr>
-            <p:ph type="sldNum" sz="quarter" idx="10"/>
-          </p:nvPr>
-        </p:nvSpPr>
-        <p:spPr/>
-        <p:txBody>
-          <a:bodyPr/>
-          <a:lstStyle/>
-          <a:p>
-            <a:fld id="{F7021451-1387-4CA6-816F-3879F97B5CBC}" type="slidenum">
-              <a:rPr lang="en-US"/>
-              <a:t>1</a:t>
-            </a:fld>
-            <a:endParaRPr lang="en-US"/>
-          </a:p>
-        </p:txBody>
-      </p:sp>
-    </p:spTree>
-    <p:extLst>
-      <p:ext uri="{BB962C8B-B14F-4D97-AF65-F5344CB8AC3E}">
-        <p14:creationId xmlns:p14="http://schemas.microsoft.com/office/powerpoint/2010/main" val="1024086991"/>
-      </p:ext>
-    </p:extLst>
-  </p:cSld>
-  <p:clrMapOvr>
-    <a:masterClrMapping/>
-  </p:clrMapOvr>
-</p:notes>
-</file>
-
-<file path=ppt/notesSlides/notesSlide10.xml><?xml version="1.0" encoding="utf-8"?>
-<p:notes xmlns:a="http://schemas.openxmlformats.org/drawingml/2006/main" xmlns:r="http://schemas.openxmlformats.org/officeDocument/2006/relationships" xmlns:p="http://schemas.openxmlformats.org/presentationml/2006/main">
-  <p:cSld>
-    <p:spTree>
-      <p:nvGrpSpPr>
-        <p:cNvPr id="1" name=""/>
-        <p:cNvGrpSpPr/>
-        <p:nvPr/>
-      </p:nvGrpSpPr>
-      <p:grpSpPr>
-        <a:xfrm>
-          <a:off x="0" y="0"/>
-          <a:ext cx="0" cy="0"/>
-          <a:chOff x="0" y="0"/>
-          <a:chExt cx="0" cy="0"/>
-        </a:xfrm>
-      </p:grpSpPr>
-      <p:sp>
-        <p:nvSpPr>
-          <p:cNvPr id="2" name="Slide Image Placeholder 1"/>
-          <p:cNvSpPr>
-            <a:spLocks noGrp="1" noRot="1" noChangeAspect="1"/>
-          </p:cNvSpPr>
-          <p:nvPr>
-            <p:ph type="sldImg"/>
-          </p:nvPr>
-        </p:nvSpPr>
-        <p:spPr/>
-      </p:sp>
-      <p:sp>
-        <p:nvSpPr>
-          <p:cNvPr id="3" name="Notes Placeholder 2"/>
-          <p:cNvSpPr>
-            <a:spLocks noGrp="1"/>
-          </p:cNvSpPr>
-          <p:nvPr>
-            <p:ph type="body" idx="1"/>
-          </p:nvPr>
-        </p:nvSpPr>
-        <p:spPr/>
-        <p:txBody>
-          <a:bodyPr/>
-          <a:lstStyle/>
-          <a:p>
-            <a:endParaRPr lang="en-US" dirty="0"/>
-          </a:p>
-        </p:txBody>
-      </p:sp>
-      <p:sp>
-        <p:nvSpPr>
-          <p:cNvPr id="4" name="Slide Number Placeholder 3"/>
-          <p:cNvSpPr>
-            <a:spLocks noGrp="1"/>
-          </p:cNvSpPr>
-          <p:nvPr>
-            <p:ph type="sldNum" sz="quarter" idx="10"/>
-          </p:nvPr>
-        </p:nvSpPr>
-        <p:spPr/>
-        <p:txBody>
-          <a:bodyPr/>
-          <a:lstStyle/>
-          <a:p>
-            <a:fld id="{F7021451-1387-4CA6-816F-3879F97B5CBC}" type="slidenum">
-              <a:rPr lang="en-US"/>
-              <a:t>10</a:t>
-            </a:fld>
-            <a:endParaRPr lang="en-US"/>
-          </a:p>
-        </p:txBody>
-      </p:sp>
-    </p:spTree>
-    <p:extLst>
-      <p:ext uri="{BB962C8B-B14F-4D97-AF65-F5344CB8AC3E}">
-        <p14:creationId xmlns:p14="http://schemas.microsoft.com/office/powerpoint/2010/main" val="1024086991"/>
-      </p:ext>
-    </p:extLst>
-  </p:cSld>
-  <p:clrMapOvr>
-    <a:masterClrMapping/>
-  </p:clrMapOvr>
-</p:notes>
-</file>
-
-<file path=ppt/notesSlides/notesSlide11.xml><?xml version="1.0" encoding="utf-8"?>
-<p:notes xmlns:a="http://schemas.openxmlformats.org/drawingml/2006/main" xmlns:r="http://schemas.openxmlformats.org/officeDocument/2006/relationships" xmlns:p="http://schemas.openxmlformats.org/presentationml/2006/main">
-  <p:cSld>
-    <p:spTree>
-      <p:nvGrpSpPr>
-        <p:cNvPr id="1" name=""/>
-        <p:cNvGrpSpPr/>
-        <p:nvPr/>
-      </p:nvGrpSpPr>
-      <p:grpSpPr>
-        <a:xfrm>
-          <a:off x="0" y="0"/>
-          <a:ext cx="0" cy="0"/>
-          <a:chOff x="0" y="0"/>
-          <a:chExt cx="0" cy="0"/>
-        </a:xfrm>
-      </p:grpSpPr>
-      <p:sp>
-        <p:nvSpPr>
-          <p:cNvPr id="2" name="Slide Image Placeholder 1"/>
-          <p:cNvSpPr>
-            <a:spLocks noGrp="1" noRot="1" noChangeAspect="1"/>
-          </p:cNvSpPr>
-          <p:nvPr>
-            <p:ph type="sldImg"/>
-          </p:nvPr>
-        </p:nvSpPr>
-        <p:spPr/>
-      </p:sp>
-      <p:sp>
-        <p:nvSpPr>
-          <p:cNvPr id="3" name="Notes Placeholder 2"/>
-          <p:cNvSpPr>
-            <a:spLocks noGrp="1"/>
-          </p:cNvSpPr>
-          <p:nvPr>
-            <p:ph type="body" idx="1"/>
-          </p:nvPr>
-        </p:nvSpPr>
-        <p:spPr/>
-        <p:txBody>
-          <a:bodyPr/>
-          <a:lstStyle/>
-          <a:p>
-            <a:endParaRPr lang="en-US" dirty="0"/>
-          </a:p>
-        </p:txBody>
-      </p:sp>
-      <p:sp>
-        <p:nvSpPr>
-          <p:cNvPr id="4" name="Slide Number Placeholder 3"/>
-          <p:cNvSpPr>
-            <a:spLocks noGrp="1"/>
-          </p:cNvSpPr>
-          <p:nvPr>
-            <p:ph type="sldNum" sz="quarter" idx="10"/>
-          </p:nvPr>
-        </p:nvSpPr>
-        <p:spPr/>
-        <p:txBody>
-          <a:bodyPr/>
-          <a:lstStyle/>
-          <a:p>
-            <a:fld id="{F7021451-1387-4CA6-816F-3879F97B5CBC}" type="slidenum">
-              <a:rPr lang="en-US"/>
-              <a:t>11</a:t>
-            </a:fld>
-            <a:endParaRPr lang="en-US"/>
-          </a:p>
-        </p:txBody>
-      </p:sp>
-    </p:spTree>
-    <p:extLst>
-      <p:ext uri="{BB962C8B-B14F-4D97-AF65-F5344CB8AC3E}">
-        <p14:creationId xmlns:p14="http://schemas.microsoft.com/office/powerpoint/2010/main" val="1024086991"/>
-      </p:ext>
-    </p:extLst>
-  </p:cSld>
-  <p:clrMapOvr>
-    <a:masterClrMapping/>
-  </p:clrMapOvr>
-</p:notes>
-</file>
-
-<file path=ppt/notesSlides/notesSlide12.xml><?xml version="1.0" encoding="utf-8"?>
-<p:notes xmlns:a="http://schemas.openxmlformats.org/drawingml/2006/main" xmlns:r="http://schemas.openxmlformats.org/officeDocument/2006/relationships" xmlns:p="http://schemas.openxmlformats.org/presentationml/2006/main">
-  <p:cSld>
-    <p:spTree>
-      <p:nvGrpSpPr>
-        <p:cNvPr id="1" name=""/>
-        <p:cNvGrpSpPr/>
-        <p:nvPr/>
-      </p:nvGrpSpPr>
-      <p:grpSpPr>
-        <a:xfrm>
-          <a:off x="0" y="0"/>
-          <a:ext cx="0" cy="0"/>
-          <a:chOff x="0" y="0"/>
-          <a:chExt cx="0" cy="0"/>
-        </a:xfrm>
-      </p:grpSpPr>
-      <p:sp>
-        <p:nvSpPr>
-          <p:cNvPr id="2" name="Slide Image Placeholder 1"/>
-          <p:cNvSpPr>
-            <a:spLocks noGrp="1" noRot="1" noChangeAspect="1"/>
-          </p:cNvSpPr>
-          <p:nvPr>
-            <p:ph type="sldImg"/>
-          </p:nvPr>
-        </p:nvSpPr>
-        <p:spPr/>
-      </p:sp>
-      <p:sp>
-        <p:nvSpPr>
-          <p:cNvPr id="3" name="Notes Placeholder 2"/>
-          <p:cNvSpPr>
-            <a:spLocks noGrp="1"/>
-          </p:cNvSpPr>
-          <p:nvPr>
-            <p:ph type="body" idx="1"/>
-          </p:nvPr>
-        </p:nvSpPr>
-        <p:spPr/>
-        <p:txBody>
-          <a:bodyPr/>
-          <a:lstStyle/>
-          <a:p>
-            <a:endParaRPr lang="en-US" dirty="0"/>
-          </a:p>
-        </p:txBody>
-      </p:sp>
-      <p:sp>
-        <p:nvSpPr>
-          <p:cNvPr id="4" name="Slide Number Placeholder 3"/>
-          <p:cNvSpPr>
-            <a:spLocks noGrp="1"/>
-          </p:cNvSpPr>
-          <p:nvPr>
-            <p:ph type="sldNum" sz="quarter" idx="10"/>
-          </p:nvPr>
-        </p:nvSpPr>
-        <p:spPr/>
-        <p:txBody>
-          <a:bodyPr/>
-          <a:lstStyle/>
-          <a:p>
-            <a:fld id="{F7021451-1387-4CA6-816F-3879F97B5CBC}" type="slidenum">
-              <a:rPr lang="en-US"/>
-              <a:t>12</a:t>
-            </a:fld>
-            <a:endParaRPr lang="en-US"/>
-          </a:p>
-        </p:txBody>
-      </p:sp>
-    </p:spTree>
-    <p:extLst>
-      <p:ext uri="{BB962C8B-B14F-4D97-AF65-F5344CB8AC3E}">
-        <p14:creationId xmlns:p14="http://schemas.microsoft.com/office/powerpoint/2010/main" val="1024086991"/>
-      </p:ext>
-    </p:extLst>
-  </p:cSld>
-  <p:clrMapOvr>
-    <a:masterClrMapping/>
-  </p:clrMapOvr>
-</p:notes>
-</file>
-
-<file path=ppt/notesSlides/notesSlide13.xml><?xml version="1.0" encoding="utf-8"?>
-<p:notes xmlns:a="http://schemas.openxmlformats.org/drawingml/2006/main" xmlns:r="http://schemas.openxmlformats.org/officeDocument/2006/relationships" xmlns:p="http://schemas.openxmlformats.org/presentationml/2006/main">
-  <p:cSld>
-    <p:spTree>
-      <p:nvGrpSpPr>
-        <p:cNvPr id="1" name=""/>
-        <p:cNvGrpSpPr/>
-        <p:nvPr/>
-      </p:nvGrpSpPr>
-      <p:grpSpPr>
-        <a:xfrm>
-          <a:off x="0" y="0"/>
-          <a:ext cx="0" cy="0"/>
-          <a:chOff x="0" y="0"/>
-          <a:chExt cx="0" cy="0"/>
-        </a:xfrm>
-      </p:grpSpPr>
-      <p:sp>
-        <p:nvSpPr>
-          <p:cNvPr id="2" name="Slide Image Placeholder 1"/>
-          <p:cNvSpPr>
-            <a:spLocks noGrp="1" noRot="1" noChangeAspect="1"/>
-          </p:cNvSpPr>
-          <p:nvPr>
-            <p:ph type="sldImg"/>
-          </p:nvPr>
-        </p:nvSpPr>
-        <p:spPr/>
-      </p:sp>
-      <p:sp>
-        <p:nvSpPr>
-          <p:cNvPr id="3" name="Notes Placeholder 2"/>
-          <p:cNvSpPr>
-            <a:spLocks noGrp="1"/>
-          </p:cNvSpPr>
-          <p:nvPr>
-            <p:ph type="body" idx="1"/>
-          </p:nvPr>
-        </p:nvSpPr>
-        <p:spPr/>
-        <p:txBody>
-          <a:bodyPr/>
-          <a:lstStyle/>
-          <a:p>
-            <a:endParaRPr lang="en-US" dirty="0"/>
-          </a:p>
-        </p:txBody>
-      </p:sp>
-      <p:sp>
-        <p:nvSpPr>
-          <p:cNvPr id="4" name="Slide Number Placeholder 3"/>
-          <p:cNvSpPr>
-            <a:spLocks noGrp="1"/>
-          </p:cNvSpPr>
-          <p:nvPr>
-            <p:ph type="sldNum" sz="quarter" idx="10"/>
-          </p:nvPr>
-        </p:nvSpPr>
-        <p:spPr/>
-        <p:txBody>
-          <a:bodyPr/>
-          <a:lstStyle/>
-          <a:p>
-            <a:fld id="{F7021451-1387-4CA6-816F-3879F97B5CBC}" type="slidenum">
-              <a:rPr lang="en-US"/>
-              <a:t>13</a:t>
-            </a:fld>
-            <a:endParaRPr lang="en-US"/>
-          </a:p>
-        </p:txBody>
-      </p:sp>
-    </p:spTree>
-    <p:extLst>
-      <p:ext uri="{BB962C8B-B14F-4D97-AF65-F5344CB8AC3E}">
-        <p14:creationId xmlns:p14="http://schemas.microsoft.com/office/powerpoint/2010/main" val="1024086991"/>
-      </p:ext>
-    </p:extLst>
-  </p:cSld>
-  <p:clrMapOvr>
-    <a:masterClrMapping/>
-  </p:clrMapOvr>
-</p:notes>
-</file>
-
-<file path=ppt/notesSlides/notesSlide14.xml><?xml version="1.0" encoding="utf-8"?>
-<p:notes xmlns:a="http://schemas.openxmlformats.org/drawingml/2006/main" xmlns:r="http://schemas.openxmlformats.org/officeDocument/2006/relationships" xmlns:p="http://schemas.openxmlformats.org/presentationml/2006/main">
-  <p:cSld>
-    <p:spTree>
-      <p:nvGrpSpPr>
-        <p:cNvPr id="1" name=""/>
-        <p:cNvGrpSpPr/>
-        <p:nvPr/>
-      </p:nvGrpSpPr>
-      <p:grpSpPr>
-        <a:xfrm>
-          <a:off x="0" y="0"/>
-          <a:ext cx="0" cy="0"/>
-          <a:chOff x="0" y="0"/>
-          <a:chExt cx="0" cy="0"/>
-        </a:xfrm>
-      </p:grpSpPr>
-      <p:sp>
-        <p:nvSpPr>
-          <p:cNvPr id="2" name="Slide Image Placeholder 1"/>
-          <p:cNvSpPr>
-            <a:spLocks noGrp="1" noRot="1" noChangeAspect="1"/>
-          </p:cNvSpPr>
-          <p:nvPr>
-            <p:ph type="sldImg"/>
-          </p:nvPr>
-        </p:nvSpPr>
-        <p:spPr/>
-      </p:sp>
-      <p:sp>
-        <p:nvSpPr>
-          <p:cNvPr id="3" name="Notes Placeholder 2"/>
-          <p:cNvSpPr>
-            <a:spLocks noGrp="1"/>
-          </p:cNvSpPr>
-          <p:nvPr>
-            <p:ph type="body" idx="1"/>
-          </p:nvPr>
-        </p:nvSpPr>
-        <p:spPr/>
-        <p:txBody>
-          <a:bodyPr/>
-          <a:lstStyle/>
-          <a:p>
-            <a:endParaRPr lang="en-US" dirty="0"/>
-          </a:p>
-        </p:txBody>
-      </p:sp>
-      <p:sp>
-        <p:nvSpPr>
-          <p:cNvPr id="4" name="Slide Number Placeholder 3"/>
-          <p:cNvSpPr>
-            <a:spLocks noGrp="1"/>
-          </p:cNvSpPr>
-          <p:nvPr>
-            <p:ph type="sldNum" sz="quarter" idx="10"/>
-          </p:nvPr>
-        </p:nvSpPr>
-        <p:spPr/>
-        <p:txBody>
-          <a:bodyPr/>
-          <a:lstStyle/>
-          <a:p>
-            <a:fld id="{F7021451-1387-4CA6-816F-3879F97B5CBC}" type="slidenum">
-              <a:rPr lang="en-US"/>
-              <a:t>14</a:t>
-            </a:fld>
-            <a:endParaRPr lang="en-US"/>
-          </a:p>
-        </p:txBody>
-      </p:sp>
-    </p:spTree>
-    <p:extLst>
-      <p:ext uri="{BB962C8B-B14F-4D97-AF65-F5344CB8AC3E}">
-        <p14:creationId xmlns:p14="http://schemas.microsoft.com/office/powerpoint/2010/main" val="1024086991"/>
-      </p:ext>
-    </p:extLst>
-  </p:cSld>
-  <p:clrMapOvr>
-    <a:masterClrMapping/>
-  </p:clrMapOvr>
-</p:notes>
-</file>
-
-<file path=ppt/notesSlides/notesSlide2.xml><?xml version="1.0" encoding="utf-8"?>
-<p:notes xmlns:a="http://schemas.openxmlformats.org/drawingml/2006/main" xmlns:r="http://schemas.openxmlformats.org/officeDocument/2006/relationships" xmlns:p="http://schemas.openxmlformats.org/presentationml/2006/main">
-  <p:cSld>
-    <p:spTree>
-      <p:nvGrpSpPr>
-        <p:cNvPr id="1" name=""/>
-        <p:cNvGrpSpPr/>
-        <p:nvPr/>
-      </p:nvGrpSpPr>
-      <p:grpSpPr>
-        <a:xfrm>
-          <a:off x="0" y="0"/>
-          <a:ext cx="0" cy="0"/>
-          <a:chOff x="0" y="0"/>
-          <a:chExt cx="0" cy="0"/>
-        </a:xfrm>
-      </p:grpSpPr>
-      <p:sp>
-        <p:nvSpPr>
-          <p:cNvPr id="2" name="Slide Image Placeholder 1"/>
-          <p:cNvSpPr>
-            <a:spLocks noGrp="1" noRot="1" noChangeAspect="1"/>
-          </p:cNvSpPr>
-          <p:nvPr>
-            <p:ph type="sldImg"/>
-          </p:nvPr>
-        </p:nvSpPr>
-        <p:spPr/>
-      </p:sp>
-      <p:sp>
-        <p:nvSpPr>
-          <p:cNvPr id="3" name="Notes Placeholder 2"/>
-          <p:cNvSpPr>
-            <a:spLocks noGrp="1"/>
-          </p:cNvSpPr>
-          <p:nvPr>
-            <p:ph type="body" idx="1"/>
-          </p:nvPr>
-        </p:nvSpPr>
-        <p:spPr/>
-        <p:txBody>
-          <a:bodyPr/>
-          <a:lstStyle/>
-          <a:p>
-            <a:endParaRPr lang="en-US" dirty="0"/>
-          </a:p>
-        </p:txBody>
-      </p:sp>
-      <p:sp>
-        <p:nvSpPr>
-          <p:cNvPr id="4" name="Slide Number Placeholder 3"/>
-          <p:cNvSpPr>
-            <a:spLocks noGrp="1"/>
-          </p:cNvSpPr>
-          <p:nvPr>
-            <p:ph type="sldNum" sz="quarter" idx="10"/>
-          </p:nvPr>
-        </p:nvSpPr>
-        <p:spPr/>
-        <p:txBody>
-          <a:bodyPr/>
-          <a:lstStyle/>
-          <a:p>
-            <a:fld id="{F7021451-1387-4CA6-816F-3879F97B5CBC}" type="slidenum">
-              <a:rPr lang="en-US"/>
-              <a:t>2</a:t>
-            </a:fld>
-            <a:endParaRPr lang="en-US"/>
-          </a:p>
-        </p:txBody>
-      </p:sp>
-    </p:spTree>
-    <p:extLst>
-      <p:ext uri="{BB962C8B-B14F-4D97-AF65-F5344CB8AC3E}">
-        <p14:creationId xmlns:p14="http://schemas.microsoft.com/office/powerpoint/2010/main" val="1024086991"/>
-      </p:ext>
-    </p:extLst>
-  </p:cSld>
-  <p:clrMapOvr>
-    <a:masterClrMapping/>
-  </p:clrMapOvr>
-</p:notes>
-</file>
-
-<file path=ppt/notesSlides/notesSlide3.xml><?xml version="1.0" encoding="utf-8"?>
-<p:notes xmlns:a="http://schemas.openxmlformats.org/drawingml/2006/main" xmlns:r="http://schemas.openxmlformats.org/officeDocument/2006/relationships" xmlns:p="http://schemas.openxmlformats.org/presentationml/2006/main">
-  <p:cSld>
-    <p:spTree>
-      <p:nvGrpSpPr>
-        <p:cNvPr id="1" name=""/>
-        <p:cNvGrpSpPr/>
-        <p:nvPr/>
-      </p:nvGrpSpPr>
-      <p:grpSpPr>
-        <a:xfrm>
-          <a:off x="0" y="0"/>
-          <a:ext cx="0" cy="0"/>
-          <a:chOff x="0" y="0"/>
-          <a:chExt cx="0" cy="0"/>
-        </a:xfrm>
-      </p:grpSpPr>
-      <p:sp>
-        <p:nvSpPr>
-          <p:cNvPr id="2" name="Slide Image Placeholder 1"/>
-          <p:cNvSpPr>
-            <a:spLocks noGrp="1" noRot="1" noChangeAspect="1"/>
-          </p:cNvSpPr>
-          <p:nvPr>
-            <p:ph type="sldImg"/>
-          </p:nvPr>
-        </p:nvSpPr>
-        <p:spPr/>
-      </p:sp>
-      <p:sp>
-        <p:nvSpPr>
-          <p:cNvPr id="3" name="Notes Placeholder 2"/>
-          <p:cNvSpPr>
-            <a:spLocks noGrp="1"/>
-          </p:cNvSpPr>
-          <p:nvPr>
-            <p:ph type="body" idx="1"/>
-          </p:nvPr>
-        </p:nvSpPr>
-        <p:spPr/>
-        <p:txBody>
-          <a:bodyPr/>
-          <a:lstStyle/>
-          <a:p>
-            <a:endParaRPr lang="en-US" dirty="0"/>
-          </a:p>
-        </p:txBody>
-      </p:sp>
-      <p:sp>
-        <p:nvSpPr>
-          <p:cNvPr id="4" name="Slide Number Placeholder 3"/>
-          <p:cNvSpPr>
-            <a:spLocks noGrp="1"/>
-          </p:cNvSpPr>
-          <p:nvPr>
-            <p:ph type="sldNum" sz="quarter" idx="10"/>
-          </p:nvPr>
-        </p:nvSpPr>
-        <p:spPr/>
-        <p:txBody>
-          <a:bodyPr/>
-          <a:lstStyle/>
-          <a:p>
-            <a:fld id="{F7021451-1387-4CA6-816F-3879F97B5CBC}" type="slidenum">
-              <a:rPr lang="en-US"/>
-              <a:t>3</a:t>
-            </a:fld>
-            <a:endParaRPr lang="en-US"/>
-          </a:p>
-        </p:txBody>
-      </p:sp>
-    </p:spTree>
-    <p:extLst>
-      <p:ext uri="{BB962C8B-B14F-4D97-AF65-F5344CB8AC3E}">
-        <p14:creationId xmlns:p14="http://schemas.microsoft.com/office/powerpoint/2010/main" val="1024086991"/>
-      </p:ext>
-    </p:extLst>
-  </p:cSld>
-  <p:clrMapOvr>
-    <a:masterClrMapping/>
-  </p:clrMapOvr>
-</p:notes>
-</file>
-
-<file path=ppt/notesSlides/notesSlide4.xml><?xml version="1.0" encoding="utf-8"?>
-<p:notes xmlns:a="http://schemas.openxmlformats.org/drawingml/2006/main" xmlns:r="http://schemas.openxmlformats.org/officeDocument/2006/relationships" xmlns:p="http://schemas.openxmlformats.org/presentationml/2006/main">
-  <p:cSld>
-    <p:spTree>
-      <p:nvGrpSpPr>
-        <p:cNvPr id="1" name=""/>
-        <p:cNvGrpSpPr/>
-        <p:nvPr/>
-      </p:nvGrpSpPr>
-      <p:grpSpPr>
-        <a:xfrm>
-          <a:off x="0" y="0"/>
-          <a:ext cx="0" cy="0"/>
-          <a:chOff x="0" y="0"/>
-          <a:chExt cx="0" cy="0"/>
-        </a:xfrm>
-      </p:grpSpPr>
-      <p:sp>
-        <p:nvSpPr>
-          <p:cNvPr id="2" name="Slide Image Placeholder 1"/>
-          <p:cNvSpPr>
-            <a:spLocks noGrp="1" noRot="1" noChangeAspect="1"/>
-          </p:cNvSpPr>
-          <p:nvPr>
-            <p:ph type="sldImg"/>
-          </p:nvPr>
-        </p:nvSpPr>
-        <p:spPr/>
-      </p:sp>
-      <p:sp>
-        <p:nvSpPr>
-          <p:cNvPr id="3" name="Notes Placeholder 2"/>
-          <p:cNvSpPr>
-            <a:spLocks noGrp="1"/>
-          </p:cNvSpPr>
-          <p:nvPr>
-            <p:ph type="body" idx="1"/>
-          </p:nvPr>
-        </p:nvSpPr>
-        <p:spPr/>
-        <p:txBody>
-          <a:bodyPr/>
-          <a:lstStyle/>
-          <a:p>
-            <a:endParaRPr lang="en-US" dirty="0"/>
-          </a:p>
-        </p:txBody>
-      </p:sp>
-      <p:sp>
-        <p:nvSpPr>
-          <p:cNvPr id="4" name="Slide Number Placeholder 3"/>
-          <p:cNvSpPr>
-            <a:spLocks noGrp="1"/>
-          </p:cNvSpPr>
-          <p:nvPr>
-            <p:ph type="sldNum" sz="quarter" idx="10"/>
-          </p:nvPr>
-        </p:nvSpPr>
-        <p:spPr/>
-        <p:txBody>
-          <a:bodyPr/>
-          <a:lstStyle/>
-          <a:p>
-            <a:fld id="{F7021451-1387-4CA6-816F-3879F97B5CBC}" type="slidenum">
-              <a:rPr lang="en-US"/>
-              <a:t>4</a:t>
-            </a:fld>
-            <a:endParaRPr lang="en-US"/>
-          </a:p>
-        </p:txBody>
-      </p:sp>
-    </p:spTree>
-    <p:extLst>
-      <p:ext uri="{BB962C8B-B14F-4D97-AF65-F5344CB8AC3E}">
-        <p14:creationId xmlns:p14="http://schemas.microsoft.com/office/powerpoint/2010/main" val="1024086991"/>
-      </p:ext>
-    </p:extLst>
-  </p:cSld>
-  <p:clrMapOvr>
-    <a:masterClrMapping/>
-  </p:clrMapOvr>
-</p:notes>
-</file>
-
-<file path=ppt/notesSlides/notesSlide5.xml><?xml version="1.0" encoding="utf-8"?>
-<p:notes xmlns:a="http://schemas.openxmlformats.org/drawingml/2006/main" xmlns:r="http://schemas.openxmlformats.org/officeDocument/2006/relationships" xmlns:p="http://schemas.openxmlformats.org/presentationml/2006/main">
-  <p:cSld>
-    <p:spTree>
-      <p:nvGrpSpPr>
-        <p:cNvPr id="1" name=""/>
-        <p:cNvGrpSpPr/>
-        <p:nvPr/>
-      </p:nvGrpSpPr>
-      <p:grpSpPr>
-        <a:xfrm>
-          <a:off x="0" y="0"/>
-          <a:ext cx="0" cy="0"/>
-          <a:chOff x="0" y="0"/>
-          <a:chExt cx="0" cy="0"/>
-        </a:xfrm>
-      </p:grpSpPr>
-      <p:sp>
-        <p:nvSpPr>
-          <p:cNvPr id="2" name="Slide Image Placeholder 1"/>
-          <p:cNvSpPr>
-            <a:spLocks noGrp="1" noRot="1" noChangeAspect="1"/>
-          </p:cNvSpPr>
-          <p:nvPr>
-            <p:ph type="sldImg"/>
-          </p:nvPr>
-        </p:nvSpPr>
-        <p:spPr/>
-      </p:sp>
-      <p:sp>
-        <p:nvSpPr>
-          <p:cNvPr id="3" name="Notes Placeholder 2"/>
-          <p:cNvSpPr>
-            <a:spLocks noGrp="1"/>
-          </p:cNvSpPr>
-          <p:nvPr>
-            <p:ph type="body" idx="1"/>
-          </p:nvPr>
-        </p:nvSpPr>
-        <p:spPr/>
-        <p:txBody>
-          <a:bodyPr/>
-          <a:lstStyle/>
-          <a:p>
-            <a:endParaRPr lang="en-US" dirty="0"/>
-          </a:p>
-        </p:txBody>
-      </p:sp>
-      <p:sp>
-        <p:nvSpPr>
-          <p:cNvPr id="4" name="Slide Number Placeholder 3"/>
-          <p:cNvSpPr>
-            <a:spLocks noGrp="1"/>
-          </p:cNvSpPr>
-          <p:nvPr>
-            <p:ph type="sldNum" sz="quarter" idx="10"/>
-          </p:nvPr>
-        </p:nvSpPr>
-        <p:spPr/>
-        <p:txBody>
-          <a:bodyPr/>
-          <a:lstStyle/>
-          <a:p>
-            <a:fld id="{F7021451-1387-4CA6-816F-3879F97B5CBC}" type="slidenum">
-              <a:rPr lang="en-US"/>
-              <a:t>5</a:t>
-            </a:fld>
-            <a:endParaRPr lang="en-US"/>
-          </a:p>
-        </p:txBody>
-      </p:sp>
-    </p:spTree>
-    <p:extLst>
-      <p:ext uri="{BB962C8B-B14F-4D97-AF65-F5344CB8AC3E}">
-        <p14:creationId xmlns:p14="http://schemas.microsoft.com/office/powerpoint/2010/main" val="1024086991"/>
-      </p:ext>
-    </p:extLst>
-  </p:cSld>
-  <p:clrMapOvr>
-    <a:masterClrMapping/>
-  </p:clrMapOvr>
-</p:notes>
-</file>
-
-<file path=ppt/notesSlides/notesSlide6.xml><?xml version="1.0" encoding="utf-8"?>
-<p:notes xmlns:a="http://schemas.openxmlformats.org/drawingml/2006/main" xmlns:r="http://schemas.openxmlformats.org/officeDocument/2006/relationships" xmlns:p="http://schemas.openxmlformats.org/presentationml/2006/main">
-  <p:cSld>
-    <p:spTree>
-      <p:nvGrpSpPr>
-        <p:cNvPr id="1" name=""/>
-        <p:cNvGrpSpPr/>
-        <p:nvPr/>
-      </p:nvGrpSpPr>
-      <p:grpSpPr>
-        <a:xfrm>
-          <a:off x="0" y="0"/>
-          <a:ext cx="0" cy="0"/>
-          <a:chOff x="0" y="0"/>
-          <a:chExt cx="0" cy="0"/>
-        </a:xfrm>
-      </p:grpSpPr>
-      <p:sp>
-        <p:nvSpPr>
-          <p:cNvPr id="2" name="Slide Image Placeholder 1"/>
-          <p:cNvSpPr>
-            <a:spLocks noGrp="1" noRot="1" noChangeAspect="1"/>
-          </p:cNvSpPr>
-          <p:nvPr>
-            <p:ph type="sldImg"/>
-          </p:nvPr>
-        </p:nvSpPr>
-        <p:spPr/>
-      </p:sp>
-      <p:sp>
-        <p:nvSpPr>
-          <p:cNvPr id="3" name="Notes Placeholder 2"/>
-          <p:cNvSpPr>
-            <a:spLocks noGrp="1"/>
-          </p:cNvSpPr>
-          <p:nvPr>
-            <p:ph type="body" idx="1"/>
-          </p:nvPr>
-        </p:nvSpPr>
-        <p:spPr/>
-        <p:txBody>
-          <a:bodyPr/>
-          <a:lstStyle/>
-          <a:p>
-            <a:endParaRPr lang="en-US" dirty="0"/>
-          </a:p>
-        </p:txBody>
-      </p:sp>
-      <p:sp>
-        <p:nvSpPr>
-          <p:cNvPr id="4" name="Slide Number Placeholder 3"/>
-          <p:cNvSpPr>
-            <a:spLocks noGrp="1"/>
-          </p:cNvSpPr>
-          <p:nvPr>
-            <p:ph type="sldNum" sz="quarter" idx="10"/>
-          </p:nvPr>
-        </p:nvSpPr>
-        <p:spPr/>
-        <p:txBody>
-          <a:bodyPr/>
-          <a:lstStyle/>
-          <a:p>
-            <a:fld id="{F7021451-1387-4CA6-816F-3879F97B5CBC}" type="slidenum">
-              <a:rPr lang="en-US"/>
-              <a:t>6</a:t>
-            </a:fld>
-            <a:endParaRPr lang="en-US"/>
-          </a:p>
-        </p:txBody>
-      </p:sp>
-    </p:spTree>
-    <p:extLst>
-      <p:ext uri="{BB962C8B-B14F-4D97-AF65-F5344CB8AC3E}">
-        <p14:creationId xmlns:p14="http://schemas.microsoft.com/office/powerpoint/2010/main" val="1024086991"/>
-      </p:ext>
-    </p:extLst>
-  </p:cSld>
-  <p:clrMapOvr>
-    <a:masterClrMapping/>
-  </p:clrMapOvr>
-</p:notes>
-</file>
-
-<file path=ppt/notesSlides/notesSlide7.xml><?xml version="1.0" encoding="utf-8"?>
-<p:notes xmlns:a="http://schemas.openxmlformats.org/drawingml/2006/main" xmlns:r="http://schemas.openxmlformats.org/officeDocument/2006/relationships" xmlns:p="http://schemas.openxmlformats.org/presentationml/2006/main">
-  <p:cSld>
-    <p:spTree>
-      <p:nvGrpSpPr>
-        <p:cNvPr id="1" name=""/>
-        <p:cNvGrpSpPr/>
-        <p:nvPr/>
-      </p:nvGrpSpPr>
-      <p:grpSpPr>
-        <a:xfrm>
-          <a:off x="0" y="0"/>
-          <a:ext cx="0" cy="0"/>
-          <a:chOff x="0" y="0"/>
-          <a:chExt cx="0" cy="0"/>
-        </a:xfrm>
-      </p:grpSpPr>
-      <p:sp>
-        <p:nvSpPr>
-          <p:cNvPr id="2" name="Slide Image Placeholder 1"/>
-          <p:cNvSpPr>
-            <a:spLocks noGrp="1" noRot="1" noChangeAspect="1"/>
-          </p:cNvSpPr>
-          <p:nvPr>
-            <p:ph type="sldImg"/>
-          </p:nvPr>
-        </p:nvSpPr>
-        <p:spPr/>
-      </p:sp>
-      <p:sp>
-        <p:nvSpPr>
-          <p:cNvPr id="3" name="Notes Placeholder 2"/>
-          <p:cNvSpPr>
-            <a:spLocks noGrp="1"/>
-          </p:cNvSpPr>
-          <p:nvPr>
-            <p:ph type="body" idx="1"/>
-          </p:nvPr>
-        </p:nvSpPr>
-        <p:spPr/>
-        <p:txBody>
-          <a:bodyPr/>
-          <a:lstStyle/>
-          <a:p>
-            <a:endParaRPr lang="en-US" dirty="0"/>
-          </a:p>
-        </p:txBody>
-      </p:sp>
-      <p:sp>
-        <p:nvSpPr>
-          <p:cNvPr id="4" name="Slide Number Placeholder 3"/>
-          <p:cNvSpPr>
-            <a:spLocks noGrp="1"/>
-          </p:cNvSpPr>
-          <p:nvPr>
-            <p:ph type="sldNum" sz="quarter" idx="10"/>
-          </p:nvPr>
-        </p:nvSpPr>
-        <p:spPr/>
-        <p:txBody>
-          <a:bodyPr/>
-          <a:lstStyle/>
-          <a:p>
-            <a:fld id="{F7021451-1387-4CA6-816F-3879F97B5CBC}" type="slidenum">
-              <a:rPr lang="en-US"/>
-              <a:t>7</a:t>
-            </a:fld>
-            <a:endParaRPr lang="en-US"/>
-          </a:p>
-        </p:txBody>
-      </p:sp>
-    </p:spTree>
-    <p:extLst>
-      <p:ext uri="{BB962C8B-B14F-4D97-AF65-F5344CB8AC3E}">
-        <p14:creationId xmlns:p14="http://schemas.microsoft.com/office/powerpoint/2010/main" val="1024086991"/>
-      </p:ext>
-    </p:extLst>
-  </p:cSld>
-  <p:clrMapOvr>
-    <a:masterClrMapping/>
-  </p:clrMapOvr>
-</p:notes>
-</file>
-
-<file path=ppt/notesSlides/notesSlide8.xml><?xml version="1.0" encoding="utf-8"?>
-<p:notes xmlns:a="http://schemas.openxmlformats.org/drawingml/2006/main" xmlns:r="http://schemas.openxmlformats.org/officeDocument/2006/relationships" xmlns:p="http://schemas.openxmlformats.org/presentationml/2006/main">
-  <p:cSld>
-    <p:spTree>
-      <p:nvGrpSpPr>
-        <p:cNvPr id="1" name=""/>
-        <p:cNvGrpSpPr/>
-        <p:nvPr/>
-      </p:nvGrpSpPr>
-      <p:grpSpPr>
-        <a:xfrm>
-          <a:off x="0" y="0"/>
-          <a:ext cx="0" cy="0"/>
-          <a:chOff x="0" y="0"/>
-          <a:chExt cx="0" cy="0"/>
-        </a:xfrm>
-      </p:grpSpPr>
-      <p:sp>
-        <p:nvSpPr>
-          <p:cNvPr id="2" name="Slide Image Placeholder 1"/>
-          <p:cNvSpPr>
-            <a:spLocks noGrp="1" noRot="1" noChangeAspect="1"/>
-          </p:cNvSpPr>
-          <p:nvPr>
-            <p:ph type="sldImg"/>
-          </p:nvPr>
-        </p:nvSpPr>
-        <p:spPr/>
-      </p:sp>
-      <p:sp>
-        <p:nvSpPr>
-          <p:cNvPr id="3" name="Notes Placeholder 2"/>
-          <p:cNvSpPr>
-            <a:spLocks noGrp="1"/>
-          </p:cNvSpPr>
-          <p:nvPr>
-            <p:ph type="body" idx="1"/>
-          </p:nvPr>
-        </p:nvSpPr>
-        <p:spPr/>
-        <p:txBody>
-          <a:bodyPr/>
-          <a:lstStyle/>
-          <a:p>
-            <a:endParaRPr lang="en-US" dirty="0"/>
-          </a:p>
-        </p:txBody>
-      </p:sp>
-      <p:sp>
-        <p:nvSpPr>
-          <p:cNvPr id="4" name="Slide Number Placeholder 3"/>
-          <p:cNvSpPr>
-            <a:spLocks noGrp="1"/>
-          </p:cNvSpPr>
-          <p:nvPr>
-            <p:ph type="sldNum" sz="quarter" idx="10"/>
-          </p:nvPr>
-        </p:nvSpPr>
-        <p:spPr/>
-        <p:txBody>
-          <a:bodyPr/>
-          <a:lstStyle/>
-          <a:p>
-            <a:fld id="{F7021451-1387-4CA6-816F-3879F97B5CBC}" type="slidenum">
-              <a:rPr lang="en-US"/>
-              <a:t>8</a:t>
-            </a:fld>
-            <a:endParaRPr lang="en-US"/>
-          </a:p>
-        </p:txBody>
-      </p:sp>
-    </p:spTree>
-    <p:extLst>
-      <p:ext uri="{BB962C8B-B14F-4D97-AF65-F5344CB8AC3E}">
-        <p14:creationId xmlns:p14="http://schemas.microsoft.com/office/powerpoint/2010/main" val="1024086991"/>
-      </p:ext>
-    </p:extLst>
-  </p:cSld>
-  <p:clrMapOvr>
-    <a:masterClrMapping/>
-  </p:clrMapOvr>
-</p:notes>
-</file>
-
-<file path=ppt/notesSlides/notesSlide9.xml><?xml version="1.0" encoding="utf-8"?>
-<p:notes xmlns:a="http://schemas.openxmlformats.org/drawingml/2006/main" xmlns:r="http://schemas.openxmlformats.org/officeDocument/2006/relationships" xmlns:p="http://schemas.openxmlformats.org/presentationml/2006/main">
-  <p:cSld>
-    <p:spTree>
-      <p:nvGrpSpPr>
-        <p:cNvPr id="1" name=""/>
-        <p:cNvGrpSpPr/>
-        <p:nvPr/>
-      </p:nvGrpSpPr>
-      <p:grpSpPr>
-        <a:xfrm>
-          <a:off x="0" y="0"/>
-          <a:ext cx="0" cy="0"/>
-          <a:chOff x="0" y="0"/>
-          <a:chExt cx="0" cy="0"/>
-        </a:xfrm>
-      </p:grpSpPr>
-      <p:sp>
-        <p:nvSpPr>
-          <p:cNvPr id="2" name="Slide Image Placeholder 1"/>
-          <p:cNvSpPr>
-            <a:spLocks noGrp="1" noRot="1" noChangeAspect="1"/>
-          </p:cNvSpPr>
-          <p:nvPr>
-            <p:ph type="sldImg"/>
-          </p:nvPr>
-        </p:nvSpPr>
-        <p:spPr/>
-      </p:sp>
-      <p:sp>
-        <p:nvSpPr>
-          <p:cNvPr id="3" name="Notes Placeholder 2"/>
-          <p:cNvSpPr>
-            <a:spLocks noGrp="1"/>
-          </p:cNvSpPr>
-          <p:nvPr>
-            <p:ph type="body" idx="1"/>
-          </p:nvPr>
-        </p:nvSpPr>
-        <p:spPr/>
-        <p:txBody>
-          <a:bodyPr/>
-          <a:lstStyle/>
-          <a:p>
-            <a:endParaRPr lang="en-US" dirty="0"/>
-          </a:p>
-        </p:txBody>
-      </p:sp>
-      <p:sp>
-        <p:nvSpPr>
-          <p:cNvPr id="4" name="Slide Number Placeholder 3"/>
-          <p:cNvSpPr>
-            <a:spLocks noGrp="1"/>
-          </p:cNvSpPr>
-          <p:nvPr>
-            <p:ph type="sldNum" sz="quarter" idx="10"/>
-          </p:nvPr>
-        </p:nvSpPr>
-        <p:spPr/>
-        <p:txBody>
-          <a:bodyPr/>
-          <a:lstStyle/>
-          <a:p>
-            <a:fld id="{F7021451-1387-4CA6-816F-3879F97B5CBC}" type="slidenum">
-              <a:rPr lang="en-US"/>
-              <a:t>9</a:t>
-            </a:fld>
-            <a:endParaRPr lang="en-US"/>
-          </a:p>
-        </p:txBody>
-      </p:sp>
-    </p:spTree>
-    <p:extLst>
-      <p:ext uri="{BB962C8B-B14F-4D97-AF65-F5344CB8AC3E}">
-        <p14:creationId xmlns:p14="http://schemas.microsoft.com/office/powerpoint/2010/main" val="1024086991"/>
-      </p:ext>
-    </p:extLst>
-  </p:cSld>
-  <p:clrMapOvr>
-    <a:masterClrMapping/>
-  </p:clrMapOvr>
-</p:notes>
-</file>
-
-<file path=ppt/slideLayouts/slideLayout1.xml><?xml version="1.0" encoding="utf-8"?>
+<file path=ppt\slideLayouts\slideLayout1.xml><?xml version="1.0" encoding="utf-8"?>
 <p:sldLayout xmlns:a="http://schemas.openxmlformats.org/drawingml/2006/main" xmlns:r="http://schemas.openxmlformats.org/officeDocument/2006/relationships" xmlns:p="http://schemas.openxmlformats.org/presentationml/2006/main" preserve="1">
   <p:cSld name="DEFAULT">
     <p:bg>
@@ -1456,7 +1546,7 @@
 </p:sldLayout>
 </file>
 
-<file path=ppt/slideMasters/slideMaster1.xml><?xml version="1.0" encoding="utf-8"?>
+<file path=ppt\slideMasters\slideMaster1.xml><?xml version="1.0" encoding="utf-8"?>
 <p:sldMaster xmlns:a="http://schemas.openxmlformats.org/drawingml/2006/main" xmlns:r="http://schemas.openxmlformats.org/officeDocument/2006/relationships" xmlns:p="http://schemas.openxmlformats.org/presentationml/2006/main">
   <p:cSld>
     <p:bg>
@@ -1738,7 +1828,7 @@
 </p:sldMaster>
 </file>
 
-<file path=ppt/slides/slide1.xml><?xml version="1.0" encoding="utf-8"?>
+<file path=ppt\slides\slide1.xml><?xml version="1.0" encoding="utf-8"?>
 <p:sld xmlns:a="http://schemas.openxmlformats.org/drawingml/2006/main" xmlns:r="http://schemas.openxmlformats.org/officeDocument/2006/relationships" xmlns:p="http://schemas.openxmlformats.org/presentationml/2006/main">
   <p:cSld name="Slide 1">
     <p:bg>
@@ -2025,7 +2115,7 @@
 </p:sld>
 </file>
 
-<file path=ppt/slides/slide10.xml><?xml version="1.0" encoding="utf-8"?>
+<file path=ppt\slides\slide10.xml><?xml version="1.0" encoding="utf-8"?>
 <p:sld xmlns:a="http://schemas.openxmlformats.org/drawingml/2006/main" xmlns:r="http://schemas.openxmlformats.org/officeDocument/2006/relationships" xmlns:p="http://schemas.openxmlformats.org/presentationml/2006/main">
   <p:cSld name="Slide 10">
     <p:bg>
@@ -2645,7 +2735,7 @@
 </p:sld>
 </file>
 
-<file path=ppt/slides/slide11.xml><?xml version="1.0" encoding="utf-8"?>
+<file path=ppt\slides\slide11.xml><?xml version="1.0" encoding="utf-8"?>
 <p:sld xmlns:a="http://schemas.openxmlformats.org/drawingml/2006/main" xmlns:r="http://schemas.openxmlformats.org/officeDocument/2006/relationships" xmlns:p="http://schemas.openxmlformats.org/presentationml/2006/main">
   <p:cSld name="Slide 11">
     <p:bg>
@@ -3141,7 +3231,7 @@
 </p:sld>
 </file>
 
-<file path=ppt/slides/slide12.xml><?xml version="1.0" encoding="utf-8"?>
+<file path=ppt\slides\slide12.xml><?xml version="1.0" encoding="utf-8"?>
 <p:sld xmlns:a="http://schemas.openxmlformats.org/drawingml/2006/main" xmlns:r="http://schemas.openxmlformats.org/officeDocument/2006/relationships" xmlns:p="http://schemas.openxmlformats.org/presentationml/2006/main">
   <p:cSld name="Slide 12">
     <p:bg>
@@ -3722,7 +3812,7 @@
 </p:sld>
 </file>
 
-<file path=ppt/slides/slide13.xml><?xml version="1.0" encoding="utf-8"?>
+<file path=ppt\slides\slide13.xml><?xml version="1.0" encoding="utf-8"?>
 <p:sld xmlns:a="http://schemas.openxmlformats.org/drawingml/2006/main" xmlns:r="http://schemas.openxmlformats.org/officeDocument/2006/relationships" xmlns:p="http://schemas.openxmlformats.org/presentationml/2006/main">
   <p:cSld name="Slide 13">
     <p:bg>
@@ -4084,7 +4174,7 @@
 </p:sld>
 </file>
 
-<file path=ppt/slides/slide14.xml><?xml version="1.0" encoding="utf-8"?>
+<file path=ppt\slides\slide14.xml><?xml version="1.0" encoding="utf-8"?>
 <p:sld xmlns:a="http://schemas.openxmlformats.org/drawingml/2006/main" xmlns:r="http://schemas.openxmlformats.org/officeDocument/2006/relationships" xmlns:p="http://schemas.openxmlformats.org/presentationml/2006/main">
   <p:cSld name="Slide 14">
     <p:bg>
@@ -4405,7 +4495,7 @@
 </p:sld>
 </file>
 
-<file path=ppt/slides/slide2.xml><?xml version="1.0" encoding="utf-8"?>
+<file path=ppt\slides\slide2.xml><?xml version="1.0" encoding="utf-8"?>
 <p:sld xmlns:a="http://schemas.openxmlformats.org/drawingml/2006/main" xmlns:r="http://schemas.openxmlformats.org/officeDocument/2006/relationships" xmlns:p="http://schemas.openxmlformats.org/presentationml/2006/main">
   <p:cSld name="Slide 2">
     <p:bg>
@@ -5082,7 +5172,7 @@
 </p:sld>
 </file>
 
-<file path=ppt/slides/slide3.xml><?xml version="1.0" encoding="utf-8"?>
+<file path=ppt\slides\slide3.xml><?xml version="1.0" encoding="utf-8"?>
 <p:sld xmlns:a="http://schemas.openxmlformats.org/drawingml/2006/main" xmlns:r="http://schemas.openxmlformats.org/officeDocument/2006/relationships" xmlns:p="http://schemas.openxmlformats.org/presentationml/2006/main">
   <p:cSld name="Slide 3">
     <p:bg>
@@ -5591,7 +5681,7 @@
 </p:sld>
 </file>
 
-<file path=ppt/slides/slide4.xml><?xml version="1.0" encoding="utf-8"?>
+<file path=ppt\slides\slide4.xml><?xml version="1.0" encoding="utf-8"?>
 <p:sld xmlns:a="http://schemas.openxmlformats.org/drawingml/2006/main" xmlns:r="http://schemas.openxmlformats.org/officeDocument/2006/relationships" xmlns:p="http://schemas.openxmlformats.org/presentationml/2006/main">
   <p:cSld name="Slide 4">
     <p:bg>
@@ -5964,7 +6054,7 @@
 </p:sld>
 </file>
 
-<file path=ppt/slides/slide5.xml><?xml version="1.0" encoding="utf-8"?>
+<file path=ppt\slides\slide5.xml><?xml version="1.0" encoding="utf-8"?>
 <p:sld xmlns:a="http://schemas.openxmlformats.org/drawingml/2006/main" xmlns:r="http://schemas.openxmlformats.org/officeDocument/2006/relationships" xmlns:p="http://schemas.openxmlformats.org/presentationml/2006/main">
   <p:cSld name="Slide 5">
     <p:bg>
@@ -6514,7 +6604,7 @@
 </p:sld>
 </file>
 
-<file path=ppt/slides/slide6.xml><?xml version="1.0" encoding="utf-8"?>
+<file path=ppt\slides\slide6.xml><?xml version="1.0" encoding="utf-8"?>
 <p:sld xmlns:a="http://schemas.openxmlformats.org/drawingml/2006/main" xmlns:r="http://schemas.openxmlformats.org/officeDocument/2006/relationships" xmlns:p="http://schemas.openxmlformats.org/presentationml/2006/main">
   <p:cSld name="Slide 6">
     <p:bg>
@@ -7146,7 +7236,7 @@
 </p:sld>
 </file>
 
-<file path=ppt/slides/slide7.xml><?xml version="1.0" encoding="utf-8"?>
+<file path=ppt\slides\slide7.xml><?xml version="1.0" encoding="utf-8"?>
 <p:sld xmlns:a="http://schemas.openxmlformats.org/drawingml/2006/main" xmlns:r="http://schemas.openxmlformats.org/officeDocument/2006/relationships" xmlns:p="http://schemas.openxmlformats.org/presentationml/2006/main">
   <p:cSld name="Slide 7">
     <p:bg>
@@ -7443,7 +7533,7 @@
                 <a:ea typeface="Arial" pitchFamily="34" charset="-122"/>
                 <a:cs typeface="Arial" pitchFamily="34" charset="-120"/>
               </a:rPr>
-              <a:t>No mesmo sentido, a mesma bola a 16 m/s tem o dobro de |p| que a 8 m/s.</a:t>
+              <a:t>No mesmo sentido, a mesma bola a 20 m/s tem o dobro de |p| que a 10 m/s.</a:t>
             </a:r>
             <a:endParaRPr lang="en-US" sz="1600" dirty="0"/>
           </a:p>
@@ -7701,7 +7791,7 @@
 </p:sld>
 </file>
 
-<file path=ppt/slides/slide8.xml><?xml version="1.0" encoding="utf-8"?>
+<file path=ppt\slides\slide8.xml><?xml version="1.0" encoding="utf-8"?>
 <p:sld xmlns:a="http://schemas.openxmlformats.org/drawingml/2006/main" xmlns:r="http://schemas.openxmlformats.org/officeDocument/2006/relationships" xmlns:p="http://schemas.openxmlformats.org/presentationml/2006/main">
   <p:cSld name="Slide 8">
     <p:bg>
@@ -7915,7 +8005,7 @@
                 <a:ea typeface="Arial" pitchFamily="34" charset="-122"/>
                 <a:cs typeface="Arial" pitchFamily="34" charset="-120"/>
               </a:rPr>
-              <a:t>Uma bola de 0,4 kg se move com velocidade de 8 m/s.</a:t>
+              <a:t>Uma bola de 0,4 kg se move com velocidade de 20 m/s.</a:t>
             </a:r>
             <a:endParaRPr lang="en-US" sz="1800" dirty="0"/>
           </a:p>
@@ -8049,7 +8139,7 @@
                 <a:ea typeface="Arial" pitchFamily="34" charset="-122"/>
                 <a:cs typeface="Arial" pitchFamily="34" charset="-120"/>
               </a:rPr>
-              <a:t>v = 8 m/s</a:t>
+              <a:t>v = 20 m/s</a:t>
             </a:r>
             <a:endParaRPr lang="en-US" sz="2200" dirty="0"/>
           </a:p>
@@ -8166,7 +8256,7 @@
                 <a:ea typeface="Arial" pitchFamily="34" charset="-122"/>
                 <a:cs typeface="Arial" pitchFamily="34" charset="-120"/>
               </a:rPr>
-              <a:t>p = 0,4 × 8</a:t>
+              <a:t>p = 0,4 × 20</a:t>
             </a:r>
             <a:endParaRPr lang="en-US" sz="2200" dirty="0"/>
           </a:p>
@@ -8183,7 +8273,7 @@
                 <a:ea typeface="Arial" pitchFamily="34" charset="-122"/>
                 <a:cs typeface="Arial" pitchFamily="34" charset="-120"/>
               </a:rPr>
-              <a:t>p = 3,2 kg·m/s</a:t>
+              <a:t>p = 8 kg·m/s</a:t>
             </a:r>
             <a:endParaRPr lang="en-US" sz="2200" dirty="0"/>
           </a:p>
@@ -8197,7 +8287,7 @@
 </p:sld>
 </file>
 
-<file path=ppt/slides/slide9.xml><?xml version="1.0" encoding="utf-8"?>
+<file path=ppt\slides\slide9.xml><?xml version="1.0" encoding="utf-8"?>
 <p:sld xmlns:a="http://schemas.openxmlformats.org/drawingml/2006/main" xmlns:r="http://schemas.openxmlformats.org/officeDocument/2006/relationships" xmlns:p="http://schemas.openxmlformats.org/presentationml/2006/main">
   <p:cSld name="Slide 9">
     <p:bg>
@@ -8620,7 +8710,11 @@
 </p:sld>
 </file>
 
-<file path=ppt/theme/theme1.xml><?xml version="1.0" encoding="utf-8"?>
+<file path=ppt\tableStyles.xml><?xml version="1.0" encoding="utf-8"?>
+<a:tblStyleLst xmlns:a="http://schemas.openxmlformats.org/drawingml/2006/main" def="{5C22544A-7EE6-4342-B048-85BDC9FD1C3A}"/>
+</file>
+
+<file path=ppt\theme\theme1.xml><?xml version="1.0" encoding="utf-8"?>
 <a:theme xmlns:a="http://schemas.openxmlformats.org/drawingml/2006/main" name="Office Theme">
   <a:themeElements>
     <a:clrScheme name="Office">
@@ -8915,7 +9009,7 @@
 </a:theme>
 </file>
 
-<file path=ppt/theme/theme2.xml><?xml version="1.0" encoding="utf-8"?>
+<file path=ppt\theme\theme2.xml><?xml version="1.0" encoding="utf-8"?>
 <a:theme xmlns:a="http://schemas.openxmlformats.org/drawingml/2006/main" name="Office Theme">
   <a:themeElements>
     <a:clrScheme name="Office">
@@ -9228,4 +9322,35 @@
     </a:ext>
   </a:extLst>
 </a:theme>
+</file>
+
+<file path=ppt\viewProps.xml><?xml version="1.0" encoding="utf-8"?>
+<p:viewPr xmlns:a="http://schemas.openxmlformats.org/drawingml/2006/main" xmlns:r="http://schemas.openxmlformats.org/officeDocument/2006/relationships" xmlns:p="http://schemas.openxmlformats.org/presentationml/2006/main">
+  <p:normalViewPr horzBarState="maximized">
+    <p:restoredLeft sz="15611"/>
+    <p:restoredTop sz="94610"/>
+  </p:normalViewPr>
+  <p:slideViewPr>
+    <p:cSldViewPr snapToGrid="0" snapToObjects="1">
+      <p:cViewPr varScale="1">
+        <p:scale>
+          <a:sx n="136" d="100"/>
+          <a:sy n="136" d="100"/>
+        </p:scale>
+        <p:origin x="216" y="312"/>
+      </p:cViewPr>
+      <p:guideLst/>
+    </p:cSldViewPr>
+  </p:slideViewPr>
+  <p:notesTextViewPr>
+    <p:cViewPr>
+      <p:scale>
+        <a:sx n="1" d="1"/>
+        <a:sy n="1" d="1"/>
+      </p:scale>
+      <p:origin x="0" y="0"/>
+    </p:cViewPr>
+  </p:notesTextViewPr>
+  <p:gridSpacing cx="76200" cy="76200"/>
+</p:viewPr>
 </file>
</xml_diff>

<commit_message>
Tarefas to-do: remove arquivos orfaos, atualiza data de acesso na fonte dos exercicios e adiciona 5 exercicios ao slide 11 do PPTX
</commit_message>
<xml_diff>
--- a/02_apresentacao/Apresentacao_Aula_IA.pptx
+++ b/02_apresentacao/Apresentacao_Aula_IA.pptx
@@ -3220,6 +3220,201 @@
               <a:t>• Etapas bem definidas</a:t>
             </a:r>
             <a:endParaRPr lang="en-US" sz="2000" dirty="0"/>
+          </a:p>
+        </p:txBody>
+      </p:sp>
+      <p:sp>
+        <p:nvSpPr>
+          <p:cNvPr id="13" name="Text 13"/>
+          <p:cNvSpPr/>
+          <p:nvPr/>
+        </p:nvSpPr>
+        <p:spPr>
+          <a:xfrm>
+            <a:off x="548640" y="6000000"/>
+            <a:ext cx="6400800" cy="600000"/>
+          </a:xfrm>
+          <a:prstGeom prst="rect">
+            <a:avLst/>
+          </a:prstGeom>
+          <a:noFill/>
+          <a:ln/>
+        </p:spPr>
+        <p:txBody>
+          <a:bodyPr wrap="square" lIns="0" tIns="0" rIns="0" bIns="0" rtlCol="0" anchor="ctr"/>
+          <a:lstStyle/>
+          <a:p>
+            <a:pPr marL="0" indent="0">
+              <a:buNone/>
+            </a:pPr>
+            <a:r>
+              <a:rPr lang="en-US" sz="1400" dirty="0">
+                <a:solidFill>
+                  <a:srgbClr val="333333"/>
+                </a:solidFill>
+                <a:latin typeface="Arial" pitchFamily="34" charset="0"/>
+                <a:ea typeface="Arial" pitchFamily="34" charset="-122"/>
+                <a:cs typeface="Arial" pitchFamily="34" charset="-120"/>
+              </a:rPr>
+              <a:t>1 (Conceitual): p = m.v — grandeza vetorial, nao e forca</a:t>
+            </a:r>
+            <a:endParaRPr lang="en-US" sz="1400" dirty="0"/>
+          </a:p>
+        </p:txBody>
+      </p:sp>
+      <p:sp>
+        <p:nvSpPr>
+          <p:cNvPr id="14" name="Text 14"/>
+          <p:cNvSpPr/>
+          <p:nvPr/>
+        </p:nvSpPr>
+        <p:spPr>
+          <a:xfrm>
+            <a:off x="548640" y="7000000"/>
+            <a:ext cx="6400800" cy="600000"/>
+          </a:xfrm>
+          <a:prstGeom prst="rect">
+            <a:avLst/>
+          </a:prstGeom>
+          <a:noFill/>
+          <a:ln/>
+        </p:spPr>
+        <p:txBody>
+          <a:bodyPr wrap="square" lIns="0" tIns="0" rIns="0" bIns="0" rtlCol="0" anchor="ctr"/>
+          <a:lstStyle/>
+          <a:p>
+            <a:pPr marL="0" indent="0">
+              <a:buNone/>
+            </a:pPr>
+            <a:r>
+              <a:rPr lang="en-US" sz="1400" dirty="0">
+                <a:solidFill>
+                  <a:srgbClr val="333333"/>
+                </a:solidFill>
+                <a:latin typeface="Arial" pitchFamily="34" charset="0"/>
+                <a:ea typeface="Arial" pitchFamily="34" charset="-122"/>
+                <a:cs typeface="Arial" pitchFamily="34" charset="-120"/>
+              </a:rPr>
+              <a:t>2 (Proporcionalidade): dobrar v com m constante dobra p</a:t>
+            </a:r>
+            <a:endParaRPr lang="en-US" sz="1400" dirty="0"/>
+          </a:p>
+        </p:txBody>
+      </p:sp>
+      <p:sp>
+        <p:nvSpPr>
+          <p:cNvPr id="15" name="Text 15"/>
+          <p:cNvSpPr/>
+          <p:nvPr/>
+        </p:nvSpPr>
+        <p:spPr>
+          <a:xfrm>
+            <a:off x="548640" y="8000000"/>
+            <a:ext cx="6400800" cy="600000"/>
+          </a:xfrm>
+          <a:prstGeom prst="rect">
+            <a:avLst/>
+          </a:prstGeom>
+          <a:noFill/>
+          <a:ln/>
+        </p:spPr>
+        <p:txBody>
+          <a:bodyPr wrap="square" lIns="0" tIns="0" rIns="0" bIns="0" rtlCol="0" anchor="ctr"/>
+          <a:lstStyle/>
+          <a:p>
+            <a:pPr marL="0" indent="0">
+              <a:buNone/>
+            </a:pPr>
+            <a:r>
+              <a:rPr lang="en-US" sz="1400" dirty="0">
+                <a:solidFill>
+                  <a:srgbClr val="333333"/>
+                </a:solidFill>
+                <a:latin typeface="Arial" pitchFamily="34" charset="0"/>
+                <a:ea typeface="Arial" pitchFamily="34" charset="-122"/>
+                <a:cs typeface="Arial" pitchFamily="34" charset="-120"/>
+              </a:rPr>
+              <a:t>3 (Calculo SI): bola 0,4 kg x 20 m/s = 8 kg.m/s</a:t>
+            </a:r>
+            <a:endParaRPr lang="en-US" sz="1400" dirty="0"/>
+          </a:p>
+        </p:txBody>
+      </p:sp>
+      <p:sp>
+        <p:nvSpPr>
+          <p:cNvPr id="16" name="Text 16"/>
+          <p:cNvSpPr/>
+          <p:nvPr/>
+        </p:nvSpPr>
+        <p:spPr>
+          <a:xfrm>
+            <a:off x="548640" y="9000000"/>
+            <a:ext cx="6400800" cy="600000"/>
+          </a:xfrm>
+          <a:prstGeom prst="rect">
+            <a:avLst/>
+          </a:prstGeom>
+          <a:noFill/>
+          <a:ln/>
+        </p:spPr>
+        <p:txBody>
+          <a:bodyPr wrap="square" lIns="0" tIns="0" rIns="0" bIns="0" rtlCol="0" anchor="ctr"/>
+          <a:lstStyle/>
+          <a:p>
+            <a:pPr marL="0" indent="0">
+              <a:buNone/>
+            </a:pPr>
+            <a:r>
+              <a:rPr lang="en-US" sz="1400" dirty="0">
+                <a:solidFill>
+                  <a:srgbClr val="333333"/>
+                </a:solidFill>
+                <a:latin typeface="Arial" pitchFamily="34" charset="0"/>
+                <a:ea typeface="Arial" pitchFamily="34" charset="-122"/>
+                <a:cs typeface="Arial" pitchFamily="34" charset="-120"/>
+              </a:rPr>
+              <a:t>4 (Vetorial): patinadores 50 kg x +3 m/s = +150; x -3 m/s = -150</a:t>
+            </a:r>
+            <a:endParaRPr lang="en-US" sz="1400" dirty="0"/>
+          </a:p>
+        </p:txBody>
+      </p:sp>
+      <p:sp>
+        <p:nvSpPr>
+          <p:cNvPr id="17" name="Text 17"/>
+          <p:cNvSpPr/>
+          <p:nvPr/>
+        </p:nvSpPr>
+        <p:spPr>
+          <a:xfrm>
+            <a:off x="548640" y="10000000"/>
+            <a:ext cx="6400800" cy="600000"/>
+          </a:xfrm>
+          <a:prstGeom prst="rect">
+            <a:avLst/>
+          </a:prstGeom>
+          <a:noFill/>
+          <a:ln/>
+        </p:spPr>
+        <p:txBody>
+          <a:bodyPr wrap="square" lIns="0" tIns="0" rIns="0" bIns="0" rtlCol="0" anchor="ctr"/>
+          <a:lstStyle/>
+          <a:p>
+            <a:pPr marL="0" indent="0">
+              <a:buNone/>
+            </a:pPr>
+            <a:r>
+              <a:rPr lang="en-US" sz="1400" dirty="0">
+                <a:solidFill>
+                  <a:srgbClr val="333333"/>
+                </a:solidFill>
+                <a:latin typeface="Arial" pitchFamily="34" charset="0"/>
+                <a:ea typeface="Arial" pitchFamily="34" charset="-122"/>
+                <a:cs typeface="Arial" pitchFamily="34" charset="-120"/>
+              </a:rPr>
+              <a:t>5 (Frenagem): p nao define distancia de parada - depende de freios e atrito</a:t>
+            </a:r>
+            <a:endParaRPr lang="en-US" sz="1400" dirty="0"/>
           </a:p>
         </p:txBody>
       </p:sp>

</xml_diff>